<commit_message>
Simulateur ROV: intégration projetée DAE, init missions, catalogue Tests UI
- Intégrateur half-explicit (projected_integrator), projection d'état, spec DAE

- Conditions initiales strict/legacy, missions M_test_init_*, tests non-régression

- Catalogue onglet Tests (src/tests/test_catalog.py), docs régénérée et script regenerate_documentation

- Ajustements M103, environnement, câble, UI simulation et tracés

Made-with: Cursor
</commit_message>
<xml_diff>
--- a/simulateur_rov/Doc physique de la chainette/Nouveau Présentation Microsoft PowerPoint.pptx
+++ b/simulateur_rov/Doc physique de la chainette/Nouveau Présentation Microsoft PowerPoint.pptx
@@ -6,6 +6,8 @@
   </p:sldMasterIdLst>
   <p:sldIdLst>
     <p:sldId id="256" r:id="rId2"/>
+    <p:sldId id="257" r:id="rId3"/>
+    <p:sldId id="258" r:id="rId4"/>
   </p:sldIdLst>
   <p:sldSz cx="12192000" cy="6858000"/>
   <p:notesSz cx="6858000" cy="9144000"/>
@@ -104,13 +106,18 @@
       </a:defRPr>
     </a:lvl9pPr>
   </p:defaultTextStyle>
+  <p:extLst>
+    <p:ext uri="{EFAFB233-063F-42B5-8137-9DF3F51BA10A}">
+      <p15:sldGuideLst xmlns:p15="http://schemas.microsoft.com/office/powerpoint/2012/main"/>
+    </p:ext>
+  </p:extLst>
 </p:presentation>
 </file>
 
 <file path=ppt/revisionInfo.xml><?xml version="1.0" encoding="utf-8"?>
 <p1510:revInfo xmlns:a="http://schemas.openxmlformats.org/drawingml/2006/main" xmlns:r="http://schemas.openxmlformats.org/officeDocument/2006/relationships" xmlns:p1510="http://schemas.microsoft.com/office/powerpoint/2015/10/main">
   <p1510:revLst>
-    <p1510:client id="{2FC93324-FAF7-48D1-A15B-2D9FB126D95D}" v="8" dt="2026-02-05T05:38:07.725"/>
+    <p1510:client id="{8E2278BE-755D-4521-A32E-1F76F99786C2}" v="463" dt="2026-04-11T08:18:09.910"/>
   </p1510:revLst>
 </p1510:revInfo>
 </file>
@@ -120,182 +127,429 @@
   <pc:docChgLst>
     <pc:chgData name="Jacques Delort" userId="338bbbaa6367577a" providerId="LiveId" clId="{29EEF4E2-F752-45CC-A7DF-F1AD94B64117}"/>
     <pc:docChg chg="undo custSel addSld modSld">
-      <pc:chgData name="Jacques Delort" userId="338bbbaa6367577a" providerId="LiveId" clId="{29EEF4E2-F752-45CC-A7DF-F1AD94B64117}" dt="2026-02-05T05:52:08.981" v="345" actId="1076"/>
+      <pc:chgData name="Jacques Delort" userId="338bbbaa6367577a" providerId="LiveId" clId="{29EEF4E2-F752-45CC-A7DF-F1AD94B64117}" dt="2026-04-11T08:18:09.910" v="1399" actId="20577"/>
       <pc:docMkLst>
         <pc:docMk/>
       </pc:docMkLst>
       <pc:sldChg chg="addSp delSp modSp new mod">
-        <pc:chgData name="Jacques Delort" userId="338bbbaa6367577a" providerId="LiveId" clId="{29EEF4E2-F752-45CC-A7DF-F1AD94B64117}" dt="2026-02-05T05:52:08.981" v="345" actId="1076"/>
+        <pc:chgData name="Jacques Delort" userId="338bbbaa6367577a" providerId="LiveId" clId="{29EEF4E2-F752-45CC-A7DF-F1AD94B64117}" dt="2026-04-11T08:18:09.910" v="1399" actId="20577"/>
         <pc:sldMkLst>
           <pc:docMk/>
-          <pc:sldMk cId="283015613" sldId="256"/>
+          <pc:sldMk cId="466176374" sldId="257"/>
         </pc:sldMkLst>
         <pc:spChg chg="del">
-          <ac:chgData name="Jacques Delort" userId="338bbbaa6367577a" providerId="LiveId" clId="{29EEF4E2-F752-45CC-A7DF-F1AD94B64117}" dt="2026-02-05T05:20:17.512" v="1" actId="478"/>
+          <ac:chgData name="Jacques Delort" userId="338bbbaa6367577a" providerId="LiveId" clId="{29EEF4E2-F752-45CC-A7DF-F1AD94B64117}" dt="2026-04-10T06:55:17.284" v="347" actId="478"/>
           <ac:spMkLst>
             <pc:docMk/>
-            <pc:sldMk cId="283015613" sldId="256"/>
-            <ac:spMk id="2" creationId="{6A795E0C-6FA5-ABB4-A7C6-97D25F06D704}"/>
+            <pc:sldMk cId="466176374" sldId="257"/>
+            <ac:spMk id="2" creationId="{9CA4CCCF-610D-C3B9-169B-B5B38BCD8FA4}"/>
           </ac:spMkLst>
         </pc:spChg>
         <pc:spChg chg="del">
-          <ac:chgData name="Jacques Delort" userId="338bbbaa6367577a" providerId="LiveId" clId="{29EEF4E2-F752-45CC-A7DF-F1AD94B64117}" dt="2026-02-05T05:20:17.512" v="1" actId="478"/>
+          <ac:chgData name="Jacques Delort" userId="338bbbaa6367577a" providerId="LiveId" clId="{29EEF4E2-F752-45CC-A7DF-F1AD94B64117}" dt="2026-04-10T06:55:17.284" v="347" actId="478"/>
           <ac:spMkLst>
             <pc:docMk/>
-            <pc:sldMk cId="283015613" sldId="256"/>
-            <ac:spMk id="3" creationId="{FB0487F0-ED33-BBF4-BE42-9FEE2210E9BA}"/>
+            <pc:sldMk cId="466176374" sldId="257"/>
+            <ac:spMk id="3" creationId="{B22DC5A7-FD6A-2E78-50EA-004212B51302}"/>
+          </ac:spMkLst>
+        </pc:spChg>
+        <pc:spChg chg="mod">
+          <ac:chgData name="Jacques Delort" userId="338bbbaa6367577a" providerId="LiveId" clId="{29EEF4E2-F752-45CC-A7DF-F1AD94B64117}" dt="2026-04-10T06:55:23.121" v="348"/>
+          <ac:spMkLst>
+            <pc:docMk/>
+            <pc:sldMk cId="466176374" sldId="257"/>
+            <ac:spMk id="6" creationId="{18073E24-11B7-EFD5-D635-1C7295D28735}"/>
+          </ac:spMkLst>
+        </pc:spChg>
+        <pc:spChg chg="mod">
+          <ac:chgData name="Jacques Delort" userId="338bbbaa6367577a" providerId="LiveId" clId="{29EEF4E2-F752-45CC-A7DF-F1AD94B64117}" dt="2026-04-10T06:55:23.121" v="348"/>
+          <ac:spMkLst>
+            <pc:docMk/>
+            <pc:sldMk cId="466176374" sldId="257"/>
+            <ac:spMk id="7" creationId="{98DFA410-3AB8-D2AB-20DD-96C96363338F}"/>
+          </ac:spMkLst>
+        </pc:spChg>
+        <pc:spChg chg="mod">
+          <ac:chgData name="Jacques Delort" userId="338bbbaa6367577a" providerId="LiveId" clId="{29EEF4E2-F752-45CC-A7DF-F1AD94B64117}" dt="2026-04-10T06:55:23.121" v="348"/>
+          <ac:spMkLst>
+            <pc:docMk/>
+            <pc:sldMk cId="466176374" sldId="257"/>
+            <ac:spMk id="8" creationId="{E256F578-58C9-9872-C024-4F5BDE2E221F}"/>
+          </ac:spMkLst>
+        </pc:spChg>
+        <pc:spChg chg="mod">
+          <ac:chgData name="Jacques Delort" userId="338bbbaa6367577a" providerId="LiveId" clId="{29EEF4E2-F752-45CC-A7DF-F1AD94B64117}" dt="2026-04-10T06:55:23.121" v="348"/>
+          <ac:spMkLst>
+            <pc:docMk/>
+            <pc:sldMk cId="466176374" sldId="257"/>
+            <ac:spMk id="9" creationId="{05908958-98B0-CECC-2026-9F423246B54B}"/>
+          </ac:spMkLst>
+        </pc:spChg>
+        <pc:spChg chg="mod">
+          <ac:chgData name="Jacques Delort" userId="338bbbaa6367577a" providerId="LiveId" clId="{29EEF4E2-F752-45CC-A7DF-F1AD94B64117}" dt="2026-04-10T06:55:23.121" v="348"/>
+          <ac:spMkLst>
+            <pc:docMk/>
+            <pc:sldMk cId="466176374" sldId="257"/>
+            <ac:spMk id="12" creationId="{43511189-25EF-4BAD-4EF6-4506C2320E56}"/>
+          </ac:spMkLst>
+        </pc:spChg>
+        <pc:spChg chg="add del">
+          <ac:chgData name="Jacques Delort" userId="338bbbaa6367577a" providerId="LiveId" clId="{29EEF4E2-F752-45CC-A7DF-F1AD94B64117}" dt="2026-04-10T06:55:48.289" v="350" actId="478"/>
+          <ac:spMkLst>
+            <pc:docMk/>
+            <pc:sldMk cId="466176374" sldId="257"/>
+            <ac:spMk id="13" creationId="{AEA49C23-6ADF-B749-ACD1-3A6DF2881DB1}"/>
           </ac:spMkLst>
         </pc:spChg>
         <pc:spChg chg="add mod">
-          <ac:chgData name="Jacques Delort" userId="338bbbaa6367577a" providerId="LiveId" clId="{29EEF4E2-F752-45CC-A7DF-F1AD94B64117}" dt="2026-02-05T05:38:07.725" v="338" actId="164"/>
+          <ac:chgData name="Jacques Delort" userId="338bbbaa6367577a" providerId="LiveId" clId="{29EEF4E2-F752-45CC-A7DF-F1AD94B64117}" dt="2026-04-10T06:57:46.847" v="369" actId="1582"/>
           <ac:spMkLst>
             <pc:docMk/>
-            <pc:sldMk cId="283015613" sldId="256"/>
-            <ac:spMk id="23" creationId="{DC441760-0B17-48FD-39EF-9CD35F96D691}"/>
+            <pc:sldMk cId="466176374" sldId="257"/>
+            <ac:spMk id="14" creationId="{6117FE2E-19FD-B0C4-32AC-25A7A2201D14}"/>
           </ac:spMkLst>
         </pc:spChg>
         <pc:spChg chg="add mod">
-          <ac:chgData name="Jacques Delort" userId="338bbbaa6367577a" providerId="LiveId" clId="{29EEF4E2-F752-45CC-A7DF-F1AD94B64117}" dt="2026-02-05T05:38:07.725" v="338" actId="164"/>
+          <ac:chgData name="Jacques Delort" userId="338bbbaa6367577a" providerId="LiveId" clId="{29EEF4E2-F752-45CC-A7DF-F1AD94B64117}" dt="2026-04-10T06:59:19.783" v="386" actId="20577"/>
           <ac:spMkLst>
             <pc:docMk/>
-            <pc:sldMk cId="283015613" sldId="256"/>
-            <ac:spMk id="24" creationId="{C54A4912-26E7-0E64-A8F3-6B8A5D25329E}"/>
+            <pc:sldMk cId="466176374" sldId="257"/>
+            <ac:spMk id="24" creationId="{6F3108BE-78D5-35CF-1E94-D4075B475807}"/>
           </ac:spMkLst>
         </pc:spChg>
         <pc:spChg chg="add mod">
-          <ac:chgData name="Jacques Delort" userId="338bbbaa6367577a" providerId="LiveId" clId="{29EEF4E2-F752-45CC-A7DF-F1AD94B64117}" dt="2026-02-05T05:38:07.725" v="338" actId="164"/>
+          <ac:chgData name="Jacques Delort" userId="338bbbaa6367577a" providerId="LiveId" clId="{29EEF4E2-F752-45CC-A7DF-F1AD94B64117}" dt="2026-04-10T06:59:37.748" v="391" actId="1076"/>
           <ac:spMkLst>
             <pc:docMk/>
-            <pc:sldMk cId="283015613" sldId="256"/>
-            <ac:spMk id="25" creationId="{75C3ABC4-8FEB-BD03-632A-80CFB7C7FC37}"/>
+            <pc:sldMk cId="466176374" sldId="257"/>
+            <ac:spMk id="25" creationId="{4F5B20E5-7B57-A9A5-279D-599FC0CF2141}"/>
           </ac:spMkLst>
         </pc:spChg>
         <pc:spChg chg="add mod">
-          <ac:chgData name="Jacques Delort" userId="338bbbaa6367577a" providerId="LiveId" clId="{29EEF4E2-F752-45CC-A7DF-F1AD94B64117}" dt="2026-02-05T05:38:07.725" v="338" actId="164"/>
+          <ac:chgData name="Jacques Delort" userId="338bbbaa6367577a" providerId="LiveId" clId="{29EEF4E2-F752-45CC-A7DF-F1AD94B64117}" dt="2026-04-10T07:00:20.067" v="399" actId="208"/>
           <ac:spMkLst>
             <pc:docMk/>
-            <pc:sldMk cId="283015613" sldId="256"/>
-            <ac:spMk id="26" creationId="{3D166648-9F59-898B-E872-392C056F6234}"/>
+            <pc:sldMk cId="466176374" sldId="257"/>
+            <ac:spMk id="26" creationId="{628D63E9-2997-3C76-93CC-0B4E45E74F65}"/>
           </ac:spMkLst>
         </pc:spChg>
         <pc:spChg chg="add mod">
-          <ac:chgData name="Jacques Delort" userId="338bbbaa6367577a" providerId="LiveId" clId="{29EEF4E2-F752-45CC-A7DF-F1AD94B64117}" dt="2026-02-05T05:38:07.725" v="338" actId="164"/>
+          <ac:chgData name="Jacques Delort" userId="338bbbaa6367577a" providerId="LiveId" clId="{29EEF4E2-F752-45CC-A7DF-F1AD94B64117}" dt="2026-04-10T07:00:37.294" v="496" actId="1037"/>
           <ac:spMkLst>
             <pc:docMk/>
-            <pc:sldMk cId="283015613" sldId="256"/>
-            <ac:spMk id="31" creationId="{451E55E2-CFEB-3808-23B3-E56951E90088}"/>
+            <pc:sldMk cId="466176374" sldId="257"/>
+            <ac:spMk id="27" creationId="{ED480462-02D5-CB95-5FB0-A430FDD63E39}"/>
+          </ac:spMkLst>
+        </pc:spChg>
+        <pc:spChg chg="add mod">
+          <ac:chgData name="Jacques Delort" userId="338bbbaa6367577a" providerId="LiveId" clId="{29EEF4E2-F752-45CC-A7DF-F1AD94B64117}" dt="2026-04-10T07:01:22.382" v="593" actId="207"/>
+          <ac:spMkLst>
+            <pc:docMk/>
+            <pc:sldMk cId="466176374" sldId="257"/>
+            <ac:spMk id="28" creationId="{AE9687CE-78F1-1B1E-20C7-72E9A37ADF68}"/>
+          </ac:spMkLst>
+        </pc:spChg>
+        <pc:spChg chg="add mod">
+          <ac:chgData name="Jacques Delort" userId="338bbbaa6367577a" providerId="LiveId" clId="{29EEF4E2-F752-45CC-A7DF-F1AD94B64117}" dt="2026-04-10T07:01:32.582" v="597" actId="20577"/>
+          <ac:spMkLst>
+            <pc:docMk/>
+            <pc:sldMk cId="466176374" sldId="257"/>
+            <ac:spMk id="29" creationId="{47E6A0B9-3652-CD3C-5772-E529F9A569D0}"/>
+          </ac:spMkLst>
+        </pc:spChg>
+        <pc:spChg chg="add mod">
+          <ac:chgData name="Jacques Delort" userId="338bbbaa6367577a" providerId="LiveId" clId="{29EEF4E2-F752-45CC-A7DF-F1AD94B64117}" dt="2026-04-10T10:42:25.618" v="1290" actId="20577"/>
+          <ac:spMkLst>
+            <pc:docMk/>
+            <pc:sldMk cId="466176374" sldId="257"/>
+            <ac:spMk id="30" creationId="{1B7DA06C-A9AB-541D-1F22-133CAC6B31FB}"/>
+          </ac:spMkLst>
+        </pc:spChg>
+        <pc:spChg chg="add mod">
+          <ac:chgData name="Jacques Delort" userId="338bbbaa6367577a" providerId="LiveId" clId="{29EEF4E2-F752-45CC-A7DF-F1AD94B64117}" dt="2026-04-10T07:05:39.740" v="713"/>
+          <ac:spMkLst>
+            <pc:docMk/>
+            <pc:sldMk cId="466176374" sldId="257"/>
+            <ac:spMk id="31" creationId="{FF3B531D-59FB-5D3D-3B16-CFB82027AD59}"/>
+          </ac:spMkLst>
+        </pc:spChg>
+        <pc:spChg chg="add mod">
+          <ac:chgData name="Jacques Delort" userId="338bbbaa6367577a" providerId="LiveId" clId="{29EEF4E2-F752-45CC-A7DF-F1AD94B64117}" dt="2026-04-10T07:14:54.857" v="875" actId="1076"/>
+          <ac:spMkLst>
+            <pc:docMk/>
+            <pc:sldMk cId="466176374" sldId="257"/>
+            <ac:spMk id="32" creationId="{24285536-4DA3-1E51-A6C7-C30CB5450609}"/>
+          </ac:spMkLst>
+        </pc:spChg>
+        <pc:spChg chg="add mod">
+          <ac:chgData name="Jacques Delort" userId="338bbbaa6367577a" providerId="LiveId" clId="{29EEF4E2-F752-45CC-A7DF-F1AD94B64117}" dt="2026-04-10T10:42:57.305" v="1299" actId="20577"/>
+          <ac:spMkLst>
+            <pc:docMk/>
+            <pc:sldMk cId="466176374" sldId="257"/>
+            <ac:spMk id="33" creationId="{91A98533-E728-A2F0-1EEF-BCB8B26C630D}"/>
+          </ac:spMkLst>
+        </pc:spChg>
+        <pc:spChg chg="add mod">
+          <ac:chgData name="Jacques Delort" userId="338bbbaa6367577a" providerId="LiveId" clId="{29EEF4E2-F752-45CC-A7DF-F1AD94B64117}" dt="2026-04-10T07:16:09.204" v="890" actId="1076"/>
+          <ac:spMkLst>
+            <pc:docMk/>
+            <pc:sldMk cId="466176374" sldId="257"/>
+            <ac:spMk id="34" creationId="{2E928A43-D245-4DD3-7C0D-49EE675CECEA}"/>
+          </ac:spMkLst>
+        </pc:spChg>
+        <pc:spChg chg="add del mod">
+          <ac:chgData name="Jacques Delort" userId="338bbbaa6367577a" providerId="LiveId" clId="{29EEF4E2-F752-45CC-A7DF-F1AD94B64117}" dt="2026-04-10T07:30:23.932" v="1204" actId="478"/>
+          <ac:spMkLst>
+            <pc:docMk/>
+            <pc:sldMk cId="466176374" sldId="257"/>
+            <ac:spMk id="35" creationId="{3DF7D8AA-8B7B-85F8-D209-BF9522E40C05}"/>
+          </ac:spMkLst>
+        </pc:spChg>
+        <pc:spChg chg="add mod">
+          <ac:chgData name="Jacques Delort" userId="338bbbaa6367577a" providerId="LiveId" clId="{29EEF4E2-F752-45CC-A7DF-F1AD94B64117}" dt="2026-04-11T07:19:39.778" v="1319" actId="1076"/>
+          <ac:spMkLst>
+            <pc:docMk/>
+            <pc:sldMk cId="466176374" sldId="257"/>
+            <ac:spMk id="36" creationId="{0FD51302-DB17-797D-5416-C10DCC618984}"/>
+          </ac:spMkLst>
+        </pc:spChg>
+        <pc:spChg chg="add mod">
+          <ac:chgData name="Jacques Delort" userId="338bbbaa6367577a" providerId="LiveId" clId="{29EEF4E2-F752-45CC-A7DF-F1AD94B64117}" dt="2026-04-11T07:19:36.885" v="1318" actId="1076"/>
+          <ac:spMkLst>
+            <pc:docMk/>
+            <pc:sldMk cId="466176374" sldId="257"/>
+            <ac:spMk id="37" creationId="{0DE26614-3059-854E-70BE-7CE17BD434EB}"/>
+          </ac:spMkLst>
+        </pc:spChg>
+        <pc:spChg chg="add mod">
+          <ac:chgData name="Jacques Delort" userId="338bbbaa6367577a" providerId="LiveId" clId="{29EEF4E2-F752-45CC-A7DF-F1AD94B64117}" dt="2026-04-11T08:18:06.663" v="1398" actId="20577"/>
+          <ac:spMkLst>
+            <pc:docMk/>
+            <pc:sldMk cId="466176374" sldId="257"/>
+            <ac:spMk id="38" creationId="{C554837C-1454-A045-A0BC-A7063C6F2F1C}"/>
+          </ac:spMkLst>
+        </pc:spChg>
+        <pc:spChg chg="add mod">
+          <ac:chgData name="Jacques Delort" userId="338bbbaa6367577a" providerId="LiveId" clId="{29EEF4E2-F752-45CC-A7DF-F1AD94B64117}" dt="2026-04-11T08:18:09.910" v="1399" actId="20577"/>
+          <ac:spMkLst>
+            <pc:docMk/>
+            <pc:sldMk cId="466176374" sldId="257"/>
+            <ac:spMk id="39" creationId="{1B091DF7-045E-882D-BB88-5EF5AF9DE3B6}"/>
+          </ac:spMkLst>
+        </pc:spChg>
+        <pc:grpChg chg="add del mod">
+          <ac:chgData name="Jacques Delort" userId="338bbbaa6367577a" providerId="LiveId" clId="{29EEF4E2-F752-45CC-A7DF-F1AD94B64117}" dt="2026-04-10T07:01:40.641" v="598" actId="478"/>
+          <ac:grpSpMkLst>
+            <pc:docMk/>
+            <pc:sldMk cId="466176374" sldId="257"/>
+            <ac:grpSpMk id="4" creationId="{482598EC-BE3B-FA0B-5EAF-59B41B67B4A6}"/>
+          </ac:grpSpMkLst>
+        </pc:grpChg>
+        <pc:picChg chg="mod">
+          <ac:chgData name="Jacques Delort" userId="338bbbaa6367577a" providerId="LiveId" clId="{29EEF4E2-F752-45CC-A7DF-F1AD94B64117}" dt="2026-04-10T06:55:23.121" v="348"/>
+          <ac:picMkLst>
+            <pc:docMk/>
+            <pc:sldMk cId="466176374" sldId="257"/>
+            <ac:picMk id="5" creationId="{60C45EEF-1C58-2C39-1418-EBDBC0C37352}"/>
+          </ac:picMkLst>
+        </pc:picChg>
+        <pc:cxnChg chg="mod">
+          <ac:chgData name="Jacques Delort" userId="338bbbaa6367577a" providerId="LiveId" clId="{29EEF4E2-F752-45CC-A7DF-F1AD94B64117}" dt="2026-04-10T06:55:23.121" v="348"/>
+          <ac:cxnSpMkLst>
+            <pc:docMk/>
+            <pc:sldMk cId="466176374" sldId="257"/>
+            <ac:cxnSpMk id="10" creationId="{B0177F50-BB42-8CB1-4FD1-CEABCB8C76BA}"/>
+          </ac:cxnSpMkLst>
+        </pc:cxnChg>
+        <pc:cxnChg chg="mod">
+          <ac:chgData name="Jacques Delort" userId="338bbbaa6367577a" providerId="LiveId" clId="{29EEF4E2-F752-45CC-A7DF-F1AD94B64117}" dt="2026-04-10T06:55:23.121" v="348"/>
+          <ac:cxnSpMkLst>
+            <pc:docMk/>
+            <pc:sldMk cId="466176374" sldId="257"/>
+            <ac:cxnSpMk id="11" creationId="{A8792C4B-7186-5B5C-BE69-53BEDEEB5E01}"/>
+          </ac:cxnSpMkLst>
+        </pc:cxnChg>
+        <pc:cxnChg chg="add ord">
+          <ac:chgData name="Jacques Delort" userId="338bbbaa6367577a" providerId="LiveId" clId="{29EEF4E2-F752-45CC-A7DF-F1AD94B64117}" dt="2026-04-10T06:57:52.733" v="370" actId="167"/>
+          <ac:cxnSpMkLst>
+            <pc:docMk/>
+            <pc:sldMk cId="466176374" sldId="257"/>
+            <ac:cxnSpMk id="16" creationId="{C8036C0F-BA69-C00D-4632-25F058B92FDE}"/>
+          </ac:cxnSpMkLst>
+        </pc:cxnChg>
+        <pc:cxnChg chg="add mod">
+          <ac:chgData name="Jacques Delort" userId="338bbbaa6367577a" providerId="LiveId" clId="{29EEF4E2-F752-45CC-A7DF-F1AD94B64117}" dt="2026-04-10T06:57:55.904" v="376" actId="1037"/>
+          <ac:cxnSpMkLst>
+            <pc:docMk/>
+            <pc:sldMk cId="466176374" sldId="257"/>
+            <ac:cxnSpMk id="17" creationId="{27A07246-CB15-597D-E4B6-4017E37FF795}"/>
+          </ac:cxnSpMkLst>
+        </pc:cxnChg>
+        <pc:cxnChg chg="add mod">
+          <ac:chgData name="Jacques Delort" userId="338bbbaa6367577a" providerId="LiveId" clId="{29EEF4E2-F752-45CC-A7DF-F1AD94B64117}" dt="2026-04-10T06:57:46.847" v="369" actId="1582"/>
+          <ac:cxnSpMkLst>
+            <pc:docMk/>
+            <pc:sldMk cId="466176374" sldId="257"/>
+            <ac:cxnSpMk id="21" creationId="{2B278DD9-C422-1B77-7000-D0E5D3972FE3}"/>
+          </ac:cxnSpMkLst>
+        </pc:cxnChg>
+        <pc:cxnChg chg="add mod">
+          <ac:chgData name="Jacques Delort" userId="338bbbaa6367577a" providerId="LiveId" clId="{29EEF4E2-F752-45CC-A7DF-F1AD94B64117}" dt="2026-04-10T06:58:20.174" v="379" actId="693"/>
+          <ac:cxnSpMkLst>
+            <pc:docMk/>
+            <pc:sldMk cId="466176374" sldId="257"/>
+            <ac:cxnSpMk id="23" creationId="{581D0EF4-9B1F-5B70-1763-48227446FBC3}"/>
+          </ac:cxnSpMkLst>
+        </pc:cxnChg>
+      </pc:sldChg>
+      <pc:sldChg chg="addSp delSp modSp add mod">
+        <pc:chgData name="Jacques Delort" userId="338bbbaa6367577a" providerId="LiveId" clId="{29EEF4E2-F752-45CC-A7DF-F1AD94B64117}" dt="2026-04-10T08:00:52.565" v="1279" actId="6549"/>
+        <pc:sldMkLst>
+          <pc:docMk/>
+          <pc:sldMk cId="3891265910" sldId="258"/>
+        </pc:sldMkLst>
+        <pc:spChg chg="add mod ord">
+          <ac:chgData name="Jacques Delort" userId="338bbbaa6367577a" providerId="LiveId" clId="{29EEF4E2-F752-45CC-A7DF-F1AD94B64117}" dt="2026-04-10T07:22:14.558" v="1125" actId="164"/>
+          <ac:spMkLst>
+            <pc:docMk/>
+            <pc:sldMk cId="3891265910" sldId="258"/>
+            <ac:spMk id="4" creationId="{1258E929-AD3C-0663-CD96-E0A01381DFB4}"/>
+          </ac:spMkLst>
+        </pc:spChg>
+        <pc:spChg chg="add mod">
+          <ac:chgData name="Jacques Delort" userId="338bbbaa6367577a" providerId="LiveId" clId="{29EEF4E2-F752-45CC-A7DF-F1AD94B64117}" dt="2026-04-10T08:00:41.219" v="1278" actId="6549"/>
+          <ac:spMkLst>
+            <pc:docMk/>
+            <pc:sldMk cId="3891265910" sldId="258"/>
+            <ac:spMk id="6" creationId="{95C93AA5-2CC1-F794-F3D1-256E6B6AEC83}"/>
+          </ac:spMkLst>
+        </pc:spChg>
+        <pc:spChg chg="mod">
+          <ac:chgData name="Jacques Delort" userId="338bbbaa6367577a" providerId="LiveId" clId="{29EEF4E2-F752-45CC-A7DF-F1AD94B64117}" dt="2026-04-10T07:22:14.558" v="1125" actId="164"/>
+          <ac:spMkLst>
+            <pc:docMk/>
+            <pc:sldMk cId="3891265910" sldId="258"/>
+            <ac:spMk id="14" creationId="{DFFA76FE-AC70-C6E5-4517-B31BCDD84344}"/>
+          </ac:spMkLst>
+        </pc:spChg>
+        <pc:spChg chg="mod">
+          <ac:chgData name="Jacques Delort" userId="338bbbaa6367577a" providerId="LiveId" clId="{29EEF4E2-F752-45CC-A7DF-F1AD94B64117}" dt="2026-04-10T07:22:14.558" v="1125" actId="164"/>
+          <ac:spMkLst>
+            <pc:docMk/>
+            <pc:sldMk cId="3891265910" sldId="258"/>
+            <ac:spMk id="24" creationId="{FCD1E9F0-F249-40EC-5E7D-422AF6524B95}"/>
+          </ac:spMkLst>
+        </pc:spChg>
+        <pc:spChg chg="mod">
+          <ac:chgData name="Jacques Delort" userId="338bbbaa6367577a" providerId="LiveId" clId="{29EEF4E2-F752-45CC-A7DF-F1AD94B64117}" dt="2026-04-10T07:22:14.558" v="1125" actId="164"/>
+          <ac:spMkLst>
+            <pc:docMk/>
+            <pc:sldMk cId="3891265910" sldId="258"/>
+            <ac:spMk id="25" creationId="{628DBE10-D30F-7EE4-6E75-A149D83F03F5}"/>
+          </ac:spMkLst>
+        </pc:spChg>
+        <pc:spChg chg="mod">
+          <ac:chgData name="Jacques Delort" userId="338bbbaa6367577a" providerId="LiveId" clId="{29EEF4E2-F752-45CC-A7DF-F1AD94B64117}" dt="2026-04-10T07:22:14.558" v="1125" actId="164"/>
+          <ac:spMkLst>
+            <pc:docMk/>
+            <pc:sldMk cId="3891265910" sldId="258"/>
+            <ac:spMk id="26" creationId="{A9D75792-E6CF-DE70-BFAD-2457D4132760}"/>
+          </ac:spMkLst>
+        </pc:spChg>
+        <pc:spChg chg="mod">
+          <ac:chgData name="Jacques Delort" userId="338bbbaa6367577a" providerId="LiveId" clId="{29EEF4E2-F752-45CC-A7DF-F1AD94B64117}" dt="2026-04-10T07:22:14.558" v="1125" actId="164"/>
+          <ac:spMkLst>
+            <pc:docMk/>
+            <pc:sldMk cId="3891265910" sldId="258"/>
+            <ac:spMk id="27" creationId="{3C26B1E7-BE67-AF5D-6172-42878FE752C7}"/>
+          </ac:spMkLst>
+        </pc:spChg>
+        <pc:spChg chg="mod">
+          <ac:chgData name="Jacques Delort" userId="338bbbaa6367577a" providerId="LiveId" clId="{29EEF4E2-F752-45CC-A7DF-F1AD94B64117}" dt="2026-04-10T07:22:14.558" v="1125" actId="164"/>
+          <ac:spMkLst>
+            <pc:docMk/>
+            <pc:sldMk cId="3891265910" sldId="258"/>
+            <ac:spMk id="28" creationId="{037D0FC4-D975-31B5-EDA9-B59750B00659}"/>
+          </ac:spMkLst>
+        </pc:spChg>
+        <pc:spChg chg="mod">
+          <ac:chgData name="Jacques Delort" userId="338bbbaa6367577a" providerId="LiveId" clId="{29EEF4E2-F752-45CC-A7DF-F1AD94B64117}" dt="2026-04-10T07:22:14.558" v="1125" actId="164"/>
+          <ac:spMkLst>
+            <pc:docMk/>
+            <pc:sldMk cId="3891265910" sldId="258"/>
+            <ac:spMk id="29" creationId="{0BD6F182-21BD-102D-AA6C-1C5C71E53BF8}"/>
+          </ac:spMkLst>
+        </pc:spChg>
+        <pc:spChg chg="mod">
+          <ac:chgData name="Jacques Delort" userId="338bbbaa6367577a" providerId="LiveId" clId="{29EEF4E2-F752-45CC-A7DF-F1AD94B64117}" dt="2026-04-10T07:56:08.924" v="1276" actId="6549"/>
+          <ac:spMkLst>
+            <pc:docMk/>
+            <pc:sldMk cId="3891265910" sldId="258"/>
+            <ac:spMk id="30" creationId="{76E76206-519F-0CE4-FF47-2039FE295BDB}"/>
+          </ac:spMkLst>
+        </pc:spChg>
+        <pc:spChg chg="mod">
+          <ac:chgData name="Jacques Delort" userId="338bbbaa6367577a" providerId="LiveId" clId="{29EEF4E2-F752-45CC-A7DF-F1AD94B64117}" dt="2026-04-10T07:54:22.045" v="1273" actId="1076"/>
+          <ac:spMkLst>
+            <pc:docMk/>
+            <pc:sldMk cId="3891265910" sldId="258"/>
+            <ac:spMk id="32" creationId="{F43FCCA6-9B3B-B6DC-C577-A4D0253B7E43}"/>
+          </ac:spMkLst>
+        </pc:spChg>
+        <pc:spChg chg="mod">
+          <ac:chgData name="Jacques Delort" userId="338bbbaa6367577a" providerId="LiveId" clId="{29EEF4E2-F752-45CC-A7DF-F1AD94B64117}" dt="2026-04-10T08:00:52.565" v="1279" actId="6549"/>
+          <ac:spMkLst>
+            <pc:docMk/>
+            <pc:sldMk cId="3891265910" sldId="258"/>
+            <ac:spMk id="33" creationId="{23510A09-1220-1C3A-2BDD-5ACBAB9E09AF}"/>
+          </ac:spMkLst>
+        </pc:spChg>
+        <pc:spChg chg="mod">
+          <ac:chgData name="Jacques Delort" userId="338bbbaa6367577a" providerId="LiveId" clId="{29EEF4E2-F752-45CC-A7DF-F1AD94B64117}" dt="2026-04-10T07:22:14.558" v="1125" actId="164"/>
+          <ac:spMkLst>
+            <pc:docMk/>
+            <pc:sldMk cId="3891265910" sldId="258"/>
+            <ac:spMk id="34" creationId="{40796FEB-385C-0970-A44C-02DB51F3C09C}"/>
           </ac:spMkLst>
         </pc:spChg>
         <pc:grpChg chg="add mod">
-          <ac:chgData name="Jacques Delort" userId="338bbbaa6367577a" providerId="LiveId" clId="{29EEF4E2-F752-45CC-A7DF-F1AD94B64117}" dt="2026-02-05T05:38:07.725" v="338" actId="164"/>
+          <ac:chgData name="Jacques Delort" userId="338bbbaa6367577a" providerId="LiveId" clId="{29EEF4E2-F752-45CC-A7DF-F1AD94B64117}" dt="2026-04-10T07:22:18.074" v="1153" actId="1037"/>
           <ac:grpSpMkLst>
             <pc:docMk/>
-            <pc:sldMk cId="283015613" sldId="256"/>
-            <ac:grpSpMk id="32" creationId="{E00ED1F6-2E7F-892D-DDB3-48014CB830DE}"/>
+            <pc:sldMk cId="3891265910" sldId="258"/>
+            <ac:grpSpMk id="5" creationId="{293B58F8-F738-E62D-B398-59CB8D0429C0}"/>
           </ac:grpSpMkLst>
         </pc:grpChg>
-        <pc:picChg chg="add mod">
-          <ac:chgData name="Jacques Delort" userId="338bbbaa6367577a" providerId="LiveId" clId="{29EEF4E2-F752-45CC-A7DF-F1AD94B64117}" dt="2026-02-05T05:38:07.725" v="338" actId="164"/>
-          <ac:picMkLst>
-            <pc:docMk/>
-            <pc:sldMk cId="283015613" sldId="256"/>
-            <ac:picMk id="5" creationId="{34F30522-30F5-AAF9-0EBD-A24E55D7D63B}"/>
-          </ac:picMkLst>
-        </pc:picChg>
-        <pc:picChg chg="add mod">
-          <ac:chgData name="Jacques Delort" userId="338bbbaa6367577a" providerId="LiveId" clId="{29EEF4E2-F752-45CC-A7DF-F1AD94B64117}" dt="2026-02-05T05:33:57.955" v="56" actId="1076"/>
-          <ac:picMkLst>
-            <pc:docMk/>
-            <pc:sldMk cId="283015613" sldId="256"/>
-            <ac:picMk id="7" creationId="{64955ABD-3B7A-A73E-D92F-678FD8171A3F}"/>
-          </ac:picMkLst>
-        </pc:picChg>
-        <pc:picChg chg="add mod">
-          <ac:chgData name="Jacques Delort" userId="338bbbaa6367577a" providerId="LiveId" clId="{29EEF4E2-F752-45CC-A7DF-F1AD94B64117}" dt="2026-02-05T05:33:15.082" v="46" actId="14100"/>
-          <ac:picMkLst>
-            <pc:docMk/>
-            <pc:sldMk cId="283015613" sldId="256"/>
-            <ac:picMk id="9" creationId="{6A9BBBC6-6DB6-887C-178A-90743CC69E6C}"/>
-          </ac:picMkLst>
-        </pc:picChg>
-        <pc:picChg chg="add mod modCrop">
-          <ac:chgData name="Jacques Delort" userId="338bbbaa6367577a" providerId="LiveId" clId="{29EEF4E2-F752-45CC-A7DF-F1AD94B64117}" dt="2026-02-05T05:33:35.508" v="52" actId="1076"/>
-          <ac:picMkLst>
-            <pc:docMk/>
-            <pc:sldMk cId="283015613" sldId="256"/>
-            <ac:picMk id="11" creationId="{82DB9682-F61E-23EB-EA5E-93F8B0DAB88E}"/>
-          </ac:picMkLst>
-        </pc:picChg>
-        <pc:picChg chg="add mod">
-          <ac:chgData name="Jacques Delort" userId="338bbbaa6367577a" providerId="LiveId" clId="{29EEF4E2-F752-45CC-A7DF-F1AD94B64117}" dt="2026-02-05T05:31:51.321" v="29" actId="1076"/>
-          <ac:picMkLst>
-            <pc:docMk/>
-            <pc:sldMk cId="283015613" sldId="256"/>
-            <ac:picMk id="13" creationId="{1E587827-12D3-9A05-7ED1-353375E99949}"/>
-          </ac:picMkLst>
-        </pc:picChg>
-        <pc:picChg chg="add del mod">
-          <ac:chgData name="Jacques Delort" userId="338bbbaa6367577a" providerId="LiveId" clId="{29EEF4E2-F752-45CC-A7DF-F1AD94B64117}" dt="2026-02-05T05:34:01.787" v="57" actId="478"/>
-          <ac:picMkLst>
-            <pc:docMk/>
-            <pc:sldMk cId="283015613" sldId="256"/>
-            <ac:picMk id="15" creationId="{6C341CFB-8EE8-6724-D838-1DA845C676B5}"/>
-          </ac:picMkLst>
-        </pc:picChg>
-        <pc:picChg chg="add del mod">
-          <ac:chgData name="Jacques Delort" userId="338bbbaa6367577a" providerId="LiveId" clId="{29EEF4E2-F752-45CC-A7DF-F1AD94B64117}" dt="2026-02-05T05:32:30.538" v="34" actId="478"/>
-          <ac:picMkLst>
-            <pc:docMk/>
-            <pc:sldMk cId="283015613" sldId="256"/>
-            <ac:picMk id="17" creationId="{B1F57403-5E7F-2B86-39F6-375DC03EC169}"/>
-          </ac:picMkLst>
-        </pc:picChg>
-        <pc:picChg chg="add mod">
-          <ac:chgData name="Jacques Delort" userId="338bbbaa6367577a" providerId="LiveId" clId="{29EEF4E2-F752-45CC-A7DF-F1AD94B64117}" dt="2026-02-05T05:33:23.170" v="48" actId="14100"/>
-          <ac:picMkLst>
-            <pc:docMk/>
-            <pc:sldMk cId="283015613" sldId="256"/>
-            <ac:picMk id="19" creationId="{313FF1FB-833F-2B96-8A0F-215C3BCB96F7}"/>
-          </ac:picMkLst>
-        </pc:picChg>
-        <pc:picChg chg="add mod">
-          <ac:chgData name="Jacques Delort" userId="338bbbaa6367577a" providerId="LiveId" clId="{29EEF4E2-F752-45CC-A7DF-F1AD94B64117}" dt="2026-02-05T05:33:31.655" v="50" actId="571"/>
-          <ac:picMkLst>
-            <pc:docMk/>
-            <pc:sldMk cId="283015613" sldId="256"/>
-            <ac:picMk id="20" creationId="{9DBB01DC-662F-F0CB-6899-416E24337603}"/>
-          </ac:picMkLst>
-        </pc:picChg>
-        <pc:picChg chg="add mod">
-          <ac:chgData name="Jacques Delort" userId="338bbbaa6367577a" providerId="LiveId" clId="{29EEF4E2-F752-45CC-A7DF-F1AD94B64117}" dt="2026-02-05T05:51:31.124" v="342" actId="1076"/>
-          <ac:picMkLst>
-            <pc:docMk/>
-            <pc:sldMk cId="283015613" sldId="256"/>
-            <ac:picMk id="34" creationId="{40014A12-14DF-4A4F-791C-DFCCEA33A883}"/>
-          </ac:picMkLst>
-        </pc:picChg>
-        <pc:picChg chg="add mod">
-          <ac:chgData name="Jacques Delort" userId="338bbbaa6367577a" providerId="LiveId" clId="{29EEF4E2-F752-45CC-A7DF-F1AD94B64117}" dt="2026-02-05T05:52:08.981" v="345" actId="1076"/>
-          <ac:picMkLst>
-            <pc:docMk/>
-            <pc:sldMk cId="283015613" sldId="256"/>
-            <ac:picMk id="36" creationId="{33231253-38BD-FA72-BD4F-32E979CF7FF4}"/>
-          </ac:picMkLst>
-        </pc:picChg>
-        <pc:cxnChg chg="add mod ord">
-          <ac:chgData name="Jacques Delort" userId="338bbbaa6367577a" providerId="LiveId" clId="{29EEF4E2-F752-45CC-A7DF-F1AD94B64117}" dt="2026-02-05T05:38:07.725" v="338" actId="164"/>
+        <pc:cxnChg chg="mod">
+          <ac:chgData name="Jacques Delort" userId="338bbbaa6367577a" providerId="LiveId" clId="{29EEF4E2-F752-45CC-A7DF-F1AD94B64117}" dt="2026-04-10T07:21:49.731" v="1124" actId="1037"/>
           <ac:cxnSpMkLst>
             <pc:docMk/>
-            <pc:sldMk cId="283015613" sldId="256"/>
-            <ac:cxnSpMk id="22" creationId="{CEA085BD-9A3A-9872-27A5-3F4B482942D5}"/>
+            <pc:sldMk cId="3891265910" sldId="258"/>
+            <ac:cxnSpMk id="16" creationId="{DBB32B79-3405-BCAF-3D4B-4415FDA71D47}"/>
           </ac:cxnSpMkLst>
         </pc:cxnChg>
-        <pc:cxnChg chg="add mod">
-          <ac:chgData name="Jacques Delort" userId="338bbbaa6367577a" providerId="LiveId" clId="{29EEF4E2-F752-45CC-A7DF-F1AD94B64117}" dt="2026-02-05T05:38:07.725" v="338" actId="164"/>
+        <pc:cxnChg chg="mod">
+          <ac:chgData name="Jacques Delort" userId="338bbbaa6367577a" providerId="LiveId" clId="{29EEF4E2-F752-45CC-A7DF-F1AD94B64117}" dt="2026-04-10T07:21:49.731" v="1124" actId="1037"/>
           <ac:cxnSpMkLst>
             <pc:docMk/>
-            <pc:sldMk cId="283015613" sldId="256"/>
-            <ac:cxnSpMk id="27" creationId="{35F92EA9-68F1-05F3-6108-13BEB98A155A}"/>
+            <pc:sldMk cId="3891265910" sldId="258"/>
+            <ac:cxnSpMk id="17" creationId="{7D5F46B1-29C5-3C5C-BEC9-9EADD2A123AE}"/>
+          </ac:cxnSpMkLst>
+        </pc:cxnChg>
+        <pc:cxnChg chg="del mod">
+          <ac:chgData name="Jacques Delort" userId="338bbbaa6367577a" providerId="LiveId" clId="{29EEF4E2-F752-45CC-A7DF-F1AD94B64117}" dt="2026-04-10T07:17:54.254" v="897" actId="478"/>
+          <ac:cxnSpMkLst>
+            <pc:docMk/>
+            <pc:sldMk cId="3891265910" sldId="258"/>
+            <ac:cxnSpMk id="21" creationId="{74078FF2-2D1C-37CF-53FA-029200FB0D52}"/>
+          </ac:cxnSpMkLst>
+        </pc:cxnChg>
+        <pc:cxnChg chg="mod">
+          <ac:chgData name="Jacques Delort" userId="338bbbaa6367577a" providerId="LiveId" clId="{29EEF4E2-F752-45CC-A7DF-F1AD94B64117}" dt="2026-04-10T07:21:49.731" v="1124" actId="1037"/>
+          <ac:cxnSpMkLst>
+            <pc:docMk/>
+            <pc:sldMk cId="3891265910" sldId="258"/>
+            <ac:cxnSpMk id="23" creationId="{20B55CB0-4820-B4F6-A5AC-AB06001D5EA3}"/>
           </ac:cxnSpMkLst>
         </pc:cxnChg>
       </pc:sldChg>
@@ -451,7 +705,7 @@
           <a:p>
             <a:fld id="{6A949CA5-6C38-42AB-BB91-5D67F6A6AF4C}" type="datetimeFigureOut">
               <a:rPr lang="fr-FR" smtClean="0"/>
-              <a:t>05/02/2026</a:t>
+              <a:t>10/04/2026</a:t>
             </a:fld>
             <a:endParaRPr lang="fr-FR"/>
           </a:p>
@@ -649,7 +903,7 @@
           <a:p>
             <a:fld id="{6A949CA5-6C38-42AB-BB91-5D67F6A6AF4C}" type="datetimeFigureOut">
               <a:rPr lang="fr-FR" smtClean="0"/>
-              <a:t>05/02/2026</a:t>
+              <a:t>10/04/2026</a:t>
             </a:fld>
             <a:endParaRPr lang="fr-FR"/>
           </a:p>
@@ -857,7 +1111,7 @@
           <a:p>
             <a:fld id="{6A949CA5-6C38-42AB-BB91-5D67F6A6AF4C}" type="datetimeFigureOut">
               <a:rPr lang="fr-FR" smtClean="0"/>
-              <a:t>05/02/2026</a:t>
+              <a:t>10/04/2026</a:t>
             </a:fld>
             <a:endParaRPr lang="fr-FR"/>
           </a:p>
@@ -1055,7 +1309,7 @@
           <a:p>
             <a:fld id="{6A949CA5-6C38-42AB-BB91-5D67F6A6AF4C}" type="datetimeFigureOut">
               <a:rPr lang="fr-FR" smtClean="0"/>
-              <a:t>05/02/2026</a:t>
+              <a:t>10/04/2026</a:t>
             </a:fld>
             <a:endParaRPr lang="fr-FR"/>
           </a:p>
@@ -1330,7 +1584,7 @@
           <a:p>
             <a:fld id="{6A949CA5-6C38-42AB-BB91-5D67F6A6AF4C}" type="datetimeFigureOut">
               <a:rPr lang="fr-FR" smtClean="0"/>
-              <a:t>05/02/2026</a:t>
+              <a:t>10/04/2026</a:t>
             </a:fld>
             <a:endParaRPr lang="fr-FR"/>
           </a:p>
@@ -1595,7 +1849,7 @@
           <a:p>
             <a:fld id="{6A949CA5-6C38-42AB-BB91-5D67F6A6AF4C}" type="datetimeFigureOut">
               <a:rPr lang="fr-FR" smtClean="0"/>
-              <a:t>05/02/2026</a:t>
+              <a:t>10/04/2026</a:t>
             </a:fld>
             <a:endParaRPr lang="fr-FR"/>
           </a:p>
@@ -2007,7 +2261,7 @@
           <a:p>
             <a:fld id="{6A949CA5-6C38-42AB-BB91-5D67F6A6AF4C}" type="datetimeFigureOut">
               <a:rPr lang="fr-FR" smtClean="0"/>
-              <a:t>05/02/2026</a:t>
+              <a:t>10/04/2026</a:t>
             </a:fld>
             <a:endParaRPr lang="fr-FR"/>
           </a:p>
@@ -2148,7 +2402,7 @@
           <a:p>
             <a:fld id="{6A949CA5-6C38-42AB-BB91-5D67F6A6AF4C}" type="datetimeFigureOut">
               <a:rPr lang="fr-FR" smtClean="0"/>
-              <a:t>05/02/2026</a:t>
+              <a:t>10/04/2026</a:t>
             </a:fld>
             <a:endParaRPr lang="fr-FR"/>
           </a:p>
@@ -2261,7 +2515,7 @@
           <a:p>
             <a:fld id="{6A949CA5-6C38-42AB-BB91-5D67F6A6AF4C}" type="datetimeFigureOut">
               <a:rPr lang="fr-FR" smtClean="0"/>
-              <a:t>05/02/2026</a:t>
+              <a:t>10/04/2026</a:t>
             </a:fld>
             <a:endParaRPr lang="fr-FR"/>
           </a:p>
@@ -2572,7 +2826,7 @@
           <a:p>
             <a:fld id="{6A949CA5-6C38-42AB-BB91-5D67F6A6AF4C}" type="datetimeFigureOut">
               <a:rPr lang="fr-FR" smtClean="0"/>
-              <a:t>05/02/2026</a:t>
+              <a:t>10/04/2026</a:t>
             </a:fld>
             <a:endParaRPr lang="fr-FR"/>
           </a:p>
@@ -2860,7 +3114,7 @@
           <a:p>
             <a:fld id="{6A949CA5-6C38-42AB-BB91-5D67F6A6AF4C}" type="datetimeFigureOut">
               <a:rPr lang="fr-FR" smtClean="0"/>
-              <a:t>05/02/2026</a:t>
+              <a:t>10/04/2026</a:t>
             </a:fld>
             <a:endParaRPr lang="fr-FR"/>
           </a:p>
@@ -3101,7 +3355,7 @@
           <a:p>
             <a:fld id="{6A949CA5-6C38-42AB-BB91-5D67F6A6AF4C}" type="datetimeFigureOut">
               <a:rPr lang="fr-FR" smtClean="0"/>
-              <a:t>05/02/2026</a:t>
+              <a:t>10/04/2026</a:t>
             </a:fld>
             <a:endParaRPr lang="fr-FR"/>
           </a:p>
@@ -4130,6 +4384,3844 @@
 </p:sld>
 </file>
 
+<file path=ppt/slides/slide2.xml><?xml version="1.0" encoding="utf-8"?>
+<p:sld xmlns:a="http://schemas.openxmlformats.org/drawingml/2006/main" xmlns:r="http://schemas.openxmlformats.org/officeDocument/2006/relationships" xmlns:p="http://schemas.openxmlformats.org/presentationml/2006/main">
+  <p:cSld>
+    <p:spTree>
+      <p:nvGrpSpPr>
+        <p:cNvPr id="1" name=""/>
+        <p:cNvGrpSpPr/>
+        <p:nvPr/>
+      </p:nvGrpSpPr>
+      <p:grpSpPr>
+        <a:xfrm>
+          <a:off x="0" y="0"/>
+          <a:ext cx="0" cy="0"/>
+          <a:chOff x="0" y="0"/>
+          <a:chExt cx="0" cy="0"/>
+        </a:xfrm>
+      </p:grpSpPr>
+      <p:cxnSp>
+        <p:nvCxnSpPr>
+          <p:cNvPr id="16" name="Connecteur droit avec flèche 15">
+            <a:extLst>
+              <a:ext uri="{FF2B5EF4-FFF2-40B4-BE49-F238E27FC236}">
+                <a16:creationId xmlns:a16="http://schemas.microsoft.com/office/drawing/2014/main" id="{C8036C0F-BA69-C00D-4632-25F058B92FDE}"/>
+              </a:ext>
+            </a:extLst>
+          </p:cNvPr>
+          <p:cNvCxnSpPr/>
+          <p:nvPr/>
+        </p:nvCxnSpPr>
+        <p:spPr>
+          <a:xfrm>
+            <a:off x="1140431" y="1259679"/>
+            <a:ext cx="3729520" cy="0"/>
+          </a:xfrm>
+          <a:prstGeom prst="straightConnector1">
+            <a:avLst/>
+          </a:prstGeom>
+          <a:ln>
+            <a:tailEnd type="triangle"/>
+          </a:ln>
+        </p:spPr>
+        <p:style>
+          <a:lnRef idx="2">
+            <a:schemeClr val="accent1"/>
+          </a:lnRef>
+          <a:fillRef idx="0">
+            <a:schemeClr val="accent1"/>
+          </a:fillRef>
+          <a:effectRef idx="1">
+            <a:schemeClr val="accent1"/>
+          </a:effectRef>
+          <a:fontRef idx="minor">
+            <a:schemeClr val="tx1"/>
+          </a:fontRef>
+        </p:style>
+      </p:cxnSp>
+      <p:sp>
+        <p:nvSpPr>
+          <p:cNvPr id="14" name="Arc 13">
+            <a:extLst>
+              <a:ext uri="{FF2B5EF4-FFF2-40B4-BE49-F238E27FC236}">
+                <a16:creationId xmlns:a16="http://schemas.microsoft.com/office/drawing/2014/main" id="{6117FE2E-19FD-B0C4-32AC-25A7A2201D14}"/>
+              </a:ext>
+            </a:extLst>
+          </p:cNvPr>
+          <p:cNvSpPr/>
+          <p:nvPr/>
+        </p:nvSpPr>
+        <p:spPr>
+          <a:xfrm>
+            <a:off x="1531098" y="1259678"/>
+            <a:ext cx="1952088" cy="5598322"/>
+          </a:xfrm>
+          <a:prstGeom prst="arc">
+            <a:avLst>
+              <a:gd name="adj1" fmla="val 16200000"/>
+              <a:gd name="adj2" fmla="val 20117360"/>
+            </a:avLst>
+          </a:prstGeom>
+          <a:ln w="38100">
+            <a:solidFill>
+              <a:srgbClr val="FF0000"/>
+            </a:solidFill>
+          </a:ln>
+        </p:spPr>
+        <p:style>
+          <a:lnRef idx="2">
+            <a:schemeClr val="accent1"/>
+          </a:lnRef>
+          <a:fillRef idx="0">
+            <a:schemeClr val="accent1"/>
+          </a:fillRef>
+          <a:effectRef idx="1">
+            <a:schemeClr val="accent1"/>
+          </a:effectRef>
+          <a:fontRef idx="minor">
+            <a:schemeClr val="tx1"/>
+          </a:fontRef>
+        </p:style>
+        <p:txBody>
+          <a:bodyPr rtlCol="0" anchor="ctr"/>
+          <a:lstStyle/>
+          <a:p>
+            <a:pPr algn="ctr"/>
+            <a:endParaRPr lang="fr-FR"/>
+          </a:p>
+        </p:txBody>
+      </p:sp>
+      <p:cxnSp>
+        <p:nvCxnSpPr>
+          <p:cNvPr id="17" name="Connecteur droit avec flèche 16">
+            <a:extLst>
+              <a:ext uri="{FF2B5EF4-FFF2-40B4-BE49-F238E27FC236}">
+                <a16:creationId xmlns:a16="http://schemas.microsoft.com/office/drawing/2014/main" id="{27A07246-CB15-597D-E4B6-4017E37FF795}"/>
+              </a:ext>
+            </a:extLst>
+          </p:cNvPr>
+          <p:cNvCxnSpPr>
+            <a:cxnSpLocks/>
+          </p:cNvCxnSpPr>
+          <p:nvPr/>
+        </p:nvCxnSpPr>
+        <p:spPr>
+          <a:xfrm>
+            <a:off x="1083281" y="1259679"/>
+            <a:ext cx="0" cy="2622349"/>
+          </a:xfrm>
+          <a:prstGeom prst="straightConnector1">
+            <a:avLst/>
+          </a:prstGeom>
+          <a:ln>
+            <a:tailEnd type="triangle"/>
+          </a:ln>
+        </p:spPr>
+        <p:style>
+          <a:lnRef idx="2">
+            <a:schemeClr val="accent1"/>
+          </a:lnRef>
+          <a:fillRef idx="0">
+            <a:schemeClr val="accent1"/>
+          </a:fillRef>
+          <a:effectRef idx="1">
+            <a:schemeClr val="accent1"/>
+          </a:effectRef>
+          <a:fontRef idx="minor">
+            <a:schemeClr val="tx1"/>
+          </a:fontRef>
+        </p:style>
+      </p:cxnSp>
+      <p:cxnSp>
+        <p:nvCxnSpPr>
+          <p:cNvPr id="21" name="Connecteur droit 20">
+            <a:extLst>
+              <a:ext uri="{FF2B5EF4-FFF2-40B4-BE49-F238E27FC236}">
+                <a16:creationId xmlns:a16="http://schemas.microsoft.com/office/drawing/2014/main" id="{2B278DD9-C422-1B77-7000-D0E5D3972FE3}"/>
+              </a:ext>
+            </a:extLst>
+          </p:cNvPr>
+          <p:cNvCxnSpPr>
+            <a:cxnSpLocks/>
+            <a:endCxn id="14" idx="0"/>
+          </p:cNvCxnSpPr>
+          <p:nvPr/>
+        </p:nvCxnSpPr>
+        <p:spPr>
+          <a:xfrm>
+            <a:off x="1058484" y="1259678"/>
+            <a:ext cx="1448658" cy="0"/>
+          </a:xfrm>
+          <a:prstGeom prst="line">
+            <a:avLst/>
+          </a:prstGeom>
+          <a:ln w="38100">
+            <a:solidFill>
+              <a:srgbClr val="FF0000"/>
+            </a:solidFill>
+          </a:ln>
+        </p:spPr>
+        <p:style>
+          <a:lnRef idx="2">
+            <a:schemeClr val="accent1"/>
+          </a:lnRef>
+          <a:fillRef idx="0">
+            <a:schemeClr val="accent1"/>
+          </a:fillRef>
+          <a:effectRef idx="1">
+            <a:schemeClr val="accent1"/>
+          </a:effectRef>
+          <a:fontRef idx="minor">
+            <a:schemeClr val="tx1"/>
+          </a:fontRef>
+        </p:style>
+      </p:cxnSp>
+      <p:cxnSp>
+        <p:nvCxnSpPr>
+          <p:cNvPr id="23" name="Connecteur droit avec flèche 22">
+            <a:extLst>
+              <a:ext uri="{FF2B5EF4-FFF2-40B4-BE49-F238E27FC236}">
+                <a16:creationId xmlns:a16="http://schemas.microsoft.com/office/drawing/2014/main" id="{581D0EF4-9B1F-5B70-1763-48227446FBC3}"/>
+              </a:ext>
+            </a:extLst>
+          </p:cNvPr>
+          <p:cNvCxnSpPr>
+            <a:cxnSpLocks/>
+          </p:cNvCxnSpPr>
+          <p:nvPr/>
+        </p:nvCxnSpPr>
+        <p:spPr>
+          <a:xfrm>
+            <a:off x="3490142" y="1259679"/>
+            <a:ext cx="0" cy="2622349"/>
+          </a:xfrm>
+          <a:prstGeom prst="straightConnector1">
+            <a:avLst/>
+          </a:prstGeom>
+          <a:ln>
+            <a:prstDash val="dash"/>
+            <a:tailEnd type="triangle"/>
+          </a:ln>
+        </p:spPr>
+        <p:style>
+          <a:lnRef idx="2">
+            <a:schemeClr val="accent1"/>
+          </a:lnRef>
+          <a:fillRef idx="0">
+            <a:schemeClr val="accent1"/>
+          </a:fillRef>
+          <a:effectRef idx="1">
+            <a:schemeClr val="accent1"/>
+          </a:effectRef>
+          <a:fontRef idx="minor">
+            <a:schemeClr val="tx1"/>
+          </a:fontRef>
+        </p:style>
+      </p:cxnSp>
+      <p:sp>
+        <p:nvSpPr>
+          <p:cNvPr id="24" name="ZoneTexte 23">
+            <a:extLst>
+              <a:ext uri="{FF2B5EF4-FFF2-40B4-BE49-F238E27FC236}">
+                <a16:creationId xmlns:a16="http://schemas.microsoft.com/office/drawing/2014/main" id="{6F3108BE-78D5-35CF-1E94-D4075B475807}"/>
+              </a:ext>
+            </a:extLst>
+          </p:cNvPr>
+          <p:cNvSpPr txBox="1"/>
+          <p:nvPr/>
+        </p:nvSpPr>
+        <p:spPr>
+          <a:xfrm>
+            <a:off x="3339557" y="832788"/>
+            <a:ext cx="589649" cy="369332"/>
+          </a:xfrm>
+          <a:prstGeom prst="rect">
+            <a:avLst/>
+          </a:prstGeom>
+          <a:noFill/>
+        </p:spPr>
+        <p:txBody>
+          <a:bodyPr wrap="none" rtlCol="0">
+            <a:spAutoFit/>
+          </a:bodyPr>
+          <a:lstStyle/>
+          <a:p>
+            <a:r>
+              <a:rPr lang="fr-FR" dirty="0" err="1"/>
+              <a:t>xrov</a:t>
+            </a:r>
+            <a:endParaRPr lang="fr-FR" dirty="0"/>
+          </a:p>
+        </p:txBody>
+      </p:sp>
+      <p:sp>
+        <p:nvSpPr>
+          <p:cNvPr id="25" name="ZoneTexte 24">
+            <a:extLst>
+              <a:ext uri="{FF2B5EF4-FFF2-40B4-BE49-F238E27FC236}">
+                <a16:creationId xmlns:a16="http://schemas.microsoft.com/office/drawing/2014/main" id="{4F5B20E5-7B57-A9A5-279D-599FC0CF2141}"/>
+              </a:ext>
+            </a:extLst>
+          </p:cNvPr>
+          <p:cNvSpPr txBox="1"/>
+          <p:nvPr/>
+        </p:nvSpPr>
+        <p:spPr>
+          <a:xfrm>
+            <a:off x="370513" y="3328030"/>
+            <a:ext cx="591252" cy="369332"/>
+          </a:xfrm>
+          <a:prstGeom prst="rect">
+            <a:avLst/>
+          </a:prstGeom>
+          <a:noFill/>
+        </p:spPr>
+        <p:txBody>
+          <a:bodyPr wrap="none" rtlCol="0">
+            <a:spAutoFit/>
+          </a:bodyPr>
+          <a:lstStyle/>
+          <a:p>
+            <a:r>
+              <a:rPr lang="fr-FR" dirty="0" err="1"/>
+              <a:t>yrov</a:t>
+            </a:r>
+            <a:endParaRPr lang="fr-FR" dirty="0"/>
+          </a:p>
+        </p:txBody>
+      </p:sp>
+      <p:sp>
+        <p:nvSpPr>
+          <p:cNvPr id="26" name="Ellipse 25">
+            <a:extLst>
+              <a:ext uri="{FF2B5EF4-FFF2-40B4-BE49-F238E27FC236}">
+                <a16:creationId xmlns:a16="http://schemas.microsoft.com/office/drawing/2014/main" id="{628D63E9-2997-3C76-93CC-0B4E45E74F65}"/>
+              </a:ext>
+            </a:extLst>
+          </p:cNvPr>
+          <p:cNvSpPr/>
+          <p:nvPr/>
+        </p:nvSpPr>
+        <p:spPr>
+          <a:xfrm>
+            <a:off x="3421735" y="3572607"/>
+            <a:ext cx="93597" cy="99277"/>
+          </a:xfrm>
+          <a:prstGeom prst="ellipse">
+            <a:avLst/>
+          </a:prstGeom>
+          <a:solidFill>
+            <a:srgbClr val="00B050"/>
+          </a:solidFill>
+          <a:ln>
+            <a:solidFill>
+              <a:srgbClr val="00B050"/>
+            </a:solidFill>
+          </a:ln>
+        </p:spPr>
+        <p:style>
+          <a:lnRef idx="2">
+            <a:schemeClr val="accent1">
+              <a:shade val="15000"/>
+            </a:schemeClr>
+          </a:lnRef>
+          <a:fillRef idx="1">
+            <a:schemeClr val="accent1"/>
+          </a:fillRef>
+          <a:effectRef idx="0">
+            <a:schemeClr val="accent1"/>
+          </a:effectRef>
+          <a:fontRef idx="minor">
+            <a:schemeClr val="lt1"/>
+          </a:fontRef>
+        </p:style>
+        <p:txBody>
+          <a:bodyPr rtlCol="0" anchor="ctr"/>
+          <a:lstStyle/>
+          <a:p>
+            <a:pPr algn="ctr"/>
+            <a:endParaRPr lang="fr-FR"/>
+          </a:p>
+        </p:txBody>
+      </p:sp>
+      <p:sp>
+        <p:nvSpPr>
+          <p:cNvPr id="27" name="Ellipse 26">
+            <a:extLst>
+              <a:ext uri="{FF2B5EF4-FFF2-40B4-BE49-F238E27FC236}">
+                <a16:creationId xmlns:a16="http://schemas.microsoft.com/office/drawing/2014/main" id="{ED480462-02D5-CB95-5FB0-A430FDD63E39}"/>
+              </a:ext>
+            </a:extLst>
+          </p:cNvPr>
+          <p:cNvSpPr/>
+          <p:nvPr/>
+        </p:nvSpPr>
+        <p:spPr>
+          <a:xfrm>
+            <a:off x="1026147" y="1218113"/>
+            <a:ext cx="93597" cy="99277"/>
+          </a:xfrm>
+          <a:prstGeom prst="ellipse">
+            <a:avLst/>
+          </a:prstGeom>
+          <a:solidFill>
+            <a:srgbClr val="00B050"/>
+          </a:solidFill>
+          <a:ln>
+            <a:solidFill>
+              <a:srgbClr val="00B050"/>
+            </a:solidFill>
+          </a:ln>
+        </p:spPr>
+        <p:style>
+          <a:lnRef idx="2">
+            <a:schemeClr val="accent1">
+              <a:shade val="15000"/>
+            </a:schemeClr>
+          </a:lnRef>
+          <a:fillRef idx="1">
+            <a:schemeClr val="accent1"/>
+          </a:fillRef>
+          <a:effectRef idx="0">
+            <a:schemeClr val="accent1"/>
+          </a:effectRef>
+          <a:fontRef idx="minor">
+            <a:schemeClr val="lt1"/>
+          </a:fontRef>
+        </p:style>
+        <p:txBody>
+          <a:bodyPr rtlCol="0" anchor="ctr"/>
+          <a:lstStyle/>
+          <a:p>
+            <a:pPr algn="ctr"/>
+            <a:endParaRPr lang="fr-FR"/>
+          </a:p>
+        </p:txBody>
+      </p:sp>
+      <p:sp>
+        <p:nvSpPr>
+          <p:cNvPr id="28" name="Ellipse 27">
+            <a:extLst>
+              <a:ext uri="{FF2B5EF4-FFF2-40B4-BE49-F238E27FC236}">
+                <a16:creationId xmlns:a16="http://schemas.microsoft.com/office/drawing/2014/main" id="{AE9687CE-78F1-1B1E-20C7-72E9A37ADF68}"/>
+              </a:ext>
+            </a:extLst>
+          </p:cNvPr>
+          <p:cNvSpPr/>
+          <p:nvPr/>
+        </p:nvSpPr>
+        <p:spPr>
+          <a:xfrm>
+            <a:off x="2505623" y="1207842"/>
+            <a:ext cx="93597" cy="99277"/>
+          </a:xfrm>
+          <a:prstGeom prst="ellipse">
+            <a:avLst/>
+          </a:prstGeom>
+          <a:solidFill>
+            <a:schemeClr val="accent5">
+              <a:lumMod val="60000"/>
+              <a:lumOff val="40000"/>
+            </a:schemeClr>
+          </a:solidFill>
+          <a:ln>
+            <a:solidFill>
+              <a:schemeClr val="accent5">
+                <a:lumMod val="60000"/>
+                <a:lumOff val="40000"/>
+              </a:schemeClr>
+            </a:solidFill>
+          </a:ln>
+        </p:spPr>
+        <p:style>
+          <a:lnRef idx="2">
+            <a:schemeClr val="accent1">
+              <a:shade val="15000"/>
+            </a:schemeClr>
+          </a:lnRef>
+          <a:fillRef idx="1">
+            <a:schemeClr val="accent1"/>
+          </a:fillRef>
+          <a:effectRef idx="0">
+            <a:schemeClr val="accent1"/>
+          </a:effectRef>
+          <a:fontRef idx="minor">
+            <a:schemeClr val="lt1"/>
+          </a:fontRef>
+        </p:style>
+        <p:txBody>
+          <a:bodyPr rtlCol="0" anchor="ctr"/>
+          <a:lstStyle/>
+          <a:p>
+            <a:pPr algn="ctr"/>
+            <a:endParaRPr lang="fr-FR"/>
+          </a:p>
+        </p:txBody>
+      </p:sp>
+      <p:sp>
+        <p:nvSpPr>
+          <p:cNvPr id="29" name="ZoneTexte 28">
+            <a:extLst>
+              <a:ext uri="{FF2B5EF4-FFF2-40B4-BE49-F238E27FC236}">
+                <a16:creationId xmlns:a16="http://schemas.microsoft.com/office/drawing/2014/main" id="{47E6A0B9-3652-CD3C-5772-E529F9A569D0}"/>
+              </a:ext>
+            </a:extLst>
+          </p:cNvPr>
+          <p:cNvSpPr txBox="1"/>
+          <p:nvPr/>
+        </p:nvSpPr>
+        <p:spPr>
+          <a:xfrm>
+            <a:off x="2304395" y="781977"/>
+            <a:ext cx="450764" cy="369332"/>
+          </a:xfrm>
+          <a:prstGeom prst="rect">
+            <a:avLst/>
+          </a:prstGeom>
+          <a:noFill/>
+        </p:spPr>
+        <p:txBody>
+          <a:bodyPr wrap="none" rtlCol="0">
+            <a:spAutoFit/>
+          </a:bodyPr>
+          <a:lstStyle/>
+          <a:p>
+            <a:r>
+              <a:rPr lang="fr-FR" dirty="0" err="1"/>
+              <a:t>xH</a:t>
+            </a:r>
+            <a:endParaRPr lang="fr-FR" dirty="0"/>
+          </a:p>
+        </p:txBody>
+      </p:sp>
+      <mc:AlternateContent xmlns:mc="http://schemas.openxmlformats.org/markup-compatibility/2006">
+        <mc:Choice xmlns:a14="http://schemas.microsoft.com/office/drawing/2010/main" Requires="a14">
+          <p:sp>
+            <p:nvSpPr>
+              <p:cNvPr id="30" name="ZoneTexte 29">
+                <a:extLst>
+                  <a:ext uri="{FF2B5EF4-FFF2-40B4-BE49-F238E27FC236}">
+                    <a16:creationId xmlns:a16="http://schemas.microsoft.com/office/drawing/2014/main" id="{1B7DA06C-A9AB-541D-1F22-133CAC6B31FB}"/>
+                  </a:ext>
+                </a:extLst>
+              </p:cNvPr>
+              <p:cNvSpPr txBox="1"/>
+              <p:nvPr/>
+            </p:nvSpPr>
+            <p:spPr>
+              <a:xfrm>
+                <a:off x="6122082" y="1033447"/>
+                <a:ext cx="5278561" cy="566694"/>
+              </a:xfrm>
+              <a:prstGeom prst="rect">
+                <a:avLst/>
+              </a:prstGeom>
+              <a:noFill/>
+            </p:spPr>
+            <p:txBody>
+              <a:bodyPr wrap="none" rtlCol="0">
+                <a:spAutoFit/>
+              </a:bodyPr>
+              <a:lstStyle/>
+              <a:p>
+                <a14:m>
+                  <m:oMathPara xmlns:m="http://schemas.openxmlformats.org/officeDocument/2006/math">
+                    <m:oMathParaPr>
+                      <m:jc m:val="centerGroup"/>
+                    </m:oMathParaPr>
+                    <m:oMath xmlns:m="http://schemas.openxmlformats.org/officeDocument/2006/math">
+                      <m:r>
+                        <a:rPr lang="fr-FR" b="0" i="1" smtClean="0">
+                          <a:latin typeface="Cambria Math" panose="02040503050406030204" pitchFamily="18" charset="0"/>
+                        </a:rPr>
+                        <m:t>𝑃𝑜𝑢𝑟</m:t>
+                      </m:r>
+                      <m:r>
+                        <a:rPr lang="fr-FR" b="0" i="1" smtClean="0">
+                          <a:latin typeface="Cambria Math" panose="02040503050406030204" pitchFamily="18" charset="0"/>
+                        </a:rPr>
+                        <m:t> </m:t>
+                      </m:r>
+                      <m:sSub>
+                        <m:sSubPr>
+                          <m:ctrlPr>
+                            <a:rPr lang="fr-FR" b="0" i="1" smtClean="0">
+                              <a:latin typeface="Cambria Math" panose="02040503050406030204" pitchFamily="18" charset="0"/>
+                            </a:rPr>
+                          </m:ctrlPr>
+                        </m:sSubPr>
+                        <m:e>
+                          <m:r>
+                            <a:rPr lang="fr-FR" b="0" i="1" smtClean="0">
+                              <a:latin typeface="Cambria Math" panose="02040503050406030204" pitchFamily="18" charset="0"/>
+                            </a:rPr>
+                            <m:t>𝑥</m:t>
+                          </m:r>
+                        </m:e>
+                        <m:sub>
+                          <m:r>
+                            <a:rPr lang="fr-FR" b="0" i="1" smtClean="0">
+                              <a:latin typeface="Cambria Math" panose="02040503050406030204" pitchFamily="18" charset="0"/>
+                            </a:rPr>
+                            <m:t>𝐻</m:t>
+                          </m:r>
+                        </m:sub>
+                      </m:sSub>
+                      <m:r>
+                        <a:rPr lang="fr-FR" b="0" i="1" smtClean="0">
+                          <a:latin typeface="Cambria Math" panose="02040503050406030204" pitchFamily="18" charset="0"/>
+                        </a:rPr>
+                        <m:t>≤  </m:t>
+                      </m:r>
+                      <m:r>
+                        <a:rPr lang="fr-FR" b="0" i="1" smtClean="0">
+                          <a:latin typeface="Cambria Math" panose="02040503050406030204" pitchFamily="18" charset="0"/>
+                        </a:rPr>
+                        <m:t>𝑥</m:t>
+                      </m:r>
+                      <m:r>
+                        <a:rPr lang="fr-FR" b="0" i="1" smtClean="0">
+                          <a:latin typeface="Cambria Math" panose="02040503050406030204" pitchFamily="18" charset="0"/>
+                        </a:rPr>
+                        <m:t> ≤ </m:t>
+                      </m:r>
+                      <m:sSub>
+                        <m:sSubPr>
+                          <m:ctrlPr>
+                            <a:rPr lang="fr-FR" b="0" i="1" smtClean="0">
+                              <a:latin typeface="Cambria Math" panose="02040503050406030204" pitchFamily="18" charset="0"/>
+                            </a:rPr>
+                          </m:ctrlPr>
+                        </m:sSubPr>
+                        <m:e>
+                          <m:r>
+                            <a:rPr lang="fr-FR" b="0" i="1" smtClean="0">
+                              <a:latin typeface="Cambria Math" panose="02040503050406030204" pitchFamily="18" charset="0"/>
+                            </a:rPr>
+                            <m:t>𝑥</m:t>
+                          </m:r>
+                        </m:e>
+                        <m:sub>
+                          <m:r>
+                            <a:rPr lang="fr-FR" b="0" i="1" smtClean="0">
+                              <a:latin typeface="Cambria Math" panose="02040503050406030204" pitchFamily="18" charset="0"/>
+                            </a:rPr>
+                            <m:t>𝑟𝑜𝑣</m:t>
+                          </m:r>
+                        </m:sub>
+                      </m:sSub>
+                      <m:r>
+                        <a:rPr lang="fr-FR" b="0" i="1" smtClean="0">
+                          <a:latin typeface="Cambria Math" panose="02040503050406030204" pitchFamily="18" charset="0"/>
+                        </a:rPr>
+                        <m:t> :</m:t>
+                      </m:r>
+                      <m:r>
+                        <a:rPr lang="fr-FR" b="0" i="1" smtClean="0">
+                          <a:latin typeface="Cambria Math" panose="02040503050406030204" pitchFamily="18" charset="0"/>
+                        </a:rPr>
+                        <m:t>𝑦</m:t>
+                      </m:r>
+                      <m:r>
+                        <a:rPr lang="fr-FR" b="0" i="1" smtClean="0">
+                          <a:latin typeface="Cambria Math" panose="02040503050406030204" pitchFamily="18" charset="0"/>
+                        </a:rPr>
+                        <m:t>=</m:t>
+                      </m:r>
+                      <m:r>
+                        <a:rPr lang="fr-FR" b="0" i="1" smtClean="0">
+                          <a:latin typeface="Cambria Math" panose="02040503050406030204" pitchFamily="18" charset="0"/>
+                        </a:rPr>
+                        <m:t>𝑎</m:t>
+                      </m:r>
+                      <m:r>
+                        <a:rPr lang="fr-FR" b="0" i="1" smtClean="0">
+                          <a:latin typeface="Cambria Math" panose="02040503050406030204" pitchFamily="18" charset="0"/>
+                        </a:rPr>
+                        <m:t> </m:t>
+                      </m:r>
+                      <m:d>
+                        <m:dPr>
+                          <m:ctrlPr>
+                            <a:rPr lang="fr-FR" b="0" i="1" smtClean="0">
+                              <a:latin typeface="Cambria Math" panose="02040503050406030204" pitchFamily="18" charset="0"/>
+                            </a:rPr>
+                          </m:ctrlPr>
+                        </m:dPr>
+                        <m:e>
+                          <m:r>
+                            <a:rPr lang="fr-FR" i="1">
+                              <a:latin typeface="Cambria Math" panose="02040503050406030204" pitchFamily="18" charset="0"/>
+                            </a:rPr>
+                            <m:t>𝑐h</m:t>
+                          </m:r>
+                          <m:d>
+                            <m:dPr>
+                              <m:ctrlPr>
+                                <a:rPr lang="fr-FR" i="1">
+                                  <a:latin typeface="Cambria Math" panose="02040503050406030204" pitchFamily="18" charset="0"/>
+                                </a:rPr>
+                              </m:ctrlPr>
+                            </m:dPr>
+                            <m:e>
+                              <m:f>
+                                <m:fPr>
+                                  <m:ctrlPr>
+                                    <a:rPr lang="fr-FR" i="1">
+                                      <a:latin typeface="Cambria Math" panose="02040503050406030204" pitchFamily="18" charset="0"/>
+                                    </a:rPr>
+                                  </m:ctrlPr>
+                                </m:fPr>
+                                <m:num>
+                                  <m:r>
+                                    <a:rPr lang="fr-FR" i="1">
+                                      <a:latin typeface="Cambria Math" panose="02040503050406030204" pitchFamily="18" charset="0"/>
+                                    </a:rPr>
+                                    <m:t>𝑥</m:t>
+                                  </m:r>
+                                  <m:r>
+                                    <a:rPr lang="fr-FR" i="1">
+                                      <a:latin typeface="Cambria Math" panose="02040503050406030204" pitchFamily="18" charset="0"/>
+                                    </a:rPr>
+                                    <m:t> − </m:t>
+                                  </m:r>
+                                  <m:sSub>
+                                    <m:sSubPr>
+                                      <m:ctrlPr>
+                                        <a:rPr lang="fr-FR" i="1">
+                                          <a:latin typeface="Cambria Math" panose="02040503050406030204" pitchFamily="18" charset="0"/>
+                                        </a:rPr>
+                                      </m:ctrlPr>
+                                    </m:sSubPr>
+                                    <m:e>
+                                      <m:r>
+                                        <a:rPr lang="fr-FR" i="1">
+                                          <a:latin typeface="Cambria Math" panose="02040503050406030204" pitchFamily="18" charset="0"/>
+                                        </a:rPr>
+                                        <m:t>𝑥</m:t>
+                                      </m:r>
+                                    </m:e>
+                                    <m:sub>
+                                      <m:r>
+                                        <a:rPr lang="fr-FR" i="1">
+                                          <a:latin typeface="Cambria Math" panose="02040503050406030204" pitchFamily="18" charset="0"/>
+                                        </a:rPr>
+                                        <m:t>𝐻</m:t>
+                                      </m:r>
+                                    </m:sub>
+                                  </m:sSub>
+                                </m:num>
+                                <m:den>
+                                  <m:r>
+                                    <a:rPr lang="fr-FR" i="1">
+                                      <a:latin typeface="Cambria Math" panose="02040503050406030204" pitchFamily="18" charset="0"/>
+                                    </a:rPr>
+                                    <m:t>𝑎</m:t>
+                                  </m:r>
+                                </m:den>
+                              </m:f>
+                            </m:e>
+                          </m:d>
+                          <m:r>
+                            <a:rPr lang="fr-FR" b="0" i="1" smtClean="0">
+                              <a:latin typeface="Cambria Math" panose="02040503050406030204" pitchFamily="18" charset="0"/>
+                            </a:rPr>
+                            <m:t>  −1</m:t>
+                          </m:r>
+                        </m:e>
+                      </m:d>
+                    </m:oMath>
+                  </m:oMathPara>
+                </a14:m>
+                <a:endParaRPr lang="fr-FR" dirty="0"/>
+              </a:p>
+            </p:txBody>
+          </p:sp>
+        </mc:Choice>
+        <mc:Fallback>
+          <p:sp>
+            <p:nvSpPr>
+              <p:cNvPr id="30" name="ZoneTexte 29">
+                <a:extLst>
+                  <a:ext uri="{FF2B5EF4-FFF2-40B4-BE49-F238E27FC236}">
+                    <a16:creationId xmlns:a16="http://schemas.microsoft.com/office/drawing/2014/main" id="{1B7DA06C-A9AB-541D-1F22-133CAC6B31FB}"/>
+                  </a:ext>
+                </a:extLst>
+              </p:cNvPr>
+              <p:cNvSpPr txBox="1">
+                <a:spLocks noRot="1" noChangeAspect="1" noMove="1" noResize="1" noEditPoints="1" noAdjustHandles="1" noChangeArrowheads="1" noChangeShapeType="1" noTextEdit="1"/>
+              </p:cNvSpPr>
+              <p:nvPr/>
+            </p:nvSpPr>
+            <p:spPr>
+              <a:xfrm>
+                <a:off x="6122082" y="1033447"/>
+                <a:ext cx="5278561" cy="566694"/>
+              </a:xfrm>
+              <a:prstGeom prst="rect">
+                <a:avLst/>
+              </a:prstGeom>
+              <a:blipFill>
+                <a:blip r:embed="rId2"/>
+                <a:stretch>
+                  <a:fillRect/>
+                </a:stretch>
+              </a:blipFill>
+            </p:spPr>
+            <p:txBody>
+              <a:bodyPr/>
+              <a:lstStyle/>
+              <a:p>
+                <a:r>
+                  <a:rPr lang="fr-FR">
+                    <a:noFill/>
+                  </a:rPr>
+                  <a:t> </a:t>
+                </a:r>
+              </a:p>
+            </p:txBody>
+          </p:sp>
+        </mc:Fallback>
+      </mc:AlternateContent>
+      <mc:AlternateContent xmlns:mc="http://schemas.openxmlformats.org/markup-compatibility/2006">
+        <mc:Choice xmlns:a14="http://schemas.microsoft.com/office/drawing/2010/main" Requires="a14">
+          <p:sp>
+            <p:nvSpPr>
+              <p:cNvPr id="32" name="ZoneTexte 31">
+                <a:extLst>
+                  <a:ext uri="{FF2B5EF4-FFF2-40B4-BE49-F238E27FC236}">
+                    <a16:creationId xmlns:a16="http://schemas.microsoft.com/office/drawing/2014/main" id="{24285536-4DA3-1E51-A6C7-C30CB5450609}"/>
+                  </a:ext>
+                </a:extLst>
+              </p:cNvPr>
+              <p:cNvSpPr txBox="1"/>
+              <p:nvPr/>
+            </p:nvSpPr>
+            <p:spPr>
+              <a:xfrm>
+                <a:off x="6245372" y="2312416"/>
+                <a:ext cx="2543132" cy="516873"/>
+              </a:xfrm>
+              <a:prstGeom prst="rect">
+                <a:avLst/>
+              </a:prstGeom>
+              <a:noFill/>
+            </p:spPr>
+            <p:txBody>
+              <a:bodyPr wrap="none" rtlCol="0">
+                <a:spAutoFit/>
+              </a:bodyPr>
+              <a:lstStyle/>
+              <a:p>
+                <a:r>
+                  <a:rPr lang="fr-FR" dirty="0"/>
+                  <a:t>L = </a:t>
+                </a:r>
+                <a14:m>
+                  <m:oMath xmlns:m="http://schemas.openxmlformats.org/officeDocument/2006/math">
+                    <m:sSub>
+                      <m:sSubPr>
+                        <m:ctrlPr>
+                          <a:rPr lang="fr-FR" i="1" smtClean="0">
+                            <a:latin typeface="Cambria Math" panose="02040503050406030204" pitchFamily="18" charset="0"/>
+                          </a:rPr>
+                        </m:ctrlPr>
+                      </m:sSubPr>
+                      <m:e>
+                        <m:r>
+                          <a:rPr lang="fr-FR" b="0" i="1" smtClean="0">
+                            <a:latin typeface="Cambria Math" panose="02040503050406030204" pitchFamily="18" charset="0"/>
+                          </a:rPr>
+                          <m:t>𝑥</m:t>
+                        </m:r>
+                      </m:e>
+                      <m:sub>
+                        <m:r>
+                          <a:rPr lang="fr-FR" b="0" i="1" smtClean="0">
+                            <a:latin typeface="Cambria Math" panose="02040503050406030204" pitchFamily="18" charset="0"/>
+                          </a:rPr>
+                          <m:t>𝐻</m:t>
+                        </m:r>
+                      </m:sub>
+                    </m:sSub>
+                    <m:r>
+                      <a:rPr lang="fr-FR" b="0" i="1" smtClean="0">
+                        <a:latin typeface="Cambria Math" panose="02040503050406030204" pitchFamily="18" charset="0"/>
+                      </a:rPr>
+                      <m:t>+</m:t>
+                    </m:r>
+                    <m:r>
+                      <a:rPr lang="fr-FR" b="0" i="1" smtClean="0">
+                        <a:latin typeface="Cambria Math" panose="02040503050406030204" pitchFamily="18" charset="0"/>
+                      </a:rPr>
+                      <m:t>𝑎</m:t>
+                    </m:r>
+                    <m:r>
+                      <a:rPr lang="fr-FR" b="0" i="1" smtClean="0">
+                        <a:latin typeface="Cambria Math" panose="02040503050406030204" pitchFamily="18" charset="0"/>
+                      </a:rPr>
+                      <m:t> </m:t>
+                    </m:r>
+                    <m:r>
+                      <a:rPr lang="fr-FR" b="0" i="1" smtClean="0">
+                        <a:latin typeface="Cambria Math" panose="02040503050406030204" pitchFamily="18" charset="0"/>
+                      </a:rPr>
+                      <m:t>𝑠h</m:t>
+                    </m:r>
+                    <m:d>
+                      <m:dPr>
+                        <m:ctrlPr>
+                          <a:rPr lang="fr-FR" b="0" i="1" smtClean="0">
+                            <a:latin typeface="Cambria Math" panose="02040503050406030204" pitchFamily="18" charset="0"/>
+                          </a:rPr>
+                        </m:ctrlPr>
+                      </m:dPr>
+                      <m:e>
+                        <m:f>
+                          <m:fPr>
+                            <m:ctrlPr>
+                              <a:rPr lang="fr-FR" b="0" i="1" smtClean="0">
+                                <a:latin typeface="Cambria Math" panose="02040503050406030204" pitchFamily="18" charset="0"/>
+                              </a:rPr>
+                            </m:ctrlPr>
+                          </m:fPr>
+                          <m:num>
+                            <m:sSub>
+                              <m:sSubPr>
+                                <m:ctrlPr>
+                                  <a:rPr lang="fr-FR" b="0" i="1" smtClean="0">
+                                    <a:latin typeface="Cambria Math" panose="02040503050406030204" pitchFamily="18" charset="0"/>
+                                  </a:rPr>
+                                </m:ctrlPr>
+                              </m:sSubPr>
+                              <m:e>
+                                <m:r>
+                                  <a:rPr lang="fr-FR" b="0" i="1" smtClean="0">
+                                    <a:latin typeface="Cambria Math" panose="02040503050406030204" pitchFamily="18" charset="0"/>
+                                  </a:rPr>
+                                  <m:t>𝑥</m:t>
+                                </m:r>
+                              </m:e>
+                              <m:sub>
+                                <m:r>
+                                  <a:rPr lang="fr-FR" b="0" i="1" smtClean="0">
+                                    <a:latin typeface="Cambria Math" panose="02040503050406030204" pitchFamily="18" charset="0"/>
+                                  </a:rPr>
+                                  <m:t>𝑟𝑜𝑣</m:t>
+                                </m:r>
+                              </m:sub>
+                            </m:sSub>
+                            <m:r>
+                              <a:rPr lang="fr-FR" b="0" i="1" smtClean="0">
+                                <a:latin typeface="Cambria Math" panose="02040503050406030204" pitchFamily="18" charset="0"/>
+                              </a:rPr>
+                              <m:t> −</m:t>
+                            </m:r>
+                            <m:sSub>
+                              <m:sSubPr>
+                                <m:ctrlPr>
+                                  <a:rPr lang="fr-FR" b="0" i="1" smtClean="0">
+                                    <a:latin typeface="Cambria Math" panose="02040503050406030204" pitchFamily="18" charset="0"/>
+                                  </a:rPr>
+                                </m:ctrlPr>
+                              </m:sSubPr>
+                              <m:e>
+                                <m:r>
+                                  <a:rPr lang="fr-FR" b="0" i="1" smtClean="0">
+                                    <a:latin typeface="Cambria Math" panose="02040503050406030204" pitchFamily="18" charset="0"/>
+                                  </a:rPr>
+                                  <m:t>𝑥</m:t>
+                                </m:r>
+                              </m:e>
+                              <m:sub>
+                                <m:r>
+                                  <a:rPr lang="fr-FR" b="0" i="1" smtClean="0">
+                                    <a:latin typeface="Cambria Math" panose="02040503050406030204" pitchFamily="18" charset="0"/>
+                                  </a:rPr>
+                                  <m:t>𝐻</m:t>
+                                </m:r>
+                              </m:sub>
+                            </m:sSub>
+                          </m:num>
+                          <m:den>
+                            <m:r>
+                              <a:rPr lang="fr-FR" b="0" i="1" smtClean="0">
+                                <a:latin typeface="Cambria Math" panose="02040503050406030204" pitchFamily="18" charset="0"/>
+                              </a:rPr>
+                              <m:t>𝑎</m:t>
+                            </m:r>
+                          </m:den>
+                        </m:f>
+                      </m:e>
+                    </m:d>
+                  </m:oMath>
+                </a14:m>
+                <a:endParaRPr lang="fr-FR" dirty="0"/>
+              </a:p>
+            </p:txBody>
+          </p:sp>
+        </mc:Choice>
+        <mc:Fallback>
+          <p:sp>
+            <p:nvSpPr>
+              <p:cNvPr id="32" name="ZoneTexte 31">
+                <a:extLst>
+                  <a:ext uri="{FF2B5EF4-FFF2-40B4-BE49-F238E27FC236}">
+                    <a16:creationId xmlns:a16="http://schemas.microsoft.com/office/drawing/2014/main" id="{24285536-4DA3-1E51-A6C7-C30CB5450609}"/>
+                  </a:ext>
+                </a:extLst>
+              </p:cNvPr>
+              <p:cNvSpPr txBox="1">
+                <a:spLocks noRot="1" noChangeAspect="1" noMove="1" noResize="1" noEditPoints="1" noAdjustHandles="1" noChangeArrowheads="1" noChangeShapeType="1" noTextEdit="1"/>
+              </p:cNvSpPr>
+              <p:nvPr/>
+            </p:nvSpPr>
+            <p:spPr>
+              <a:xfrm>
+                <a:off x="6245372" y="2312416"/>
+                <a:ext cx="2543132" cy="516873"/>
+              </a:xfrm>
+              <a:prstGeom prst="rect">
+                <a:avLst/>
+              </a:prstGeom>
+              <a:blipFill>
+                <a:blip r:embed="rId3"/>
+                <a:stretch>
+                  <a:fillRect l="-2158" b="-4706"/>
+                </a:stretch>
+              </a:blipFill>
+            </p:spPr>
+            <p:txBody>
+              <a:bodyPr/>
+              <a:lstStyle/>
+              <a:p>
+                <a:r>
+                  <a:rPr lang="fr-FR">
+                    <a:noFill/>
+                  </a:rPr>
+                  <a:t> </a:t>
+                </a:r>
+              </a:p>
+            </p:txBody>
+          </p:sp>
+        </mc:Fallback>
+      </mc:AlternateContent>
+      <mc:AlternateContent xmlns:mc="http://schemas.openxmlformats.org/markup-compatibility/2006">
+        <mc:Choice xmlns:a14="http://schemas.microsoft.com/office/drawing/2010/main" Requires="a14">
+          <p:sp>
+            <p:nvSpPr>
+              <p:cNvPr id="33" name="ZoneTexte 32">
+                <a:extLst>
+                  <a:ext uri="{FF2B5EF4-FFF2-40B4-BE49-F238E27FC236}">
+                    <a16:creationId xmlns:a16="http://schemas.microsoft.com/office/drawing/2014/main" id="{91A98533-E728-A2F0-1EEF-BCB8B26C630D}"/>
+                  </a:ext>
+                </a:extLst>
+              </p:cNvPr>
+              <p:cNvSpPr txBox="1"/>
+              <p:nvPr/>
+            </p:nvSpPr>
+            <p:spPr>
+              <a:xfrm>
+                <a:off x="6245372" y="1598345"/>
+                <a:ext cx="3026982" cy="506870"/>
+              </a:xfrm>
+              <a:prstGeom prst="rect">
+                <a:avLst/>
+              </a:prstGeom>
+              <a:noFill/>
+            </p:spPr>
+            <p:txBody>
+              <a:bodyPr wrap="none" rtlCol="0">
+                <a:spAutoFit/>
+              </a:bodyPr>
+              <a:lstStyle/>
+              <a:p>
+                <a14:m>
+                  <m:oMath xmlns:m="http://schemas.openxmlformats.org/officeDocument/2006/math">
+                    <m:sSub>
+                      <m:sSubPr>
+                        <m:ctrlPr>
+                          <a:rPr lang="fr-FR" b="0" i="1" smtClean="0">
+                            <a:latin typeface="Cambria Math" panose="02040503050406030204" pitchFamily="18" charset="0"/>
+                          </a:rPr>
+                        </m:ctrlPr>
+                      </m:sSubPr>
+                      <m:e>
+                        <m:r>
+                          <a:rPr lang="fr-FR" b="0" i="1" smtClean="0">
+                            <a:latin typeface="Cambria Math" panose="02040503050406030204" pitchFamily="18" charset="0"/>
+                          </a:rPr>
+                          <m:t>𝑦</m:t>
+                        </m:r>
+                      </m:e>
+                      <m:sub>
+                        <m:r>
+                          <a:rPr lang="fr-FR" b="0" i="1" smtClean="0">
+                            <a:latin typeface="Cambria Math" panose="02040503050406030204" pitchFamily="18" charset="0"/>
+                          </a:rPr>
+                          <m:t>𝑟𝑜𝑣</m:t>
+                        </m:r>
+                      </m:sub>
+                    </m:sSub>
+                    <m:r>
+                      <a:rPr lang="fr-FR" b="0" i="1" smtClean="0">
+                        <a:latin typeface="Cambria Math" panose="02040503050406030204" pitchFamily="18" charset="0"/>
+                      </a:rPr>
+                      <m:t>=</m:t>
+                    </m:r>
+                    <m:r>
+                      <a:rPr lang="fr-FR" b="0" i="1" smtClean="0">
+                        <a:latin typeface="Cambria Math" panose="02040503050406030204" pitchFamily="18" charset="0"/>
+                      </a:rPr>
+                      <m:t>𝑎</m:t>
+                    </m:r>
+                  </m:oMath>
+                </a14:m>
+                <a:r>
+                  <a:rPr lang="fr-FR" dirty="0"/>
+                  <a:t> </a:t>
+                </a:r>
+                <a14:m>
+                  <m:oMath xmlns:m="http://schemas.openxmlformats.org/officeDocument/2006/math">
+                    <m:d>
+                      <m:dPr>
+                        <m:ctrlPr>
+                          <a:rPr lang="fr-FR" i="1" dirty="0" smtClean="0">
+                            <a:latin typeface="Cambria Math" panose="02040503050406030204" pitchFamily="18" charset="0"/>
+                          </a:rPr>
+                        </m:ctrlPr>
+                      </m:dPr>
+                      <m:e>
+                        <m:r>
+                          <a:rPr lang="fr-FR" i="1">
+                            <a:latin typeface="Cambria Math" panose="02040503050406030204" pitchFamily="18" charset="0"/>
+                          </a:rPr>
+                          <m:t>𝑐h</m:t>
+                        </m:r>
+                        <m:d>
+                          <m:dPr>
+                            <m:ctrlPr>
+                              <a:rPr lang="fr-FR" i="1">
+                                <a:latin typeface="Cambria Math" panose="02040503050406030204" pitchFamily="18" charset="0"/>
+                              </a:rPr>
+                            </m:ctrlPr>
+                          </m:dPr>
+                          <m:e>
+                            <m:f>
+                              <m:fPr>
+                                <m:ctrlPr>
+                                  <a:rPr lang="fr-FR" i="1">
+                                    <a:latin typeface="Cambria Math" panose="02040503050406030204" pitchFamily="18" charset="0"/>
+                                  </a:rPr>
+                                </m:ctrlPr>
+                              </m:fPr>
+                              <m:num>
+                                <m:sSub>
+                                  <m:sSubPr>
+                                    <m:ctrlPr>
+                                      <a:rPr lang="fr-FR" i="1">
+                                        <a:latin typeface="Cambria Math" panose="02040503050406030204" pitchFamily="18" charset="0"/>
+                                      </a:rPr>
+                                    </m:ctrlPr>
+                                  </m:sSubPr>
+                                  <m:e>
+                                    <m:r>
+                                      <a:rPr lang="fr-FR" i="1">
+                                        <a:latin typeface="Cambria Math" panose="02040503050406030204" pitchFamily="18" charset="0"/>
+                                      </a:rPr>
+                                      <m:t>𝑥</m:t>
+                                    </m:r>
+                                  </m:e>
+                                  <m:sub>
+                                    <m:r>
+                                      <a:rPr lang="fr-FR" i="1">
+                                        <a:latin typeface="Cambria Math" panose="02040503050406030204" pitchFamily="18" charset="0"/>
+                                      </a:rPr>
+                                      <m:t>𝑟𝑜𝑣</m:t>
+                                    </m:r>
+                                  </m:sub>
+                                </m:sSub>
+                                <m:r>
+                                  <a:rPr lang="fr-FR" i="1">
+                                    <a:latin typeface="Cambria Math" panose="02040503050406030204" pitchFamily="18" charset="0"/>
+                                  </a:rPr>
+                                  <m:t> − </m:t>
+                                </m:r>
+                                <m:sSub>
+                                  <m:sSubPr>
+                                    <m:ctrlPr>
+                                      <a:rPr lang="fr-FR" i="1">
+                                        <a:latin typeface="Cambria Math" panose="02040503050406030204" pitchFamily="18" charset="0"/>
+                                      </a:rPr>
+                                    </m:ctrlPr>
+                                  </m:sSubPr>
+                                  <m:e>
+                                    <m:r>
+                                      <a:rPr lang="fr-FR" i="1">
+                                        <a:latin typeface="Cambria Math" panose="02040503050406030204" pitchFamily="18" charset="0"/>
+                                      </a:rPr>
+                                      <m:t>𝑥</m:t>
+                                    </m:r>
+                                  </m:e>
+                                  <m:sub>
+                                    <m:r>
+                                      <a:rPr lang="fr-FR" i="1">
+                                        <a:latin typeface="Cambria Math" panose="02040503050406030204" pitchFamily="18" charset="0"/>
+                                      </a:rPr>
+                                      <m:t>𝐻</m:t>
+                                    </m:r>
+                                  </m:sub>
+                                </m:sSub>
+                              </m:num>
+                              <m:den>
+                                <m:r>
+                                  <a:rPr lang="fr-FR" i="1">
+                                    <a:latin typeface="Cambria Math" panose="02040503050406030204" pitchFamily="18" charset="0"/>
+                                  </a:rPr>
+                                  <m:t>𝑎</m:t>
+                                </m:r>
+                              </m:den>
+                            </m:f>
+                          </m:e>
+                        </m:d>
+                        <m:r>
+                          <a:rPr lang="fr-FR" b="0" i="1" smtClean="0">
+                            <a:latin typeface="Cambria Math" panose="02040503050406030204" pitchFamily="18" charset="0"/>
+                          </a:rPr>
+                          <m:t> −1</m:t>
+                        </m:r>
+                      </m:e>
+                    </m:d>
+                  </m:oMath>
+                </a14:m>
+                <a:endParaRPr lang="fr-FR" dirty="0"/>
+              </a:p>
+            </p:txBody>
+          </p:sp>
+        </mc:Choice>
+        <mc:Fallback>
+          <p:sp>
+            <p:nvSpPr>
+              <p:cNvPr id="33" name="ZoneTexte 32">
+                <a:extLst>
+                  <a:ext uri="{FF2B5EF4-FFF2-40B4-BE49-F238E27FC236}">
+                    <a16:creationId xmlns:a16="http://schemas.microsoft.com/office/drawing/2014/main" id="{91A98533-E728-A2F0-1EEF-BCB8B26C630D}"/>
+                  </a:ext>
+                </a:extLst>
+              </p:cNvPr>
+              <p:cNvSpPr txBox="1">
+                <a:spLocks noRot="1" noChangeAspect="1" noMove="1" noResize="1" noEditPoints="1" noAdjustHandles="1" noChangeArrowheads="1" noChangeShapeType="1" noTextEdit="1"/>
+              </p:cNvSpPr>
+              <p:nvPr/>
+            </p:nvSpPr>
+            <p:spPr>
+              <a:xfrm>
+                <a:off x="6245372" y="1598345"/>
+                <a:ext cx="3026982" cy="506870"/>
+              </a:xfrm>
+              <a:prstGeom prst="rect">
+                <a:avLst/>
+              </a:prstGeom>
+              <a:blipFill>
+                <a:blip r:embed="rId4"/>
+                <a:stretch>
+                  <a:fillRect/>
+                </a:stretch>
+              </a:blipFill>
+            </p:spPr>
+            <p:txBody>
+              <a:bodyPr/>
+              <a:lstStyle/>
+              <a:p>
+                <a:r>
+                  <a:rPr lang="fr-FR">
+                    <a:noFill/>
+                  </a:rPr>
+                  <a:t> </a:t>
+                </a:r>
+              </a:p>
+            </p:txBody>
+          </p:sp>
+        </mc:Fallback>
+      </mc:AlternateContent>
+      <p:sp>
+        <p:nvSpPr>
+          <p:cNvPr id="34" name="ZoneTexte 33">
+            <a:extLst>
+              <a:ext uri="{FF2B5EF4-FFF2-40B4-BE49-F238E27FC236}">
+                <a16:creationId xmlns:a16="http://schemas.microsoft.com/office/drawing/2014/main" id="{2E928A43-D245-4DD3-7C0D-49EE675CECEA}"/>
+              </a:ext>
+            </a:extLst>
+          </p:cNvPr>
+          <p:cNvSpPr txBox="1"/>
+          <p:nvPr/>
+        </p:nvSpPr>
+        <p:spPr>
+          <a:xfrm>
+            <a:off x="670633" y="857904"/>
+            <a:ext cx="678391" cy="369332"/>
+          </a:xfrm>
+          <a:prstGeom prst="rect">
+            <a:avLst/>
+          </a:prstGeom>
+          <a:noFill/>
+        </p:spPr>
+        <p:txBody>
+          <a:bodyPr wrap="none" rtlCol="0">
+            <a:spAutoFit/>
+          </a:bodyPr>
+          <a:lstStyle/>
+          <a:p>
+            <a:r>
+              <a:rPr lang="fr-FR" dirty="0"/>
+              <a:t>(0, 0)</a:t>
+            </a:r>
+          </a:p>
+        </p:txBody>
+      </p:sp>
+      <mc:AlternateContent xmlns:mc="http://schemas.openxmlformats.org/markup-compatibility/2006">
+        <mc:Choice xmlns:a14="http://schemas.microsoft.com/office/drawing/2010/main" Requires="a14">
+          <p:sp>
+            <p:nvSpPr>
+              <p:cNvPr id="36" name="ZoneTexte 35">
+                <a:extLst>
+                  <a:ext uri="{FF2B5EF4-FFF2-40B4-BE49-F238E27FC236}">
+                    <a16:creationId xmlns:a16="http://schemas.microsoft.com/office/drawing/2014/main" id="{0FD51302-DB17-797D-5416-C10DCC618984}"/>
+                  </a:ext>
+                </a:extLst>
+              </p:cNvPr>
+              <p:cNvSpPr txBox="1"/>
+              <p:nvPr/>
+            </p:nvSpPr>
+            <p:spPr>
+              <a:xfrm>
+                <a:off x="6062322" y="5571118"/>
+                <a:ext cx="1767663" cy="506870"/>
+              </a:xfrm>
+              <a:prstGeom prst="rect">
+                <a:avLst/>
+              </a:prstGeom>
+              <a:noFill/>
+            </p:spPr>
+            <p:txBody>
+              <a:bodyPr wrap="none" rtlCol="0">
+                <a:spAutoFit/>
+              </a:bodyPr>
+              <a:lstStyle/>
+              <a:p>
+                <a14:m>
+                  <m:oMath xmlns:m="http://schemas.openxmlformats.org/officeDocument/2006/math">
+                    <m:sSub>
+                      <m:sSubPr>
+                        <m:ctrlPr>
+                          <a:rPr lang="fr-FR" i="1" dirty="0" smtClean="0">
+                            <a:latin typeface="Cambria Math" panose="02040503050406030204" pitchFamily="18" charset="0"/>
+                          </a:rPr>
+                        </m:ctrlPr>
+                      </m:sSubPr>
+                      <m:e>
+                        <m:r>
+                          <a:rPr lang="fr-FR" b="0" i="1" dirty="0" smtClean="0">
+                            <a:latin typeface="Cambria Math" panose="02040503050406030204" pitchFamily="18" charset="0"/>
+                          </a:rPr>
+                          <m:t>𝐿</m:t>
+                        </m:r>
+                      </m:e>
+                      <m:sub>
+                        <m:r>
+                          <a:rPr lang="fr-FR" b="0" i="1" dirty="0" smtClean="0">
+                            <a:latin typeface="Cambria Math" panose="02040503050406030204" pitchFamily="18" charset="0"/>
+                          </a:rPr>
+                          <m:t>0</m:t>
+                        </m:r>
+                      </m:sub>
+                    </m:sSub>
+                  </m:oMath>
+                </a14:m>
+                <a:r>
+                  <a:rPr lang="fr-FR" dirty="0"/>
+                  <a:t> = </a:t>
+                </a:r>
+                <a14:m>
+                  <m:oMath xmlns:m="http://schemas.openxmlformats.org/officeDocument/2006/math">
+                    <m:r>
+                      <a:rPr lang="fr-FR" b="0" i="1" smtClean="0">
+                        <a:latin typeface="Cambria Math" panose="02040503050406030204" pitchFamily="18" charset="0"/>
+                      </a:rPr>
+                      <m:t>𝑎</m:t>
+                    </m:r>
+                    <m:r>
+                      <a:rPr lang="fr-FR" b="0" i="1" smtClean="0">
+                        <a:latin typeface="Cambria Math" panose="02040503050406030204" pitchFamily="18" charset="0"/>
+                      </a:rPr>
+                      <m:t> </m:t>
+                    </m:r>
+                    <m:r>
+                      <a:rPr lang="fr-FR" b="0" i="1" smtClean="0">
+                        <a:latin typeface="Cambria Math" panose="02040503050406030204" pitchFamily="18" charset="0"/>
+                      </a:rPr>
+                      <m:t>𝑠h</m:t>
+                    </m:r>
+                    <m:d>
+                      <m:dPr>
+                        <m:ctrlPr>
+                          <a:rPr lang="fr-FR" b="0" i="1" smtClean="0">
+                            <a:latin typeface="Cambria Math" panose="02040503050406030204" pitchFamily="18" charset="0"/>
+                          </a:rPr>
+                        </m:ctrlPr>
+                      </m:dPr>
+                      <m:e>
+                        <m:f>
+                          <m:fPr>
+                            <m:ctrlPr>
+                              <a:rPr lang="fr-FR" b="0" i="1" smtClean="0">
+                                <a:latin typeface="Cambria Math" panose="02040503050406030204" pitchFamily="18" charset="0"/>
+                              </a:rPr>
+                            </m:ctrlPr>
+                          </m:fPr>
+                          <m:num>
+                            <m:sSub>
+                              <m:sSubPr>
+                                <m:ctrlPr>
+                                  <a:rPr lang="fr-FR" b="0" i="1" smtClean="0">
+                                    <a:latin typeface="Cambria Math" panose="02040503050406030204" pitchFamily="18" charset="0"/>
+                                  </a:rPr>
+                                </m:ctrlPr>
+                              </m:sSubPr>
+                              <m:e>
+                                <m:r>
+                                  <a:rPr lang="fr-FR" b="0" i="1" smtClean="0">
+                                    <a:latin typeface="Cambria Math" panose="02040503050406030204" pitchFamily="18" charset="0"/>
+                                  </a:rPr>
+                                  <m:t>𝑥</m:t>
+                                </m:r>
+                              </m:e>
+                              <m:sub>
+                                <m:r>
+                                  <a:rPr lang="fr-FR" b="0" i="1" smtClean="0">
+                                    <a:latin typeface="Cambria Math" panose="02040503050406030204" pitchFamily="18" charset="0"/>
+                                  </a:rPr>
+                                  <m:t>𝑟𝑜𝑣</m:t>
+                                </m:r>
+                              </m:sub>
+                            </m:sSub>
+                            <m:r>
+                              <a:rPr lang="fr-FR" b="0" i="1" smtClean="0">
+                                <a:latin typeface="Cambria Math" panose="02040503050406030204" pitchFamily="18" charset="0"/>
+                              </a:rPr>
+                              <m:t> </m:t>
+                            </m:r>
+                          </m:num>
+                          <m:den>
+                            <m:r>
+                              <a:rPr lang="fr-FR" b="0" i="1" smtClean="0">
+                                <a:latin typeface="Cambria Math" panose="02040503050406030204" pitchFamily="18" charset="0"/>
+                              </a:rPr>
+                              <m:t>𝑎</m:t>
+                            </m:r>
+                          </m:den>
+                        </m:f>
+                      </m:e>
+                    </m:d>
+                  </m:oMath>
+                </a14:m>
+                <a:endParaRPr lang="fr-FR" dirty="0"/>
+              </a:p>
+            </p:txBody>
+          </p:sp>
+        </mc:Choice>
+        <mc:Fallback>
+          <p:sp>
+            <p:nvSpPr>
+              <p:cNvPr id="36" name="ZoneTexte 35">
+                <a:extLst>
+                  <a:ext uri="{FF2B5EF4-FFF2-40B4-BE49-F238E27FC236}">
+                    <a16:creationId xmlns:a16="http://schemas.microsoft.com/office/drawing/2014/main" id="{0FD51302-DB17-797D-5416-C10DCC618984}"/>
+                  </a:ext>
+                </a:extLst>
+              </p:cNvPr>
+              <p:cNvSpPr txBox="1">
+                <a:spLocks noRot="1" noChangeAspect="1" noMove="1" noResize="1" noEditPoints="1" noAdjustHandles="1" noChangeArrowheads="1" noChangeShapeType="1" noTextEdit="1"/>
+              </p:cNvSpPr>
+              <p:nvPr/>
+            </p:nvSpPr>
+            <p:spPr>
+              <a:xfrm>
+                <a:off x="6062322" y="5571118"/>
+                <a:ext cx="1767663" cy="506870"/>
+              </a:xfrm>
+              <a:prstGeom prst="rect">
+                <a:avLst/>
+              </a:prstGeom>
+              <a:blipFill>
+                <a:blip r:embed="rId5"/>
+                <a:stretch>
+                  <a:fillRect b="-7229"/>
+                </a:stretch>
+              </a:blipFill>
+            </p:spPr>
+            <p:txBody>
+              <a:bodyPr/>
+              <a:lstStyle/>
+              <a:p>
+                <a:r>
+                  <a:rPr lang="fr-FR">
+                    <a:noFill/>
+                  </a:rPr>
+                  <a:t> </a:t>
+                </a:r>
+              </a:p>
+            </p:txBody>
+          </p:sp>
+        </mc:Fallback>
+      </mc:AlternateContent>
+      <mc:AlternateContent xmlns:mc="http://schemas.openxmlformats.org/markup-compatibility/2006">
+        <mc:Choice xmlns:a14="http://schemas.microsoft.com/office/drawing/2010/main" Requires="a14">
+          <p:sp>
+            <p:nvSpPr>
+              <p:cNvPr id="37" name="ZoneTexte 36">
+                <a:extLst>
+                  <a:ext uri="{FF2B5EF4-FFF2-40B4-BE49-F238E27FC236}">
+                    <a16:creationId xmlns:a16="http://schemas.microsoft.com/office/drawing/2014/main" id="{0DE26614-3059-854E-70BE-7CE17BD434EB}"/>
+                  </a:ext>
+                </a:extLst>
+              </p:cNvPr>
+              <p:cNvSpPr txBox="1"/>
+              <p:nvPr/>
+            </p:nvSpPr>
+            <p:spPr>
+              <a:xfrm>
+                <a:off x="6062322" y="4878565"/>
+                <a:ext cx="2646494" cy="506870"/>
+              </a:xfrm>
+              <a:prstGeom prst="rect">
+                <a:avLst/>
+              </a:prstGeom>
+              <a:noFill/>
+            </p:spPr>
+            <p:txBody>
+              <a:bodyPr wrap="none" rtlCol="0">
+                <a:spAutoFit/>
+              </a:bodyPr>
+              <a:lstStyle/>
+              <a:p>
+                <a14:m>
+                  <m:oMath xmlns:m="http://schemas.openxmlformats.org/officeDocument/2006/math">
+                    <m:sSub>
+                      <m:sSubPr>
+                        <m:ctrlPr>
+                          <a:rPr lang="fr-FR" b="0" i="1" smtClean="0">
+                            <a:latin typeface="Cambria Math" panose="02040503050406030204" pitchFamily="18" charset="0"/>
+                          </a:rPr>
+                        </m:ctrlPr>
+                      </m:sSubPr>
+                      <m:e>
+                        <m:r>
+                          <a:rPr lang="fr-FR" b="0" i="1" smtClean="0">
+                            <a:latin typeface="Cambria Math" panose="02040503050406030204" pitchFamily="18" charset="0"/>
+                          </a:rPr>
+                          <m:t>𝑦</m:t>
+                        </m:r>
+                      </m:e>
+                      <m:sub>
+                        <m:r>
+                          <a:rPr lang="fr-FR" b="0" i="1" smtClean="0">
+                            <a:latin typeface="Cambria Math" panose="02040503050406030204" pitchFamily="18" charset="0"/>
+                          </a:rPr>
+                          <m:t>𝑟𝑜𝑣</m:t>
+                        </m:r>
+                      </m:sub>
+                    </m:sSub>
+                    <m:r>
+                      <a:rPr lang="fr-FR" b="0" i="1" smtClean="0">
+                        <a:latin typeface="Cambria Math" panose="02040503050406030204" pitchFamily="18" charset="0"/>
+                      </a:rPr>
+                      <m:t>=</m:t>
+                    </m:r>
+                    <m:r>
+                      <a:rPr lang="fr-FR" b="0" i="1" smtClean="0">
+                        <a:latin typeface="Cambria Math" panose="02040503050406030204" pitchFamily="18" charset="0"/>
+                      </a:rPr>
+                      <m:t>𝑎</m:t>
+                    </m:r>
+                  </m:oMath>
+                </a14:m>
+                <a:r>
+                  <a:rPr lang="fr-FR" dirty="0"/>
+                  <a:t> </a:t>
+                </a:r>
+                <a14:m>
+                  <m:oMath xmlns:m="http://schemas.openxmlformats.org/officeDocument/2006/math">
+                    <m:d>
+                      <m:dPr>
+                        <m:ctrlPr>
+                          <a:rPr lang="fr-FR" i="1" dirty="0" smtClean="0">
+                            <a:latin typeface="Cambria Math" panose="02040503050406030204" pitchFamily="18" charset="0"/>
+                          </a:rPr>
+                        </m:ctrlPr>
+                      </m:dPr>
+                      <m:e>
+                        <m:r>
+                          <a:rPr lang="fr-FR" i="1">
+                            <a:latin typeface="Cambria Math" panose="02040503050406030204" pitchFamily="18" charset="0"/>
+                          </a:rPr>
+                          <m:t>𝑐h</m:t>
+                        </m:r>
+                        <m:d>
+                          <m:dPr>
+                            <m:ctrlPr>
+                              <a:rPr lang="fr-FR" i="1">
+                                <a:latin typeface="Cambria Math" panose="02040503050406030204" pitchFamily="18" charset="0"/>
+                              </a:rPr>
+                            </m:ctrlPr>
+                          </m:dPr>
+                          <m:e>
+                            <m:f>
+                              <m:fPr>
+                                <m:ctrlPr>
+                                  <a:rPr lang="fr-FR" i="1">
+                                    <a:latin typeface="Cambria Math" panose="02040503050406030204" pitchFamily="18" charset="0"/>
+                                  </a:rPr>
+                                </m:ctrlPr>
+                              </m:fPr>
+                              <m:num>
+                                <m:sSub>
+                                  <m:sSubPr>
+                                    <m:ctrlPr>
+                                      <a:rPr lang="fr-FR" i="1">
+                                        <a:latin typeface="Cambria Math" panose="02040503050406030204" pitchFamily="18" charset="0"/>
+                                      </a:rPr>
+                                    </m:ctrlPr>
+                                  </m:sSubPr>
+                                  <m:e>
+                                    <m:r>
+                                      <a:rPr lang="fr-FR" i="1">
+                                        <a:latin typeface="Cambria Math" panose="02040503050406030204" pitchFamily="18" charset="0"/>
+                                      </a:rPr>
+                                      <m:t>𝑥</m:t>
+                                    </m:r>
+                                  </m:e>
+                                  <m:sub>
+                                    <m:r>
+                                      <a:rPr lang="fr-FR" i="1">
+                                        <a:latin typeface="Cambria Math" panose="02040503050406030204" pitchFamily="18" charset="0"/>
+                                      </a:rPr>
+                                      <m:t>𝑟𝑜𝑣</m:t>
+                                    </m:r>
+                                  </m:sub>
+                                </m:sSub>
+                                <m:r>
+                                  <a:rPr lang="fr-FR" i="1">
+                                    <a:latin typeface="Cambria Math" panose="02040503050406030204" pitchFamily="18" charset="0"/>
+                                  </a:rPr>
+                                  <m:t> </m:t>
+                                </m:r>
+                              </m:num>
+                              <m:den>
+                                <m:r>
+                                  <a:rPr lang="fr-FR" i="1">
+                                    <a:latin typeface="Cambria Math" panose="02040503050406030204" pitchFamily="18" charset="0"/>
+                                  </a:rPr>
+                                  <m:t>𝑎</m:t>
+                                </m:r>
+                              </m:den>
+                            </m:f>
+                          </m:e>
+                        </m:d>
+                        <m:r>
+                          <a:rPr lang="fr-FR" b="0" i="1" smtClean="0">
+                            <a:latin typeface="Cambria Math" panose="02040503050406030204" pitchFamily="18" charset="0"/>
+                          </a:rPr>
+                          <m:t> −1</m:t>
+                        </m:r>
+                      </m:e>
+                    </m:d>
+                  </m:oMath>
+                </a14:m>
+                <a:endParaRPr lang="fr-FR" dirty="0"/>
+              </a:p>
+            </p:txBody>
+          </p:sp>
+        </mc:Choice>
+        <mc:Fallback>
+          <p:sp>
+            <p:nvSpPr>
+              <p:cNvPr id="37" name="ZoneTexte 36">
+                <a:extLst>
+                  <a:ext uri="{FF2B5EF4-FFF2-40B4-BE49-F238E27FC236}">
+                    <a16:creationId xmlns:a16="http://schemas.microsoft.com/office/drawing/2014/main" id="{0DE26614-3059-854E-70BE-7CE17BD434EB}"/>
+                  </a:ext>
+                </a:extLst>
+              </p:cNvPr>
+              <p:cNvSpPr txBox="1">
+                <a:spLocks noRot="1" noChangeAspect="1" noMove="1" noResize="1" noEditPoints="1" noAdjustHandles="1" noChangeArrowheads="1" noChangeShapeType="1" noTextEdit="1"/>
+              </p:cNvSpPr>
+              <p:nvPr/>
+            </p:nvSpPr>
+            <p:spPr>
+              <a:xfrm>
+                <a:off x="6062322" y="4878565"/>
+                <a:ext cx="2646494" cy="506870"/>
+              </a:xfrm>
+              <a:prstGeom prst="rect">
+                <a:avLst/>
+              </a:prstGeom>
+              <a:blipFill>
+                <a:blip r:embed="rId6"/>
+                <a:stretch>
+                  <a:fillRect/>
+                </a:stretch>
+              </a:blipFill>
+            </p:spPr>
+            <p:txBody>
+              <a:bodyPr/>
+              <a:lstStyle/>
+              <a:p>
+                <a:r>
+                  <a:rPr lang="fr-FR">
+                    <a:noFill/>
+                  </a:rPr>
+                  <a:t> </a:t>
+                </a:r>
+              </a:p>
+            </p:txBody>
+          </p:sp>
+        </mc:Fallback>
+      </mc:AlternateContent>
+      <mc:AlternateContent xmlns:mc="http://schemas.openxmlformats.org/markup-compatibility/2006">
+        <mc:Choice xmlns:a14="http://schemas.microsoft.com/office/drawing/2010/main" Requires="a14">
+          <p:sp>
+            <p:nvSpPr>
+              <p:cNvPr id="38" name="ZoneTexte 37">
+                <a:extLst>
+                  <a:ext uri="{FF2B5EF4-FFF2-40B4-BE49-F238E27FC236}">
+                    <a16:creationId xmlns:a16="http://schemas.microsoft.com/office/drawing/2014/main" id="{C554837C-1454-A045-A0BC-A7063C6F2F1C}"/>
+                  </a:ext>
+                </a:extLst>
+              </p:cNvPr>
+              <p:cNvSpPr txBox="1"/>
+              <p:nvPr/>
+            </p:nvSpPr>
+            <p:spPr>
+              <a:xfrm>
+                <a:off x="6245372" y="3017529"/>
+                <a:ext cx="3082767" cy="509050"/>
+              </a:xfrm>
+              <a:prstGeom prst="rect">
+                <a:avLst/>
+              </a:prstGeom>
+              <a:noFill/>
+            </p:spPr>
+            <p:txBody>
+              <a:bodyPr wrap="none" lIns="0" tIns="0" rIns="0" bIns="0" rtlCol="0">
+                <a:spAutoFit/>
+              </a:bodyPr>
+              <a:lstStyle/>
+              <a:p>
+                <a14:m>
+                  <m:oMathPara xmlns:m="http://schemas.openxmlformats.org/officeDocument/2006/math">
+                    <m:oMathParaPr>
+                      <m:jc m:val="centerGroup"/>
+                    </m:oMathParaPr>
+                    <m:oMath xmlns:m="http://schemas.openxmlformats.org/officeDocument/2006/math">
+                      <m:r>
+                        <a:rPr lang="fr-FR" b="0" i="1" smtClean="0">
+                          <a:latin typeface="Cambria Math" panose="02040503050406030204" pitchFamily="18" charset="0"/>
+                        </a:rPr>
+                        <m:t>𝑎𝑐h</m:t>
+                      </m:r>
+                      <m:d>
+                        <m:dPr>
+                          <m:ctrlPr>
+                            <a:rPr lang="fr-FR" b="0" i="1" smtClean="0">
+                              <a:latin typeface="Cambria Math" panose="02040503050406030204" pitchFamily="18" charset="0"/>
+                            </a:rPr>
+                          </m:ctrlPr>
+                        </m:dPr>
+                        <m:e>
+                          <m:f>
+                            <m:fPr>
+                              <m:ctrlPr>
+                                <a:rPr lang="fr-FR" i="1">
+                                  <a:latin typeface="Cambria Math" panose="02040503050406030204" pitchFamily="18" charset="0"/>
+                                </a:rPr>
+                              </m:ctrlPr>
+                            </m:fPr>
+                            <m:num>
+                              <m:sSub>
+                                <m:sSubPr>
+                                  <m:ctrlPr>
+                                    <a:rPr lang="fr-FR" i="1">
+                                      <a:latin typeface="Cambria Math" panose="02040503050406030204" pitchFamily="18" charset="0"/>
+                                    </a:rPr>
+                                  </m:ctrlPr>
+                                </m:sSubPr>
+                                <m:e>
+                                  <m:r>
+                                    <a:rPr lang="fr-FR" i="1">
+                                      <a:latin typeface="Cambria Math" panose="02040503050406030204" pitchFamily="18" charset="0"/>
+                                    </a:rPr>
+                                    <m:t>𝑦</m:t>
+                                  </m:r>
+                                </m:e>
+                                <m:sub>
+                                  <m:r>
+                                    <a:rPr lang="fr-FR" i="1">
+                                      <a:latin typeface="Cambria Math" panose="02040503050406030204" pitchFamily="18" charset="0"/>
+                                    </a:rPr>
+                                    <m:t>𝑟𝑜𝑣</m:t>
+                                  </m:r>
+                                </m:sub>
+                              </m:sSub>
+                              <m:r>
+                                <a:rPr lang="fr-FR" b="0" i="1" smtClean="0">
+                                  <a:latin typeface="Cambria Math" panose="02040503050406030204" pitchFamily="18" charset="0"/>
+                                </a:rPr>
+                                <m:t>+</m:t>
+                              </m:r>
+                              <m:r>
+                                <a:rPr lang="fr-FR" i="1">
+                                  <a:latin typeface="Cambria Math" panose="02040503050406030204" pitchFamily="18" charset="0"/>
+                                </a:rPr>
+                                <m:t>𝑎</m:t>
+                              </m:r>
+                            </m:num>
+                            <m:den>
+                              <m:r>
+                                <a:rPr lang="fr-FR" i="1">
+                                  <a:latin typeface="Cambria Math" panose="02040503050406030204" pitchFamily="18" charset="0"/>
+                                </a:rPr>
+                                <m:t>𝑎</m:t>
+                              </m:r>
+                            </m:den>
+                          </m:f>
+                        </m:e>
+                      </m:d>
+                      <m:r>
+                        <a:rPr lang="fr-FR" b="0" i="1" smtClean="0">
+                          <a:latin typeface="Cambria Math" panose="02040503050406030204" pitchFamily="18" charset="0"/>
+                        </a:rPr>
+                        <m:t>=</m:t>
+                      </m:r>
+                      <m:d>
+                        <m:dPr>
+                          <m:ctrlPr>
+                            <a:rPr lang="fr-FR" i="1">
+                              <a:latin typeface="Cambria Math" panose="02040503050406030204" pitchFamily="18" charset="0"/>
+                            </a:rPr>
+                          </m:ctrlPr>
+                        </m:dPr>
+                        <m:e>
+                          <m:f>
+                            <m:fPr>
+                              <m:ctrlPr>
+                                <a:rPr lang="fr-FR" i="1">
+                                  <a:latin typeface="Cambria Math" panose="02040503050406030204" pitchFamily="18" charset="0"/>
+                                </a:rPr>
+                              </m:ctrlPr>
+                            </m:fPr>
+                            <m:num>
+                              <m:sSub>
+                                <m:sSubPr>
+                                  <m:ctrlPr>
+                                    <a:rPr lang="fr-FR" i="1">
+                                      <a:latin typeface="Cambria Math" panose="02040503050406030204" pitchFamily="18" charset="0"/>
+                                    </a:rPr>
+                                  </m:ctrlPr>
+                                </m:sSubPr>
+                                <m:e>
+                                  <m:r>
+                                    <a:rPr lang="fr-FR" i="1">
+                                      <a:latin typeface="Cambria Math" panose="02040503050406030204" pitchFamily="18" charset="0"/>
+                                    </a:rPr>
+                                    <m:t>𝑥</m:t>
+                                  </m:r>
+                                </m:e>
+                                <m:sub>
+                                  <m:r>
+                                    <a:rPr lang="fr-FR" i="1">
+                                      <a:latin typeface="Cambria Math" panose="02040503050406030204" pitchFamily="18" charset="0"/>
+                                    </a:rPr>
+                                    <m:t>𝑟𝑜𝑣</m:t>
+                                  </m:r>
+                                </m:sub>
+                              </m:sSub>
+                              <m:r>
+                                <a:rPr lang="fr-FR" i="1">
+                                  <a:latin typeface="Cambria Math" panose="02040503050406030204" pitchFamily="18" charset="0"/>
+                                </a:rPr>
+                                <m:t> − </m:t>
+                              </m:r>
+                              <m:sSub>
+                                <m:sSubPr>
+                                  <m:ctrlPr>
+                                    <a:rPr lang="fr-FR" i="1">
+                                      <a:latin typeface="Cambria Math" panose="02040503050406030204" pitchFamily="18" charset="0"/>
+                                    </a:rPr>
+                                  </m:ctrlPr>
+                                </m:sSubPr>
+                                <m:e>
+                                  <m:r>
+                                    <a:rPr lang="fr-FR" i="1">
+                                      <a:latin typeface="Cambria Math" panose="02040503050406030204" pitchFamily="18" charset="0"/>
+                                    </a:rPr>
+                                    <m:t>𝑥</m:t>
+                                  </m:r>
+                                </m:e>
+                                <m:sub>
+                                  <m:r>
+                                    <a:rPr lang="fr-FR" i="1">
+                                      <a:latin typeface="Cambria Math" panose="02040503050406030204" pitchFamily="18" charset="0"/>
+                                    </a:rPr>
+                                    <m:t>𝐻</m:t>
+                                  </m:r>
+                                </m:sub>
+                              </m:sSub>
+                            </m:num>
+                            <m:den>
+                              <m:r>
+                                <a:rPr lang="fr-FR" i="1">
+                                  <a:latin typeface="Cambria Math" panose="02040503050406030204" pitchFamily="18" charset="0"/>
+                                </a:rPr>
+                                <m:t>𝑎</m:t>
+                              </m:r>
+                            </m:den>
+                          </m:f>
+                        </m:e>
+                      </m:d>
+                    </m:oMath>
+                  </m:oMathPara>
+                </a14:m>
+                <a:endParaRPr lang="fr-FR" dirty="0"/>
+              </a:p>
+            </p:txBody>
+          </p:sp>
+        </mc:Choice>
+        <mc:Fallback>
+          <p:sp>
+            <p:nvSpPr>
+              <p:cNvPr id="38" name="ZoneTexte 37">
+                <a:extLst>
+                  <a:ext uri="{FF2B5EF4-FFF2-40B4-BE49-F238E27FC236}">
+                    <a16:creationId xmlns:a16="http://schemas.microsoft.com/office/drawing/2014/main" id="{C554837C-1454-A045-A0BC-A7063C6F2F1C}"/>
+                  </a:ext>
+                </a:extLst>
+              </p:cNvPr>
+              <p:cNvSpPr txBox="1">
+                <a:spLocks noRot="1" noChangeAspect="1" noMove="1" noResize="1" noEditPoints="1" noAdjustHandles="1" noChangeArrowheads="1" noChangeShapeType="1" noTextEdit="1"/>
+              </p:cNvSpPr>
+              <p:nvPr/>
+            </p:nvSpPr>
+            <p:spPr>
+              <a:xfrm>
+                <a:off x="6245372" y="3017529"/>
+                <a:ext cx="3082767" cy="509050"/>
+              </a:xfrm>
+              <a:prstGeom prst="rect">
+                <a:avLst/>
+              </a:prstGeom>
+              <a:blipFill>
+                <a:blip r:embed="rId7"/>
+                <a:stretch>
+                  <a:fillRect/>
+                </a:stretch>
+              </a:blipFill>
+            </p:spPr>
+            <p:txBody>
+              <a:bodyPr/>
+              <a:lstStyle/>
+              <a:p>
+                <a:r>
+                  <a:rPr lang="fr-FR">
+                    <a:noFill/>
+                  </a:rPr>
+                  <a:t> </a:t>
+                </a:r>
+              </a:p>
+            </p:txBody>
+          </p:sp>
+        </mc:Fallback>
+      </mc:AlternateContent>
+      <mc:AlternateContent xmlns:mc="http://schemas.openxmlformats.org/markup-compatibility/2006">
+        <mc:Choice xmlns:a14="http://schemas.microsoft.com/office/drawing/2010/main" Requires="a14">
+          <p:sp>
+            <p:nvSpPr>
+              <p:cNvPr id="39" name="ZoneTexte 38">
+                <a:extLst>
+                  <a:ext uri="{FF2B5EF4-FFF2-40B4-BE49-F238E27FC236}">
+                    <a16:creationId xmlns:a16="http://schemas.microsoft.com/office/drawing/2014/main" id="{1B091DF7-045E-882D-BB88-5EF5AF9DE3B6}"/>
+                  </a:ext>
+                </a:extLst>
+              </p:cNvPr>
+              <p:cNvSpPr txBox="1"/>
+              <p:nvPr/>
+            </p:nvSpPr>
+            <p:spPr>
+              <a:xfrm>
+                <a:off x="6245372" y="3616747"/>
+                <a:ext cx="3099310" cy="509050"/>
+              </a:xfrm>
+              <a:prstGeom prst="rect">
+                <a:avLst/>
+              </a:prstGeom>
+              <a:noFill/>
+            </p:spPr>
+            <p:txBody>
+              <a:bodyPr wrap="none" lIns="0" tIns="0" rIns="0" bIns="0" rtlCol="0">
+                <a:spAutoFit/>
+              </a:bodyPr>
+              <a:lstStyle/>
+              <a:p>
+                <a14:m>
+                  <m:oMathPara xmlns:m="http://schemas.openxmlformats.org/officeDocument/2006/math">
+                    <m:oMathParaPr>
+                      <m:jc m:val="centerGroup"/>
+                    </m:oMathParaPr>
+                    <m:oMath xmlns:m="http://schemas.openxmlformats.org/officeDocument/2006/math">
+                      <m:sSub>
+                        <m:sSubPr>
+                          <m:ctrlPr>
+                            <a:rPr lang="fr-FR" b="0" i="1" smtClean="0">
+                              <a:latin typeface="Cambria Math" panose="02040503050406030204" pitchFamily="18" charset="0"/>
+                            </a:rPr>
+                          </m:ctrlPr>
+                        </m:sSubPr>
+                        <m:e>
+                          <m:r>
+                            <a:rPr lang="fr-FR" b="0" i="1" smtClean="0">
+                              <a:latin typeface="Cambria Math" panose="02040503050406030204" pitchFamily="18" charset="0"/>
+                            </a:rPr>
+                            <m:t>𝑥</m:t>
+                          </m:r>
+                        </m:e>
+                        <m:sub>
+                          <m:r>
+                            <a:rPr lang="fr-FR" b="0" i="1" smtClean="0">
+                              <a:latin typeface="Cambria Math" panose="02040503050406030204" pitchFamily="18" charset="0"/>
+                            </a:rPr>
+                            <m:t>𝑟𝑜𝑣</m:t>
+                          </m:r>
+                        </m:sub>
+                      </m:sSub>
+                      <m:r>
+                        <a:rPr lang="fr-FR" b="0" i="1" smtClean="0">
+                          <a:latin typeface="Cambria Math" panose="02040503050406030204" pitchFamily="18" charset="0"/>
+                        </a:rPr>
+                        <m:t>−</m:t>
+                      </m:r>
+                      <m:r>
+                        <a:rPr lang="fr-FR" b="0" i="1" smtClean="0">
+                          <a:latin typeface="Cambria Math" panose="02040503050406030204" pitchFamily="18" charset="0"/>
+                        </a:rPr>
+                        <m:t>𝑎</m:t>
+                      </m:r>
+                      <m:r>
+                        <a:rPr lang="fr-FR" b="0" i="1" smtClean="0">
+                          <a:latin typeface="Cambria Math" panose="02040503050406030204" pitchFamily="18" charset="0"/>
+                        </a:rPr>
+                        <m:t> </m:t>
+                      </m:r>
+                      <m:r>
+                        <a:rPr lang="fr-FR" b="0" i="1" smtClean="0">
+                          <a:latin typeface="Cambria Math" panose="02040503050406030204" pitchFamily="18" charset="0"/>
+                        </a:rPr>
+                        <m:t>𝑎𝑐h</m:t>
+                      </m:r>
+                      <m:d>
+                        <m:dPr>
+                          <m:ctrlPr>
+                            <a:rPr lang="fr-FR" b="0" i="1" smtClean="0">
+                              <a:latin typeface="Cambria Math" panose="02040503050406030204" pitchFamily="18" charset="0"/>
+                            </a:rPr>
+                          </m:ctrlPr>
+                        </m:dPr>
+                        <m:e>
+                          <m:f>
+                            <m:fPr>
+                              <m:ctrlPr>
+                                <a:rPr lang="fr-FR" i="1">
+                                  <a:latin typeface="Cambria Math" panose="02040503050406030204" pitchFamily="18" charset="0"/>
+                                </a:rPr>
+                              </m:ctrlPr>
+                            </m:fPr>
+                            <m:num>
+                              <m:sSub>
+                                <m:sSubPr>
+                                  <m:ctrlPr>
+                                    <a:rPr lang="fr-FR" i="1">
+                                      <a:latin typeface="Cambria Math" panose="02040503050406030204" pitchFamily="18" charset="0"/>
+                                    </a:rPr>
+                                  </m:ctrlPr>
+                                </m:sSubPr>
+                                <m:e>
+                                  <m:r>
+                                    <a:rPr lang="fr-FR" i="1">
+                                      <a:latin typeface="Cambria Math" panose="02040503050406030204" pitchFamily="18" charset="0"/>
+                                    </a:rPr>
+                                    <m:t>𝑦</m:t>
+                                  </m:r>
+                                </m:e>
+                                <m:sub>
+                                  <m:r>
+                                    <a:rPr lang="fr-FR" i="1">
+                                      <a:latin typeface="Cambria Math" panose="02040503050406030204" pitchFamily="18" charset="0"/>
+                                    </a:rPr>
+                                    <m:t>𝑟𝑜𝑣</m:t>
+                                  </m:r>
+                                </m:sub>
+                              </m:sSub>
+                              <m:r>
+                                <a:rPr lang="fr-FR" b="0" i="1" smtClean="0">
+                                  <a:latin typeface="Cambria Math" panose="02040503050406030204" pitchFamily="18" charset="0"/>
+                                </a:rPr>
+                                <m:t>+</m:t>
+                              </m:r>
+                              <m:r>
+                                <a:rPr lang="fr-FR" i="1">
+                                  <a:latin typeface="Cambria Math" panose="02040503050406030204" pitchFamily="18" charset="0"/>
+                                </a:rPr>
+                                <m:t>𝑎</m:t>
+                              </m:r>
+                            </m:num>
+                            <m:den>
+                              <m:r>
+                                <a:rPr lang="fr-FR" i="1">
+                                  <a:latin typeface="Cambria Math" panose="02040503050406030204" pitchFamily="18" charset="0"/>
+                                </a:rPr>
+                                <m:t>𝑎</m:t>
+                              </m:r>
+                            </m:den>
+                          </m:f>
+                        </m:e>
+                      </m:d>
+                      <m:r>
+                        <a:rPr lang="fr-FR" b="0" i="1" smtClean="0">
+                          <a:latin typeface="Cambria Math" panose="02040503050406030204" pitchFamily="18" charset="0"/>
+                        </a:rPr>
+                        <m:t>= </m:t>
+                      </m:r>
+                      <m:sSub>
+                        <m:sSubPr>
+                          <m:ctrlPr>
+                            <a:rPr lang="fr-FR" b="0" i="1" smtClean="0">
+                              <a:latin typeface="Cambria Math" panose="02040503050406030204" pitchFamily="18" charset="0"/>
+                            </a:rPr>
+                          </m:ctrlPr>
+                        </m:sSubPr>
+                        <m:e>
+                          <m:r>
+                            <a:rPr lang="fr-FR" b="0" i="1" smtClean="0">
+                              <a:latin typeface="Cambria Math" panose="02040503050406030204" pitchFamily="18" charset="0"/>
+                            </a:rPr>
+                            <m:t>𝑥</m:t>
+                          </m:r>
+                        </m:e>
+                        <m:sub>
+                          <m:r>
+                            <a:rPr lang="fr-FR" b="0" i="1" smtClean="0">
+                              <a:latin typeface="Cambria Math" panose="02040503050406030204" pitchFamily="18" charset="0"/>
+                            </a:rPr>
+                            <m:t>𝐻</m:t>
+                          </m:r>
+                        </m:sub>
+                      </m:sSub>
+                    </m:oMath>
+                  </m:oMathPara>
+                </a14:m>
+                <a:endParaRPr lang="fr-FR" dirty="0"/>
+              </a:p>
+            </p:txBody>
+          </p:sp>
+        </mc:Choice>
+        <mc:Fallback>
+          <p:sp>
+            <p:nvSpPr>
+              <p:cNvPr id="39" name="ZoneTexte 38">
+                <a:extLst>
+                  <a:ext uri="{FF2B5EF4-FFF2-40B4-BE49-F238E27FC236}">
+                    <a16:creationId xmlns:a16="http://schemas.microsoft.com/office/drawing/2014/main" id="{1B091DF7-045E-882D-BB88-5EF5AF9DE3B6}"/>
+                  </a:ext>
+                </a:extLst>
+              </p:cNvPr>
+              <p:cNvSpPr txBox="1">
+                <a:spLocks noRot="1" noChangeAspect="1" noMove="1" noResize="1" noEditPoints="1" noAdjustHandles="1" noChangeArrowheads="1" noChangeShapeType="1" noTextEdit="1"/>
+              </p:cNvSpPr>
+              <p:nvPr/>
+            </p:nvSpPr>
+            <p:spPr>
+              <a:xfrm>
+                <a:off x="6245372" y="3616747"/>
+                <a:ext cx="3099310" cy="509050"/>
+              </a:xfrm>
+              <a:prstGeom prst="rect">
+                <a:avLst/>
+              </a:prstGeom>
+              <a:blipFill>
+                <a:blip r:embed="rId8"/>
+                <a:stretch>
+                  <a:fillRect/>
+                </a:stretch>
+              </a:blipFill>
+            </p:spPr>
+            <p:txBody>
+              <a:bodyPr/>
+              <a:lstStyle/>
+              <a:p>
+                <a:r>
+                  <a:rPr lang="fr-FR">
+                    <a:noFill/>
+                  </a:rPr>
+                  <a:t> </a:t>
+                </a:r>
+              </a:p>
+            </p:txBody>
+          </p:sp>
+        </mc:Fallback>
+      </mc:AlternateContent>
+    </p:spTree>
+    <p:extLst>
+      <p:ext uri="{BB962C8B-B14F-4D97-AF65-F5344CB8AC3E}">
+        <p14:creationId xmlns:p14="http://schemas.microsoft.com/office/powerpoint/2010/main" val="466176374"/>
+      </p:ext>
+    </p:extLst>
+  </p:cSld>
+  <p:clrMapOvr>
+    <a:masterClrMapping/>
+  </p:clrMapOvr>
+</p:sld>
+</file>
+
+<file path=ppt/slides/slide3.xml><?xml version="1.0" encoding="utf-8"?>
+<p:sld xmlns:a="http://schemas.openxmlformats.org/drawingml/2006/main" xmlns:r="http://schemas.openxmlformats.org/officeDocument/2006/relationships" xmlns:p="http://schemas.openxmlformats.org/presentationml/2006/main">
+  <p:cSld>
+    <p:spTree>
+      <p:nvGrpSpPr>
+        <p:cNvPr id="1" name="">
+          <a:extLst>
+            <a:ext uri="{FF2B5EF4-FFF2-40B4-BE49-F238E27FC236}">
+              <a16:creationId xmlns:a16="http://schemas.microsoft.com/office/drawing/2014/main" id="{95C75343-6E10-1FE1-5C53-6F945898ADA6}"/>
+            </a:ext>
+          </a:extLst>
+        </p:cNvPr>
+        <p:cNvGrpSpPr/>
+        <p:nvPr/>
+      </p:nvGrpSpPr>
+      <p:grpSpPr>
+        <a:xfrm>
+          <a:off x="0" y="0"/>
+          <a:ext cx="0" cy="0"/>
+          <a:chOff x="0" y="0"/>
+          <a:chExt cx="0" cy="0"/>
+        </a:xfrm>
+      </p:grpSpPr>
+      <mc:AlternateContent xmlns:mc="http://schemas.openxmlformats.org/markup-compatibility/2006">
+        <mc:Choice xmlns:a14="http://schemas.microsoft.com/office/drawing/2010/main" Requires="a14">
+          <p:sp>
+            <p:nvSpPr>
+              <p:cNvPr id="30" name="ZoneTexte 29">
+                <a:extLst>
+                  <a:ext uri="{FF2B5EF4-FFF2-40B4-BE49-F238E27FC236}">
+                    <a16:creationId xmlns:a16="http://schemas.microsoft.com/office/drawing/2014/main" id="{76E76206-519F-0CE4-FF47-2039FE295BDB}"/>
+                  </a:ext>
+                </a:extLst>
+              </p:cNvPr>
+              <p:cNvSpPr txBox="1"/>
+              <p:nvPr/>
+            </p:nvSpPr>
+            <p:spPr>
+              <a:xfrm>
+                <a:off x="7006546" y="1033083"/>
+                <a:ext cx="5097741" cy="566694"/>
+              </a:xfrm>
+              <a:prstGeom prst="rect">
+                <a:avLst/>
+              </a:prstGeom>
+              <a:noFill/>
+            </p:spPr>
+            <p:txBody>
+              <a:bodyPr wrap="none" rtlCol="0">
+                <a:spAutoFit/>
+              </a:bodyPr>
+              <a:lstStyle/>
+              <a:p>
+                <a14:m>
+                  <m:oMathPara xmlns:m="http://schemas.openxmlformats.org/officeDocument/2006/math">
+                    <m:oMathParaPr>
+                      <m:jc m:val="centerGroup"/>
+                    </m:oMathParaPr>
+                    <m:oMath xmlns:m="http://schemas.openxmlformats.org/officeDocument/2006/math">
+                      <m:r>
+                        <a:rPr lang="fr-FR" b="0" i="1" smtClean="0">
+                          <a:latin typeface="Cambria Math" panose="02040503050406030204" pitchFamily="18" charset="0"/>
+                        </a:rPr>
+                        <m:t>𝑃𝑜𝑢𝑟</m:t>
+                      </m:r>
+                      <m:r>
+                        <a:rPr lang="fr-FR" b="0" i="1" smtClean="0">
+                          <a:latin typeface="Cambria Math" panose="02040503050406030204" pitchFamily="18" charset="0"/>
+                        </a:rPr>
+                        <m:t> </m:t>
+                      </m:r>
+                      <m:sSub>
+                        <m:sSubPr>
+                          <m:ctrlPr>
+                            <a:rPr lang="fr-FR" b="0" i="1" smtClean="0">
+                              <a:latin typeface="Cambria Math" panose="02040503050406030204" pitchFamily="18" charset="0"/>
+                            </a:rPr>
+                          </m:ctrlPr>
+                        </m:sSubPr>
+                        <m:e>
+                          <m:r>
+                            <a:rPr lang="fr-FR" b="0" i="1" smtClean="0">
+                              <a:latin typeface="Cambria Math" panose="02040503050406030204" pitchFamily="18" charset="0"/>
+                            </a:rPr>
+                            <m:t>𝑥</m:t>
+                          </m:r>
+                        </m:e>
+                        <m:sub>
+                          <m:r>
+                            <a:rPr lang="fr-FR" b="0" i="1" smtClean="0">
+                              <a:latin typeface="Cambria Math" panose="02040503050406030204" pitchFamily="18" charset="0"/>
+                            </a:rPr>
+                            <m:t>𝐻</m:t>
+                          </m:r>
+                        </m:sub>
+                      </m:sSub>
+                      <m:r>
+                        <a:rPr lang="fr-FR" b="0" i="1" smtClean="0">
+                          <a:latin typeface="Cambria Math" panose="02040503050406030204" pitchFamily="18" charset="0"/>
+                        </a:rPr>
+                        <m:t>≤  </m:t>
+                      </m:r>
+                      <m:r>
+                        <a:rPr lang="fr-FR" b="0" i="1" smtClean="0">
+                          <a:latin typeface="Cambria Math" panose="02040503050406030204" pitchFamily="18" charset="0"/>
+                        </a:rPr>
+                        <m:t>𝑥</m:t>
+                      </m:r>
+                      <m:r>
+                        <a:rPr lang="fr-FR" b="0" i="1" smtClean="0">
+                          <a:latin typeface="Cambria Math" panose="02040503050406030204" pitchFamily="18" charset="0"/>
+                        </a:rPr>
+                        <m:t> ≤ </m:t>
+                      </m:r>
+                      <m:sSub>
+                        <m:sSubPr>
+                          <m:ctrlPr>
+                            <a:rPr lang="fr-FR" b="0" i="1" smtClean="0">
+                              <a:latin typeface="Cambria Math" panose="02040503050406030204" pitchFamily="18" charset="0"/>
+                            </a:rPr>
+                          </m:ctrlPr>
+                        </m:sSubPr>
+                        <m:e>
+                          <m:r>
+                            <a:rPr lang="fr-FR" b="0" i="1" smtClean="0">
+                              <a:latin typeface="Cambria Math" panose="02040503050406030204" pitchFamily="18" charset="0"/>
+                            </a:rPr>
+                            <m:t>𝑥</m:t>
+                          </m:r>
+                        </m:e>
+                        <m:sub>
+                          <m:r>
+                            <a:rPr lang="fr-FR" b="0" i="1" smtClean="0">
+                              <a:latin typeface="Cambria Math" panose="02040503050406030204" pitchFamily="18" charset="0"/>
+                            </a:rPr>
+                            <m:t>𝑟𝑜𝑣</m:t>
+                          </m:r>
+                        </m:sub>
+                      </m:sSub>
+                      <m:r>
+                        <a:rPr lang="fr-FR" b="0" i="1" smtClean="0">
+                          <a:latin typeface="Cambria Math" panose="02040503050406030204" pitchFamily="18" charset="0"/>
+                        </a:rPr>
+                        <m:t> :</m:t>
+                      </m:r>
+                      <m:r>
+                        <a:rPr lang="fr-FR" b="0" i="1" smtClean="0">
+                          <a:latin typeface="Cambria Math" panose="02040503050406030204" pitchFamily="18" charset="0"/>
+                        </a:rPr>
+                        <m:t>𝑦</m:t>
+                      </m:r>
+                      <m:r>
+                        <a:rPr lang="fr-FR" b="0" i="1" smtClean="0">
+                          <a:latin typeface="Cambria Math" panose="02040503050406030204" pitchFamily="18" charset="0"/>
+                        </a:rPr>
+                        <m:t>=</m:t>
+                      </m:r>
+                      <m:sSub>
+                        <m:sSubPr>
+                          <m:ctrlPr>
+                            <a:rPr lang="fr-FR" b="0" i="1" smtClean="0">
+                              <a:latin typeface="Cambria Math" panose="02040503050406030204" pitchFamily="18" charset="0"/>
+                            </a:rPr>
+                          </m:ctrlPr>
+                        </m:sSubPr>
+                        <m:e>
+                          <m:r>
+                            <a:rPr lang="fr-FR" b="0" i="1" smtClean="0">
+                              <a:latin typeface="Cambria Math" panose="02040503050406030204" pitchFamily="18" charset="0"/>
+                            </a:rPr>
+                            <m:t>𝑦</m:t>
+                          </m:r>
+                        </m:e>
+                        <m:sub>
+                          <m:r>
+                            <a:rPr lang="fr-FR" b="0" i="1" smtClean="0">
+                              <a:latin typeface="Cambria Math" panose="02040503050406030204" pitchFamily="18" charset="0"/>
+                            </a:rPr>
+                            <m:t>𝐻</m:t>
+                          </m:r>
+                        </m:sub>
+                      </m:sSub>
+                      <m:r>
+                        <a:rPr lang="fr-FR" b="0" i="1" smtClean="0">
+                          <a:latin typeface="Cambria Math" panose="02040503050406030204" pitchFamily="18" charset="0"/>
+                        </a:rPr>
+                        <m:t>+ </m:t>
+                      </m:r>
+                      <m:r>
+                        <a:rPr lang="fr-FR" b="0" i="1" smtClean="0">
+                          <a:latin typeface="Cambria Math" panose="02040503050406030204" pitchFamily="18" charset="0"/>
+                        </a:rPr>
+                        <m:t>𝑎</m:t>
+                      </m:r>
+                      <m:r>
+                        <a:rPr lang="fr-FR" b="0" i="1" smtClean="0">
+                          <a:latin typeface="Cambria Math" panose="02040503050406030204" pitchFamily="18" charset="0"/>
+                        </a:rPr>
+                        <m:t> </m:t>
+                      </m:r>
+                      <m:r>
+                        <a:rPr lang="fr-FR" b="0" i="1" smtClean="0">
+                          <a:latin typeface="Cambria Math" panose="02040503050406030204" pitchFamily="18" charset="0"/>
+                        </a:rPr>
+                        <m:t>𝑐h</m:t>
+                      </m:r>
+                      <m:d>
+                        <m:dPr>
+                          <m:ctrlPr>
+                            <a:rPr lang="fr-FR" b="0" i="1" smtClean="0">
+                              <a:latin typeface="Cambria Math" panose="02040503050406030204" pitchFamily="18" charset="0"/>
+                            </a:rPr>
+                          </m:ctrlPr>
+                        </m:dPr>
+                        <m:e>
+                          <m:f>
+                            <m:fPr>
+                              <m:ctrlPr>
+                                <a:rPr lang="fr-FR" b="0" i="1" smtClean="0">
+                                  <a:latin typeface="Cambria Math" panose="02040503050406030204" pitchFamily="18" charset="0"/>
+                                </a:rPr>
+                              </m:ctrlPr>
+                            </m:fPr>
+                            <m:num>
+                              <m:r>
+                                <a:rPr lang="fr-FR" b="0" i="1" smtClean="0">
+                                  <a:latin typeface="Cambria Math" panose="02040503050406030204" pitchFamily="18" charset="0"/>
+                                </a:rPr>
+                                <m:t>𝑥</m:t>
+                              </m:r>
+                              <m:r>
+                                <a:rPr lang="fr-FR" b="0" i="1" smtClean="0">
+                                  <a:latin typeface="Cambria Math" panose="02040503050406030204" pitchFamily="18" charset="0"/>
+                                </a:rPr>
+                                <m:t> − </m:t>
+                              </m:r>
+                              <m:sSub>
+                                <m:sSubPr>
+                                  <m:ctrlPr>
+                                    <a:rPr lang="fr-FR" b="0" i="1" smtClean="0">
+                                      <a:latin typeface="Cambria Math" panose="02040503050406030204" pitchFamily="18" charset="0"/>
+                                    </a:rPr>
+                                  </m:ctrlPr>
+                                </m:sSubPr>
+                                <m:e>
+                                  <m:r>
+                                    <a:rPr lang="fr-FR" b="0" i="1" smtClean="0">
+                                      <a:latin typeface="Cambria Math" panose="02040503050406030204" pitchFamily="18" charset="0"/>
+                                    </a:rPr>
+                                    <m:t>𝑥</m:t>
+                                  </m:r>
+                                </m:e>
+                                <m:sub>
+                                  <m:r>
+                                    <a:rPr lang="fr-FR" b="0" i="1" smtClean="0">
+                                      <a:latin typeface="Cambria Math" panose="02040503050406030204" pitchFamily="18" charset="0"/>
+                                    </a:rPr>
+                                    <m:t>𝐻</m:t>
+                                  </m:r>
+                                </m:sub>
+                              </m:sSub>
+                            </m:num>
+                            <m:den>
+                              <m:r>
+                                <a:rPr lang="fr-FR" b="0" i="1" smtClean="0">
+                                  <a:latin typeface="Cambria Math" panose="02040503050406030204" pitchFamily="18" charset="0"/>
+                                </a:rPr>
+                                <m:t>𝑎</m:t>
+                              </m:r>
+                            </m:den>
+                          </m:f>
+                        </m:e>
+                      </m:d>
+                    </m:oMath>
+                  </m:oMathPara>
+                </a14:m>
+                <a:endParaRPr lang="fr-FR" dirty="0"/>
+              </a:p>
+            </p:txBody>
+          </p:sp>
+        </mc:Choice>
+        <mc:Fallback>
+          <p:sp>
+            <p:nvSpPr>
+              <p:cNvPr id="30" name="ZoneTexte 29">
+                <a:extLst>
+                  <a:ext uri="{FF2B5EF4-FFF2-40B4-BE49-F238E27FC236}">
+                    <a16:creationId xmlns:a16="http://schemas.microsoft.com/office/drawing/2014/main" id="{76E76206-519F-0CE4-FF47-2039FE295BDB}"/>
+                  </a:ext>
+                </a:extLst>
+              </p:cNvPr>
+              <p:cNvSpPr txBox="1">
+                <a:spLocks noRot="1" noChangeAspect="1" noMove="1" noResize="1" noEditPoints="1" noAdjustHandles="1" noChangeArrowheads="1" noChangeShapeType="1" noTextEdit="1"/>
+              </p:cNvSpPr>
+              <p:nvPr/>
+            </p:nvSpPr>
+            <p:spPr>
+              <a:xfrm>
+                <a:off x="7006546" y="1033083"/>
+                <a:ext cx="5097741" cy="566694"/>
+              </a:xfrm>
+              <a:prstGeom prst="rect">
+                <a:avLst/>
+              </a:prstGeom>
+              <a:blipFill>
+                <a:blip r:embed="rId2"/>
+                <a:stretch>
+                  <a:fillRect/>
+                </a:stretch>
+              </a:blipFill>
+            </p:spPr>
+            <p:txBody>
+              <a:bodyPr/>
+              <a:lstStyle/>
+              <a:p>
+                <a:r>
+                  <a:rPr lang="fr-FR">
+                    <a:noFill/>
+                  </a:rPr>
+                  <a:t> </a:t>
+                </a:r>
+              </a:p>
+            </p:txBody>
+          </p:sp>
+        </mc:Fallback>
+      </mc:AlternateContent>
+      <mc:AlternateContent xmlns:mc="http://schemas.openxmlformats.org/markup-compatibility/2006">
+        <mc:Choice xmlns:a14="http://schemas.microsoft.com/office/drawing/2010/main" Requires="a14">
+          <p:sp>
+            <p:nvSpPr>
+              <p:cNvPr id="32" name="ZoneTexte 31">
+                <a:extLst>
+                  <a:ext uri="{FF2B5EF4-FFF2-40B4-BE49-F238E27FC236}">
+                    <a16:creationId xmlns:a16="http://schemas.microsoft.com/office/drawing/2014/main" id="{F43FCCA6-9B3B-B6DC-C577-A4D0253B7E43}"/>
+                  </a:ext>
+                </a:extLst>
+              </p:cNvPr>
+              <p:cNvSpPr txBox="1"/>
+              <p:nvPr/>
+            </p:nvSpPr>
+            <p:spPr>
+              <a:xfrm>
+                <a:off x="7116791" y="3137926"/>
+                <a:ext cx="3328604" cy="582147"/>
+              </a:xfrm>
+              <a:prstGeom prst="rect">
+                <a:avLst/>
+              </a:prstGeom>
+              <a:noFill/>
+            </p:spPr>
+            <p:txBody>
+              <a:bodyPr wrap="none" rtlCol="0">
+                <a:spAutoFit/>
+              </a:bodyPr>
+              <a:lstStyle/>
+              <a:p>
+                <a:r>
+                  <a:rPr lang="fr-FR" dirty="0"/>
+                  <a:t>L = </a:t>
+                </a:r>
+                <a14:m>
+                  <m:oMath xmlns:m="http://schemas.openxmlformats.org/officeDocument/2006/math">
+                    <m:r>
+                      <a:rPr lang="fr-FR" b="0" i="1" smtClean="0">
+                        <a:latin typeface="Cambria Math" panose="02040503050406030204" pitchFamily="18" charset="0"/>
+                      </a:rPr>
+                      <m:t>𝑎</m:t>
+                    </m:r>
+                    <m:d>
+                      <m:dPr>
+                        <m:ctrlPr>
+                          <a:rPr lang="fr-FR" b="0" i="1" smtClean="0">
+                            <a:latin typeface="Cambria Math" panose="02040503050406030204" pitchFamily="18" charset="0"/>
+                          </a:rPr>
+                        </m:ctrlPr>
+                      </m:dPr>
+                      <m:e>
+                        <m:r>
+                          <a:rPr lang="fr-FR" i="1">
+                            <a:latin typeface="Cambria Math" panose="02040503050406030204" pitchFamily="18" charset="0"/>
+                          </a:rPr>
+                          <m:t>𝑠h</m:t>
+                        </m:r>
+                        <m:d>
+                          <m:dPr>
+                            <m:ctrlPr>
+                              <a:rPr lang="fr-FR" i="1">
+                                <a:latin typeface="Cambria Math" panose="02040503050406030204" pitchFamily="18" charset="0"/>
+                              </a:rPr>
+                            </m:ctrlPr>
+                          </m:dPr>
+                          <m:e>
+                            <m:f>
+                              <m:fPr>
+                                <m:ctrlPr>
+                                  <a:rPr lang="fr-FR" i="1">
+                                    <a:latin typeface="Cambria Math" panose="02040503050406030204" pitchFamily="18" charset="0"/>
+                                  </a:rPr>
+                                </m:ctrlPr>
+                              </m:fPr>
+                              <m:num>
+                                <m:sSub>
+                                  <m:sSubPr>
+                                    <m:ctrlPr>
+                                      <a:rPr lang="fr-FR" i="1">
+                                        <a:latin typeface="Cambria Math" panose="02040503050406030204" pitchFamily="18" charset="0"/>
+                                      </a:rPr>
+                                    </m:ctrlPr>
+                                  </m:sSubPr>
+                                  <m:e>
+                                    <m:r>
+                                      <a:rPr lang="fr-FR" i="1">
+                                        <a:latin typeface="Cambria Math" panose="02040503050406030204" pitchFamily="18" charset="0"/>
+                                      </a:rPr>
+                                      <m:t>𝑥</m:t>
+                                    </m:r>
+                                  </m:e>
+                                  <m:sub>
+                                    <m:r>
+                                      <a:rPr lang="fr-FR" i="1">
+                                        <a:latin typeface="Cambria Math" panose="02040503050406030204" pitchFamily="18" charset="0"/>
+                                      </a:rPr>
+                                      <m:t>𝑟𝑜𝑣</m:t>
+                                    </m:r>
+                                  </m:sub>
+                                </m:sSub>
+                                <m:r>
+                                  <a:rPr lang="fr-FR" i="1">
+                                    <a:latin typeface="Cambria Math" panose="02040503050406030204" pitchFamily="18" charset="0"/>
+                                  </a:rPr>
+                                  <m:t> −</m:t>
+                                </m:r>
+                                <m:sSub>
+                                  <m:sSubPr>
+                                    <m:ctrlPr>
+                                      <a:rPr lang="fr-FR" i="1">
+                                        <a:latin typeface="Cambria Math" panose="02040503050406030204" pitchFamily="18" charset="0"/>
+                                      </a:rPr>
+                                    </m:ctrlPr>
+                                  </m:sSubPr>
+                                  <m:e>
+                                    <m:r>
+                                      <a:rPr lang="fr-FR" i="1">
+                                        <a:latin typeface="Cambria Math" panose="02040503050406030204" pitchFamily="18" charset="0"/>
+                                      </a:rPr>
+                                      <m:t>𝑥</m:t>
+                                    </m:r>
+                                  </m:e>
+                                  <m:sub>
+                                    <m:r>
+                                      <a:rPr lang="fr-FR" i="1">
+                                        <a:latin typeface="Cambria Math" panose="02040503050406030204" pitchFamily="18" charset="0"/>
+                                      </a:rPr>
+                                      <m:t>𝐻</m:t>
+                                    </m:r>
+                                  </m:sub>
+                                </m:sSub>
+                              </m:num>
+                              <m:den>
+                                <m:r>
+                                  <a:rPr lang="fr-FR" i="1">
+                                    <a:latin typeface="Cambria Math" panose="02040503050406030204" pitchFamily="18" charset="0"/>
+                                  </a:rPr>
+                                  <m:t>𝑎</m:t>
+                                </m:r>
+                              </m:den>
+                            </m:f>
+                          </m:e>
+                        </m:d>
+                        <m:r>
+                          <a:rPr lang="fr-FR" i="1">
+                            <a:latin typeface="Cambria Math" panose="02040503050406030204" pitchFamily="18" charset="0"/>
+                          </a:rPr>
+                          <m:t> −</m:t>
+                        </m:r>
+                        <m:r>
+                          <a:rPr lang="fr-FR" i="1">
+                            <a:latin typeface="Cambria Math" panose="02040503050406030204" pitchFamily="18" charset="0"/>
+                          </a:rPr>
+                          <m:t>𝑠h</m:t>
+                        </m:r>
+                        <m:d>
+                          <m:dPr>
+                            <m:ctrlPr>
+                              <a:rPr lang="fr-FR" i="1">
+                                <a:latin typeface="Cambria Math" panose="02040503050406030204" pitchFamily="18" charset="0"/>
+                              </a:rPr>
+                            </m:ctrlPr>
+                          </m:dPr>
+                          <m:e>
+                            <m:f>
+                              <m:fPr>
+                                <m:ctrlPr>
+                                  <a:rPr lang="fr-FR" i="1">
+                                    <a:latin typeface="Cambria Math" panose="02040503050406030204" pitchFamily="18" charset="0"/>
+                                  </a:rPr>
+                                </m:ctrlPr>
+                              </m:fPr>
+                              <m:num>
+                                <m:r>
+                                  <a:rPr lang="fr-FR" i="1">
+                                    <a:latin typeface="Cambria Math" panose="02040503050406030204" pitchFamily="18" charset="0"/>
+                                  </a:rPr>
+                                  <m:t>−</m:t>
+                                </m:r>
+                                <m:sSub>
+                                  <m:sSubPr>
+                                    <m:ctrlPr>
+                                      <a:rPr lang="fr-FR" i="1">
+                                        <a:latin typeface="Cambria Math" panose="02040503050406030204" pitchFamily="18" charset="0"/>
+                                      </a:rPr>
+                                    </m:ctrlPr>
+                                  </m:sSubPr>
+                                  <m:e>
+                                    <m:r>
+                                      <a:rPr lang="fr-FR" i="1">
+                                        <a:latin typeface="Cambria Math" panose="02040503050406030204" pitchFamily="18" charset="0"/>
+                                      </a:rPr>
+                                      <m:t>𝑥</m:t>
+                                    </m:r>
+                                  </m:e>
+                                  <m:sub>
+                                    <m:r>
+                                      <a:rPr lang="fr-FR" i="1">
+                                        <a:latin typeface="Cambria Math" panose="02040503050406030204" pitchFamily="18" charset="0"/>
+                                      </a:rPr>
+                                      <m:t>𝐻</m:t>
+                                    </m:r>
+                                  </m:sub>
+                                </m:sSub>
+                              </m:num>
+                              <m:den>
+                                <m:r>
+                                  <a:rPr lang="fr-FR" i="1">
+                                    <a:latin typeface="Cambria Math" panose="02040503050406030204" pitchFamily="18" charset="0"/>
+                                  </a:rPr>
+                                  <m:t>𝑎</m:t>
+                                </m:r>
+                              </m:den>
+                            </m:f>
+                          </m:e>
+                        </m:d>
+                      </m:e>
+                    </m:d>
+                  </m:oMath>
+                </a14:m>
+                <a:endParaRPr lang="fr-FR" dirty="0"/>
+              </a:p>
+            </p:txBody>
+          </p:sp>
+        </mc:Choice>
+        <mc:Fallback>
+          <p:sp>
+            <p:nvSpPr>
+              <p:cNvPr id="32" name="ZoneTexte 31">
+                <a:extLst>
+                  <a:ext uri="{FF2B5EF4-FFF2-40B4-BE49-F238E27FC236}">
+                    <a16:creationId xmlns:a16="http://schemas.microsoft.com/office/drawing/2014/main" id="{F43FCCA6-9B3B-B6DC-C577-A4D0253B7E43}"/>
+                  </a:ext>
+                </a:extLst>
+              </p:cNvPr>
+              <p:cNvSpPr txBox="1">
+                <a:spLocks noRot="1" noChangeAspect="1" noMove="1" noResize="1" noEditPoints="1" noAdjustHandles="1" noChangeArrowheads="1" noChangeShapeType="1" noTextEdit="1"/>
+              </p:cNvSpPr>
+              <p:nvPr/>
+            </p:nvSpPr>
+            <p:spPr>
+              <a:xfrm>
+                <a:off x="7116791" y="3137926"/>
+                <a:ext cx="3328604" cy="582147"/>
+              </a:xfrm>
+              <a:prstGeom prst="rect">
+                <a:avLst/>
+              </a:prstGeom>
+              <a:blipFill>
+                <a:blip r:embed="rId3"/>
+                <a:stretch>
+                  <a:fillRect l="-1465"/>
+                </a:stretch>
+              </a:blipFill>
+            </p:spPr>
+            <p:txBody>
+              <a:bodyPr/>
+              <a:lstStyle/>
+              <a:p>
+                <a:r>
+                  <a:rPr lang="fr-FR">
+                    <a:noFill/>
+                  </a:rPr>
+                  <a:t> </a:t>
+                </a:r>
+              </a:p>
+            </p:txBody>
+          </p:sp>
+        </mc:Fallback>
+      </mc:AlternateContent>
+      <mc:AlternateContent xmlns:mc="http://schemas.openxmlformats.org/markup-compatibility/2006">
+        <mc:Choice xmlns:a14="http://schemas.microsoft.com/office/drawing/2010/main" Requires="a14">
+          <p:sp>
+            <p:nvSpPr>
+              <p:cNvPr id="33" name="ZoneTexte 32">
+                <a:extLst>
+                  <a:ext uri="{FF2B5EF4-FFF2-40B4-BE49-F238E27FC236}">
+                    <a16:creationId xmlns:a16="http://schemas.microsoft.com/office/drawing/2014/main" id="{23510A09-1220-1C3A-2BDD-5ACBAB9E09AF}"/>
+                  </a:ext>
+                </a:extLst>
+              </p:cNvPr>
+              <p:cNvSpPr txBox="1"/>
+              <p:nvPr/>
+            </p:nvSpPr>
+            <p:spPr>
+              <a:xfrm>
+                <a:off x="7051727" y="2356672"/>
+                <a:ext cx="3277179" cy="566694"/>
+              </a:xfrm>
+              <a:prstGeom prst="rect">
+                <a:avLst/>
+              </a:prstGeom>
+              <a:noFill/>
+            </p:spPr>
+            <p:txBody>
+              <a:bodyPr wrap="none" rtlCol="0">
+                <a:spAutoFit/>
+              </a:bodyPr>
+              <a:lstStyle/>
+              <a:p>
+                <a14:m>
+                  <m:oMathPara xmlns:m="http://schemas.openxmlformats.org/officeDocument/2006/math">
+                    <m:oMathParaPr>
+                      <m:jc m:val="centerGroup"/>
+                    </m:oMathParaPr>
+                    <m:oMath xmlns:m="http://schemas.openxmlformats.org/officeDocument/2006/math">
+                      <m:sSub>
+                        <m:sSubPr>
+                          <m:ctrlPr>
+                            <a:rPr lang="fr-FR" b="0" i="1" smtClean="0">
+                              <a:latin typeface="Cambria Math" panose="02040503050406030204" pitchFamily="18" charset="0"/>
+                            </a:rPr>
+                          </m:ctrlPr>
+                        </m:sSubPr>
+                        <m:e>
+                          <m:r>
+                            <a:rPr lang="fr-FR" b="0" i="1" smtClean="0">
+                              <a:latin typeface="Cambria Math" panose="02040503050406030204" pitchFamily="18" charset="0"/>
+                            </a:rPr>
+                            <m:t>𝑦</m:t>
+                          </m:r>
+                        </m:e>
+                        <m:sub>
+                          <m:r>
+                            <a:rPr lang="fr-FR" b="0" i="1" smtClean="0">
+                              <a:latin typeface="Cambria Math" panose="02040503050406030204" pitchFamily="18" charset="0"/>
+                            </a:rPr>
+                            <m:t>𝑟𝑜𝑣</m:t>
+                          </m:r>
+                        </m:sub>
+                      </m:sSub>
+                      <m:r>
+                        <a:rPr lang="fr-FR" b="0" i="1" smtClean="0">
+                          <a:latin typeface="Cambria Math" panose="02040503050406030204" pitchFamily="18" charset="0"/>
+                        </a:rPr>
+                        <m:t>=</m:t>
+                      </m:r>
+                      <m:sSub>
+                        <m:sSubPr>
+                          <m:ctrlPr>
+                            <a:rPr lang="fr-FR" b="0" i="1" smtClean="0">
+                              <a:latin typeface="Cambria Math" panose="02040503050406030204" pitchFamily="18" charset="0"/>
+                            </a:rPr>
+                          </m:ctrlPr>
+                        </m:sSubPr>
+                        <m:e>
+                          <m:r>
+                            <a:rPr lang="fr-FR" b="0" i="1" smtClean="0">
+                              <a:latin typeface="Cambria Math" panose="02040503050406030204" pitchFamily="18" charset="0"/>
+                            </a:rPr>
+                            <m:t>𝑦</m:t>
+                          </m:r>
+                        </m:e>
+                        <m:sub>
+                          <m:r>
+                            <a:rPr lang="fr-FR" b="0" i="1" smtClean="0">
+                              <a:latin typeface="Cambria Math" panose="02040503050406030204" pitchFamily="18" charset="0"/>
+                            </a:rPr>
+                            <m:t>𝐻</m:t>
+                          </m:r>
+                        </m:sub>
+                      </m:sSub>
+                      <m:r>
+                        <a:rPr lang="fr-FR" b="0" i="1" smtClean="0">
+                          <a:latin typeface="Cambria Math" panose="02040503050406030204" pitchFamily="18" charset="0"/>
+                        </a:rPr>
+                        <m:t>+ </m:t>
+                      </m:r>
+                      <m:r>
+                        <a:rPr lang="fr-FR" b="0" i="1" smtClean="0">
+                          <a:latin typeface="Cambria Math" panose="02040503050406030204" pitchFamily="18" charset="0"/>
+                        </a:rPr>
+                        <m:t>𝑎</m:t>
+                      </m:r>
+                      <m:r>
+                        <a:rPr lang="fr-FR" b="0" i="1" smtClean="0">
+                          <a:latin typeface="Cambria Math" panose="02040503050406030204" pitchFamily="18" charset="0"/>
+                        </a:rPr>
+                        <m:t> </m:t>
+                      </m:r>
+                      <m:r>
+                        <a:rPr lang="fr-FR" b="0" i="1" smtClean="0">
+                          <a:latin typeface="Cambria Math" panose="02040503050406030204" pitchFamily="18" charset="0"/>
+                        </a:rPr>
+                        <m:t>𝑐h</m:t>
+                      </m:r>
+                      <m:d>
+                        <m:dPr>
+                          <m:ctrlPr>
+                            <a:rPr lang="fr-FR" b="0" i="1" smtClean="0">
+                              <a:latin typeface="Cambria Math" panose="02040503050406030204" pitchFamily="18" charset="0"/>
+                            </a:rPr>
+                          </m:ctrlPr>
+                        </m:dPr>
+                        <m:e>
+                          <m:f>
+                            <m:fPr>
+                              <m:ctrlPr>
+                                <a:rPr lang="fr-FR" b="0" i="1" smtClean="0">
+                                  <a:latin typeface="Cambria Math" panose="02040503050406030204" pitchFamily="18" charset="0"/>
+                                </a:rPr>
+                              </m:ctrlPr>
+                            </m:fPr>
+                            <m:num>
+                              <m:sSub>
+                                <m:sSubPr>
+                                  <m:ctrlPr>
+                                    <a:rPr lang="fr-FR" b="0" i="1" smtClean="0">
+                                      <a:latin typeface="Cambria Math" panose="02040503050406030204" pitchFamily="18" charset="0"/>
+                                    </a:rPr>
+                                  </m:ctrlPr>
+                                </m:sSubPr>
+                                <m:e>
+                                  <m:r>
+                                    <a:rPr lang="fr-FR" b="0" i="1" smtClean="0">
+                                      <a:latin typeface="Cambria Math" panose="02040503050406030204" pitchFamily="18" charset="0"/>
+                                    </a:rPr>
+                                    <m:t>𝑥</m:t>
+                                  </m:r>
+                                </m:e>
+                                <m:sub>
+                                  <m:r>
+                                    <a:rPr lang="fr-FR" b="0" i="1" smtClean="0">
+                                      <a:latin typeface="Cambria Math" panose="02040503050406030204" pitchFamily="18" charset="0"/>
+                                    </a:rPr>
+                                    <m:t>𝑟𝑜𝑣</m:t>
+                                  </m:r>
+                                </m:sub>
+                              </m:sSub>
+                              <m:r>
+                                <a:rPr lang="fr-FR" b="0" i="1" smtClean="0">
+                                  <a:latin typeface="Cambria Math" panose="02040503050406030204" pitchFamily="18" charset="0"/>
+                                </a:rPr>
+                                <m:t> − </m:t>
+                              </m:r>
+                              <m:sSub>
+                                <m:sSubPr>
+                                  <m:ctrlPr>
+                                    <a:rPr lang="fr-FR" b="0" i="1" smtClean="0">
+                                      <a:latin typeface="Cambria Math" panose="02040503050406030204" pitchFamily="18" charset="0"/>
+                                    </a:rPr>
+                                  </m:ctrlPr>
+                                </m:sSubPr>
+                                <m:e>
+                                  <m:r>
+                                    <a:rPr lang="fr-FR" b="0" i="1" smtClean="0">
+                                      <a:latin typeface="Cambria Math" panose="02040503050406030204" pitchFamily="18" charset="0"/>
+                                    </a:rPr>
+                                    <m:t>𝑥</m:t>
+                                  </m:r>
+                                </m:e>
+                                <m:sub>
+                                  <m:r>
+                                    <a:rPr lang="fr-FR" b="0" i="1" smtClean="0">
+                                      <a:latin typeface="Cambria Math" panose="02040503050406030204" pitchFamily="18" charset="0"/>
+                                    </a:rPr>
+                                    <m:t>𝐻</m:t>
+                                  </m:r>
+                                </m:sub>
+                              </m:sSub>
+                            </m:num>
+                            <m:den>
+                              <m:r>
+                                <a:rPr lang="fr-FR" b="0" i="1" smtClean="0">
+                                  <a:latin typeface="Cambria Math" panose="02040503050406030204" pitchFamily="18" charset="0"/>
+                                </a:rPr>
+                                <m:t>𝑎</m:t>
+                              </m:r>
+                            </m:den>
+                          </m:f>
+                        </m:e>
+                      </m:d>
+                    </m:oMath>
+                  </m:oMathPara>
+                </a14:m>
+                <a:endParaRPr lang="fr-FR" dirty="0"/>
+              </a:p>
+            </p:txBody>
+          </p:sp>
+        </mc:Choice>
+        <mc:Fallback>
+          <p:sp>
+            <p:nvSpPr>
+              <p:cNvPr id="33" name="ZoneTexte 32">
+                <a:extLst>
+                  <a:ext uri="{FF2B5EF4-FFF2-40B4-BE49-F238E27FC236}">
+                    <a16:creationId xmlns:a16="http://schemas.microsoft.com/office/drawing/2014/main" id="{23510A09-1220-1C3A-2BDD-5ACBAB9E09AF}"/>
+                  </a:ext>
+                </a:extLst>
+              </p:cNvPr>
+              <p:cNvSpPr txBox="1">
+                <a:spLocks noRot="1" noChangeAspect="1" noMove="1" noResize="1" noEditPoints="1" noAdjustHandles="1" noChangeArrowheads="1" noChangeShapeType="1" noTextEdit="1"/>
+              </p:cNvSpPr>
+              <p:nvPr/>
+            </p:nvSpPr>
+            <p:spPr>
+              <a:xfrm>
+                <a:off x="7051727" y="2356672"/>
+                <a:ext cx="3277179" cy="566694"/>
+              </a:xfrm>
+              <a:prstGeom prst="rect">
+                <a:avLst/>
+              </a:prstGeom>
+              <a:blipFill>
+                <a:blip r:embed="rId4"/>
+                <a:stretch>
+                  <a:fillRect/>
+                </a:stretch>
+              </a:blipFill>
+            </p:spPr>
+            <p:txBody>
+              <a:bodyPr/>
+              <a:lstStyle/>
+              <a:p>
+                <a:r>
+                  <a:rPr lang="fr-FR">
+                    <a:noFill/>
+                  </a:rPr>
+                  <a:t> </a:t>
+                </a:r>
+              </a:p>
+            </p:txBody>
+          </p:sp>
+        </mc:Fallback>
+      </mc:AlternateContent>
+      <p:grpSp>
+        <p:nvGrpSpPr>
+          <p:cNvPr id="5" name="Groupe 4">
+            <a:extLst>
+              <a:ext uri="{FF2B5EF4-FFF2-40B4-BE49-F238E27FC236}">
+                <a16:creationId xmlns:a16="http://schemas.microsoft.com/office/drawing/2014/main" id="{293B58F8-F738-E62D-B398-59CB8D0429C0}"/>
+              </a:ext>
+            </a:extLst>
+          </p:cNvPr>
+          <p:cNvGrpSpPr/>
+          <p:nvPr/>
+        </p:nvGrpSpPr>
+        <p:grpSpPr>
+          <a:xfrm>
+            <a:off x="-4124921" y="303538"/>
+            <a:ext cx="10251122" cy="9223970"/>
+            <a:chOff x="-3782021" y="671838"/>
+            <a:chExt cx="10251122" cy="9223970"/>
+          </a:xfrm>
+        </p:grpSpPr>
+        <p:sp>
+          <p:nvSpPr>
+            <p:cNvPr id="4" name="Arc 3">
+              <a:extLst>
+                <a:ext uri="{FF2B5EF4-FFF2-40B4-BE49-F238E27FC236}">
+                  <a16:creationId xmlns:a16="http://schemas.microsoft.com/office/drawing/2014/main" id="{1258E929-AD3C-0663-CD96-E0A01381DFB4}"/>
+                </a:ext>
+              </a:extLst>
+            </p:cNvPr>
+            <p:cNvSpPr/>
+            <p:nvPr/>
+          </p:nvSpPr>
+          <p:spPr>
+            <a:xfrm>
+              <a:off x="-3782021" y="1173499"/>
+              <a:ext cx="9173027" cy="8722309"/>
+            </a:xfrm>
+            <a:prstGeom prst="arc">
+              <a:avLst>
+                <a:gd name="adj1" fmla="val 17723212"/>
+                <a:gd name="adj2" fmla="val 20387261"/>
+              </a:avLst>
+            </a:prstGeom>
+            <a:ln w="38100">
+              <a:solidFill>
+                <a:srgbClr val="FF0000"/>
+              </a:solidFill>
+            </a:ln>
+          </p:spPr>
+          <p:style>
+            <a:lnRef idx="2">
+              <a:schemeClr val="accent1"/>
+            </a:lnRef>
+            <a:fillRef idx="0">
+              <a:schemeClr val="accent1"/>
+            </a:fillRef>
+            <a:effectRef idx="1">
+              <a:schemeClr val="accent1"/>
+            </a:effectRef>
+            <a:fontRef idx="minor">
+              <a:schemeClr val="tx1"/>
+            </a:fontRef>
+          </p:style>
+          <p:txBody>
+            <a:bodyPr rtlCol="0" anchor="ctr"/>
+            <a:lstStyle/>
+            <a:p>
+              <a:pPr algn="ctr"/>
+              <a:endParaRPr lang="fr-FR"/>
+            </a:p>
+          </p:txBody>
+        </p:sp>
+        <p:cxnSp>
+          <p:nvCxnSpPr>
+            <p:cNvPr id="16" name="Connecteur droit avec flèche 15">
+              <a:extLst>
+                <a:ext uri="{FF2B5EF4-FFF2-40B4-BE49-F238E27FC236}">
+                  <a16:creationId xmlns:a16="http://schemas.microsoft.com/office/drawing/2014/main" id="{DBB32B79-3405-BCAF-3D4B-4415FDA71D47}"/>
+                </a:ext>
+              </a:extLst>
+            </p:cNvPr>
+            <p:cNvCxnSpPr/>
+            <p:nvPr/>
+          </p:nvCxnSpPr>
+          <p:spPr>
+            <a:xfrm>
+              <a:off x="2739581" y="1546415"/>
+              <a:ext cx="3729520" cy="0"/>
+            </a:xfrm>
+            <a:prstGeom prst="straightConnector1">
+              <a:avLst/>
+            </a:prstGeom>
+            <a:ln>
+              <a:tailEnd type="triangle"/>
+            </a:ln>
+          </p:spPr>
+          <p:style>
+            <a:lnRef idx="2">
+              <a:schemeClr val="accent1"/>
+            </a:lnRef>
+            <a:fillRef idx="0">
+              <a:schemeClr val="accent1"/>
+            </a:fillRef>
+            <a:effectRef idx="1">
+              <a:schemeClr val="accent1"/>
+            </a:effectRef>
+            <a:fontRef idx="minor">
+              <a:schemeClr val="tx1"/>
+            </a:fontRef>
+          </p:style>
+        </p:cxnSp>
+        <p:sp>
+          <p:nvSpPr>
+            <p:cNvPr id="14" name="Arc 13">
+              <a:extLst>
+                <a:ext uri="{FF2B5EF4-FFF2-40B4-BE49-F238E27FC236}">
+                  <a16:creationId xmlns:a16="http://schemas.microsoft.com/office/drawing/2014/main" id="{DFFA76FE-AC70-C6E5-4517-B31BCDD84344}"/>
+                </a:ext>
+              </a:extLst>
+            </p:cNvPr>
+            <p:cNvSpPr/>
+            <p:nvPr/>
+          </p:nvSpPr>
+          <p:spPr>
+            <a:xfrm>
+              <a:off x="-3782021" y="1173089"/>
+              <a:ext cx="9173027" cy="8722309"/>
+            </a:xfrm>
+            <a:prstGeom prst="arc">
+              <a:avLst>
+                <a:gd name="adj1" fmla="val 16291574"/>
+                <a:gd name="adj2" fmla="val 17678338"/>
+              </a:avLst>
+            </a:prstGeom>
+            <a:ln w="38100">
+              <a:solidFill>
+                <a:schemeClr val="accent5">
+                  <a:lumMod val="60000"/>
+                  <a:lumOff val="40000"/>
+                </a:schemeClr>
+              </a:solidFill>
+            </a:ln>
+          </p:spPr>
+          <p:style>
+            <a:lnRef idx="2">
+              <a:schemeClr val="accent1"/>
+            </a:lnRef>
+            <a:fillRef idx="0">
+              <a:schemeClr val="accent1"/>
+            </a:fillRef>
+            <a:effectRef idx="1">
+              <a:schemeClr val="accent1"/>
+            </a:effectRef>
+            <a:fontRef idx="minor">
+              <a:schemeClr val="tx1"/>
+            </a:fontRef>
+          </p:style>
+          <p:txBody>
+            <a:bodyPr rtlCol="0" anchor="ctr"/>
+            <a:lstStyle/>
+            <a:p>
+              <a:pPr algn="ctr"/>
+              <a:endParaRPr lang="fr-FR"/>
+            </a:p>
+          </p:txBody>
+        </p:sp>
+        <p:cxnSp>
+          <p:nvCxnSpPr>
+            <p:cNvPr id="17" name="Connecteur droit avec flèche 16">
+              <a:extLst>
+                <a:ext uri="{FF2B5EF4-FFF2-40B4-BE49-F238E27FC236}">
+                  <a16:creationId xmlns:a16="http://schemas.microsoft.com/office/drawing/2014/main" id="{7D5F46B1-29C5-3C5C-BEC9-9EADD2A123AE}"/>
+                </a:ext>
+              </a:extLst>
+            </p:cNvPr>
+            <p:cNvCxnSpPr>
+              <a:cxnSpLocks/>
+            </p:cNvCxnSpPr>
+            <p:nvPr/>
+          </p:nvCxnSpPr>
+          <p:spPr>
+            <a:xfrm>
+              <a:off x="2682431" y="1574990"/>
+              <a:ext cx="0" cy="2622349"/>
+            </a:xfrm>
+            <a:prstGeom prst="straightConnector1">
+              <a:avLst/>
+            </a:prstGeom>
+            <a:ln>
+              <a:tailEnd type="triangle"/>
+            </a:ln>
+          </p:spPr>
+          <p:style>
+            <a:lnRef idx="2">
+              <a:schemeClr val="accent1"/>
+            </a:lnRef>
+            <a:fillRef idx="0">
+              <a:schemeClr val="accent1"/>
+            </a:fillRef>
+            <a:effectRef idx="1">
+              <a:schemeClr val="accent1"/>
+            </a:effectRef>
+            <a:fontRef idx="minor">
+              <a:schemeClr val="tx1"/>
+            </a:fontRef>
+          </p:style>
+        </p:cxnSp>
+        <p:cxnSp>
+          <p:nvCxnSpPr>
+            <p:cNvPr id="23" name="Connecteur droit avec flèche 22">
+              <a:extLst>
+                <a:ext uri="{FF2B5EF4-FFF2-40B4-BE49-F238E27FC236}">
+                  <a16:creationId xmlns:a16="http://schemas.microsoft.com/office/drawing/2014/main" id="{20B55CB0-4820-B4F6-A5AC-AB06001D5EA3}"/>
+                </a:ext>
+              </a:extLst>
+            </p:cNvPr>
+            <p:cNvCxnSpPr>
+              <a:cxnSpLocks/>
+            </p:cNvCxnSpPr>
+            <p:nvPr/>
+          </p:nvCxnSpPr>
+          <p:spPr>
+            <a:xfrm>
+              <a:off x="5089292" y="1574990"/>
+              <a:ext cx="0" cy="2622349"/>
+            </a:xfrm>
+            <a:prstGeom prst="straightConnector1">
+              <a:avLst/>
+            </a:prstGeom>
+            <a:ln>
+              <a:prstDash val="dash"/>
+              <a:tailEnd type="triangle"/>
+            </a:ln>
+          </p:spPr>
+          <p:style>
+            <a:lnRef idx="2">
+              <a:schemeClr val="accent1"/>
+            </a:lnRef>
+            <a:fillRef idx="0">
+              <a:schemeClr val="accent1"/>
+            </a:fillRef>
+            <a:effectRef idx="1">
+              <a:schemeClr val="accent1"/>
+            </a:effectRef>
+            <a:fontRef idx="minor">
+              <a:schemeClr val="tx1"/>
+            </a:fontRef>
+          </p:style>
+        </p:cxnSp>
+        <p:sp>
+          <p:nvSpPr>
+            <p:cNvPr id="24" name="ZoneTexte 23">
+              <a:extLst>
+                <a:ext uri="{FF2B5EF4-FFF2-40B4-BE49-F238E27FC236}">
+                  <a16:creationId xmlns:a16="http://schemas.microsoft.com/office/drawing/2014/main" id="{FCD1E9F0-F249-40EC-5E7D-422AF6524B95}"/>
+                </a:ext>
+              </a:extLst>
+            </p:cNvPr>
+            <p:cNvSpPr txBox="1"/>
+            <p:nvPr/>
+          </p:nvSpPr>
+          <p:spPr>
+            <a:xfrm>
+              <a:off x="4938707" y="1129049"/>
+              <a:ext cx="589649" cy="369332"/>
+            </a:xfrm>
+            <a:prstGeom prst="rect">
+              <a:avLst/>
+            </a:prstGeom>
+            <a:noFill/>
+          </p:spPr>
+          <p:txBody>
+            <a:bodyPr wrap="none" rtlCol="0">
+              <a:spAutoFit/>
+            </a:bodyPr>
+            <a:lstStyle/>
+            <a:p>
+              <a:r>
+                <a:rPr lang="fr-FR" dirty="0" err="1"/>
+                <a:t>xrov</a:t>
+              </a:r>
+              <a:endParaRPr lang="fr-FR" dirty="0"/>
+            </a:p>
+          </p:txBody>
+        </p:sp>
+        <p:sp>
+          <p:nvSpPr>
+            <p:cNvPr id="25" name="ZoneTexte 24">
+              <a:extLst>
+                <a:ext uri="{FF2B5EF4-FFF2-40B4-BE49-F238E27FC236}">
+                  <a16:creationId xmlns:a16="http://schemas.microsoft.com/office/drawing/2014/main" id="{628DBE10-D30F-7EE4-6E75-A149D83F03F5}"/>
+                </a:ext>
+              </a:extLst>
+            </p:cNvPr>
+            <p:cNvSpPr txBox="1"/>
+            <p:nvPr/>
+          </p:nvSpPr>
+          <p:spPr>
+            <a:xfrm>
+              <a:off x="1969663" y="3643341"/>
+              <a:ext cx="591252" cy="369332"/>
+            </a:xfrm>
+            <a:prstGeom prst="rect">
+              <a:avLst/>
+            </a:prstGeom>
+            <a:noFill/>
+          </p:spPr>
+          <p:txBody>
+            <a:bodyPr wrap="none" rtlCol="0">
+              <a:spAutoFit/>
+            </a:bodyPr>
+            <a:lstStyle/>
+            <a:p>
+              <a:r>
+                <a:rPr lang="fr-FR" dirty="0" err="1"/>
+                <a:t>yrov</a:t>
+              </a:r>
+              <a:endParaRPr lang="fr-FR" dirty="0"/>
+            </a:p>
+          </p:txBody>
+        </p:sp>
+        <p:sp>
+          <p:nvSpPr>
+            <p:cNvPr id="26" name="Ellipse 25">
+              <a:extLst>
+                <a:ext uri="{FF2B5EF4-FFF2-40B4-BE49-F238E27FC236}">
+                  <a16:creationId xmlns:a16="http://schemas.microsoft.com/office/drawing/2014/main" id="{A9D75792-E6CF-DE70-BFAD-2457D4132760}"/>
+                </a:ext>
+              </a:extLst>
+            </p:cNvPr>
+            <p:cNvSpPr/>
+            <p:nvPr/>
+          </p:nvSpPr>
+          <p:spPr>
+            <a:xfrm>
+              <a:off x="5020885" y="3887918"/>
+              <a:ext cx="93597" cy="99277"/>
+            </a:xfrm>
+            <a:prstGeom prst="ellipse">
+              <a:avLst/>
+            </a:prstGeom>
+            <a:solidFill>
+              <a:srgbClr val="00B050"/>
+            </a:solidFill>
+            <a:ln>
+              <a:solidFill>
+                <a:srgbClr val="00B050"/>
+              </a:solidFill>
+            </a:ln>
+          </p:spPr>
+          <p:style>
+            <a:lnRef idx="2">
+              <a:schemeClr val="accent1">
+                <a:shade val="15000"/>
+              </a:schemeClr>
+            </a:lnRef>
+            <a:fillRef idx="1">
+              <a:schemeClr val="accent1"/>
+            </a:fillRef>
+            <a:effectRef idx="0">
+              <a:schemeClr val="accent1"/>
+            </a:effectRef>
+            <a:fontRef idx="minor">
+              <a:schemeClr val="lt1"/>
+            </a:fontRef>
+          </p:style>
+          <p:txBody>
+            <a:bodyPr rtlCol="0" anchor="ctr"/>
+            <a:lstStyle/>
+            <a:p>
+              <a:pPr algn="ctr"/>
+              <a:endParaRPr lang="fr-FR"/>
+            </a:p>
+          </p:txBody>
+        </p:sp>
+        <p:sp>
+          <p:nvSpPr>
+            <p:cNvPr id="27" name="Ellipse 26">
+              <a:extLst>
+                <a:ext uri="{FF2B5EF4-FFF2-40B4-BE49-F238E27FC236}">
+                  <a16:creationId xmlns:a16="http://schemas.microsoft.com/office/drawing/2014/main" id="{3C26B1E7-BE67-AF5D-6172-42878FE752C7}"/>
+                </a:ext>
+              </a:extLst>
+            </p:cNvPr>
+            <p:cNvSpPr/>
+            <p:nvPr/>
+          </p:nvSpPr>
+          <p:spPr>
+            <a:xfrm>
+              <a:off x="2625297" y="1504849"/>
+              <a:ext cx="93597" cy="99277"/>
+            </a:xfrm>
+            <a:prstGeom prst="ellipse">
+              <a:avLst/>
+            </a:prstGeom>
+            <a:solidFill>
+              <a:srgbClr val="00B050"/>
+            </a:solidFill>
+            <a:ln>
+              <a:solidFill>
+                <a:srgbClr val="00B050"/>
+              </a:solidFill>
+            </a:ln>
+          </p:spPr>
+          <p:style>
+            <a:lnRef idx="2">
+              <a:schemeClr val="accent1">
+                <a:shade val="15000"/>
+              </a:schemeClr>
+            </a:lnRef>
+            <a:fillRef idx="1">
+              <a:schemeClr val="accent1"/>
+            </a:fillRef>
+            <a:effectRef idx="0">
+              <a:schemeClr val="accent1"/>
+            </a:effectRef>
+            <a:fontRef idx="minor">
+              <a:schemeClr val="lt1"/>
+            </a:fontRef>
+          </p:style>
+          <p:txBody>
+            <a:bodyPr rtlCol="0" anchor="ctr"/>
+            <a:lstStyle/>
+            <a:p>
+              <a:pPr algn="ctr"/>
+              <a:endParaRPr lang="fr-FR"/>
+            </a:p>
+          </p:txBody>
+        </p:sp>
+        <p:sp>
+          <p:nvSpPr>
+            <p:cNvPr id="28" name="Ellipse 27">
+              <a:extLst>
+                <a:ext uri="{FF2B5EF4-FFF2-40B4-BE49-F238E27FC236}">
+                  <a16:creationId xmlns:a16="http://schemas.microsoft.com/office/drawing/2014/main" id="{037D0FC4-D975-31B5-EDA9-B59750B00659}"/>
+                </a:ext>
+              </a:extLst>
+            </p:cNvPr>
+            <p:cNvSpPr/>
+            <p:nvPr/>
+          </p:nvSpPr>
+          <p:spPr>
+            <a:xfrm>
+              <a:off x="883956" y="1133256"/>
+              <a:ext cx="93597" cy="99277"/>
+            </a:xfrm>
+            <a:prstGeom prst="ellipse">
+              <a:avLst/>
+            </a:prstGeom>
+            <a:solidFill>
+              <a:schemeClr val="accent5">
+                <a:lumMod val="60000"/>
+                <a:lumOff val="40000"/>
+              </a:schemeClr>
+            </a:solidFill>
+            <a:ln>
+              <a:solidFill>
+                <a:schemeClr val="accent5">
+                  <a:lumMod val="60000"/>
+                  <a:lumOff val="40000"/>
+                </a:schemeClr>
+              </a:solidFill>
+            </a:ln>
+          </p:spPr>
+          <p:style>
+            <a:lnRef idx="2">
+              <a:schemeClr val="accent1">
+                <a:shade val="15000"/>
+              </a:schemeClr>
+            </a:lnRef>
+            <a:fillRef idx="1">
+              <a:schemeClr val="accent1"/>
+            </a:fillRef>
+            <a:effectRef idx="0">
+              <a:schemeClr val="accent1"/>
+            </a:effectRef>
+            <a:fontRef idx="minor">
+              <a:schemeClr val="lt1"/>
+            </a:fontRef>
+          </p:style>
+          <p:txBody>
+            <a:bodyPr rtlCol="0" anchor="ctr"/>
+            <a:lstStyle/>
+            <a:p>
+              <a:pPr algn="ctr"/>
+              <a:endParaRPr lang="fr-FR"/>
+            </a:p>
+          </p:txBody>
+        </p:sp>
+        <p:sp>
+          <p:nvSpPr>
+            <p:cNvPr id="29" name="ZoneTexte 28">
+              <a:extLst>
+                <a:ext uri="{FF2B5EF4-FFF2-40B4-BE49-F238E27FC236}">
+                  <a16:creationId xmlns:a16="http://schemas.microsoft.com/office/drawing/2014/main" id="{0BD6F182-21BD-102D-AA6C-1C5C71E53BF8}"/>
+                </a:ext>
+              </a:extLst>
+            </p:cNvPr>
+            <p:cNvSpPr txBox="1"/>
+            <p:nvPr/>
+          </p:nvSpPr>
+          <p:spPr>
+            <a:xfrm>
+              <a:off x="623315" y="671838"/>
+              <a:ext cx="450764" cy="369332"/>
+            </a:xfrm>
+            <a:prstGeom prst="rect">
+              <a:avLst/>
+            </a:prstGeom>
+            <a:noFill/>
+          </p:spPr>
+          <p:txBody>
+            <a:bodyPr wrap="none" rtlCol="0">
+              <a:spAutoFit/>
+            </a:bodyPr>
+            <a:lstStyle/>
+            <a:p>
+              <a:r>
+                <a:rPr lang="fr-FR" dirty="0" err="1"/>
+                <a:t>xH</a:t>
+              </a:r>
+              <a:endParaRPr lang="fr-FR" dirty="0"/>
+            </a:p>
+          </p:txBody>
+        </p:sp>
+        <p:sp>
+          <p:nvSpPr>
+            <p:cNvPr id="34" name="ZoneTexte 33">
+              <a:extLst>
+                <a:ext uri="{FF2B5EF4-FFF2-40B4-BE49-F238E27FC236}">
+                  <a16:creationId xmlns:a16="http://schemas.microsoft.com/office/drawing/2014/main" id="{40796FEB-385C-0970-A44C-02DB51F3C09C}"/>
+                </a:ext>
+              </a:extLst>
+            </p:cNvPr>
+            <p:cNvSpPr txBox="1"/>
+            <p:nvPr/>
+          </p:nvSpPr>
+          <p:spPr>
+            <a:xfrm>
+              <a:off x="3567277" y="759717"/>
+              <a:ext cx="678391" cy="369332"/>
+            </a:xfrm>
+            <a:prstGeom prst="rect">
+              <a:avLst/>
+            </a:prstGeom>
+            <a:noFill/>
+          </p:spPr>
+          <p:txBody>
+            <a:bodyPr wrap="none" rtlCol="0">
+              <a:spAutoFit/>
+            </a:bodyPr>
+            <a:lstStyle/>
+            <a:p>
+              <a:r>
+                <a:rPr lang="fr-FR" dirty="0"/>
+                <a:t>(0, 0)</a:t>
+              </a:r>
+            </a:p>
+          </p:txBody>
+        </p:sp>
+      </p:grpSp>
+      <mc:AlternateContent xmlns:mc="http://schemas.openxmlformats.org/markup-compatibility/2006">
+        <mc:Choice xmlns:a14="http://schemas.microsoft.com/office/drawing/2010/main" Requires="a14">
+          <p:sp>
+            <p:nvSpPr>
+              <p:cNvPr id="6" name="ZoneTexte 5">
+                <a:extLst>
+                  <a:ext uri="{FF2B5EF4-FFF2-40B4-BE49-F238E27FC236}">
+                    <a16:creationId xmlns:a16="http://schemas.microsoft.com/office/drawing/2014/main" id="{95C93AA5-2CC1-F794-F3D1-256E6B6AEC83}"/>
+                  </a:ext>
+                </a:extLst>
+              </p:cNvPr>
+              <p:cNvSpPr txBox="1"/>
+              <p:nvPr/>
+            </p:nvSpPr>
+            <p:spPr>
+              <a:xfrm>
+                <a:off x="7083058" y="1764500"/>
+                <a:ext cx="2425600" cy="566694"/>
+              </a:xfrm>
+              <a:prstGeom prst="rect">
+                <a:avLst/>
+              </a:prstGeom>
+              <a:noFill/>
+            </p:spPr>
+            <p:txBody>
+              <a:bodyPr wrap="none" rtlCol="0">
+                <a:spAutoFit/>
+              </a:bodyPr>
+              <a:lstStyle/>
+              <a:p>
+                <a14:m>
+                  <m:oMathPara xmlns:m="http://schemas.openxmlformats.org/officeDocument/2006/math">
+                    <m:oMathParaPr>
+                      <m:jc m:val="centerGroup"/>
+                    </m:oMathParaPr>
+                    <m:oMath xmlns:m="http://schemas.openxmlformats.org/officeDocument/2006/math">
+                      <m:r>
+                        <a:rPr lang="fr-FR" b="0" i="1" smtClean="0">
+                          <a:latin typeface="Cambria Math" panose="02040503050406030204" pitchFamily="18" charset="0"/>
+                        </a:rPr>
+                        <m:t>0=</m:t>
+                      </m:r>
+                      <m:sSub>
+                        <m:sSubPr>
+                          <m:ctrlPr>
+                            <a:rPr lang="fr-FR" b="0" i="1" smtClean="0">
+                              <a:latin typeface="Cambria Math" panose="02040503050406030204" pitchFamily="18" charset="0"/>
+                            </a:rPr>
+                          </m:ctrlPr>
+                        </m:sSubPr>
+                        <m:e>
+                          <m:r>
+                            <a:rPr lang="fr-FR" b="0" i="1" smtClean="0">
+                              <a:latin typeface="Cambria Math" panose="02040503050406030204" pitchFamily="18" charset="0"/>
+                            </a:rPr>
+                            <m:t>𝑦</m:t>
+                          </m:r>
+                        </m:e>
+                        <m:sub>
+                          <m:r>
+                            <a:rPr lang="fr-FR" b="0" i="1" smtClean="0">
+                              <a:latin typeface="Cambria Math" panose="02040503050406030204" pitchFamily="18" charset="0"/>
+                            </a:rPr>
+                            <m:t>𝐻</m:t>
+                          </m:r>
+                        </m:sub>
+                      </m:sSub>
+                      <m:r>
+                        <a:rPr lang="fr-FR" b="0" i="1" smtClean="0">
+                          <a:latin typeface="Cambria Math" panose="02040503050406030204" pitchFamily="18" charset="0"/>
+                        </a:rPr>
+                        <m:t>+ </m:t>
+                      </m:r>
+                      <m:r>
+                        <a:rPr lang="fr-FR" b="0" i="1" smtClean="0">
+                          <a:latin typeface="Cambria Math" panose="02040503050406030204" pitchFamily="18" charset="0"/>
+                        </a:rPr>
+                        <m:t>𝑎</m:t>
+                      </m:r>
+                      <m:r>
+                        <a:rPr lang="fr-FR" b="0" i="1" smtClean="0">
+                          <a:latin typeface="Cambria Math" panose="02040503050406030204" pitchFamily="18" charset="0"/>
+                        </a:rPr>
+                        <m:t> </m:t>
+                      </m:r>
+                      <m:r>
+                        <a:rPr lang="fr-FR" b="0" i="1" smtClean="0">
+                          <a:latin typeface="Cambria Math" panose="02040503050406030204" pitchFamily="18" charset="0"/>
+                        </a:rPr>
+                        <m:t>𝑐h</m:t>
+                      </m:r>
+                      <m:d>
+                        <m:dPr>
+                          <m:ctrlPr>
+                            <a:rPr lang="fr-FR" b="0" i="1" smtClean="0">
+                              <a:latin typeface="Cambria Math" panose="02040503050406030204" pitchFamily="18" charset="0"/>
+                            </a:rPr>
+                          </m:ctrlPr>
+                        </m:dPr>
+                        <m:e>
+                          <m:f>
+                            <m:fPr>
+                              <m:ctrlPr>
+                                <a:rPr lang="fr-FR" b="0" i="1" smtClean="0">
+                                  <a:latin typeface="Cambria Math" panose="02040503050406030204" pitchFamily="18" charset="0"/>
+                                </a:rPr>
+                              </m:ctrlPr>
+                            </m:fPr>
+                            <m:num>
+                              <m:r>
+                                <a:rPr lang="fr-FR" b="0" i="1" smtClean="0">
+                                  <a:latin typeface="Cambria Math" panose="02040503050406030204" pitchFamily="18" charset="0"/>
+                                </a:rPr>
+                                <m:t>− </m:t>
+                              </m:r>
+                              <m:sSub>
+                                <m:sSubPr>
+                                  <m:ctrlPr>
+                                    <a:rPr lang="fr-FR" b="0" i="1" smtClean="0">
+                                      <a:latin typeface="Cambria Math" panose="02040503050406030204" pitchFamily="18" charset="0"/>
+                                    </a:rPr>
+                                  </m:ctrlPr>
+                                </m:sSubPr>
+                                <m:e>
+                                  <m:r>
+                                    <a:rPr lang="fr-FR" b="0" i="1" smtClean="0">
+                                      <a:latin typeface="Cambria Math" panose="02040503050406030204" pitchFamily="18" charset="0"/>
+                                    </a:rPr>
+                                    <m:t>𝑥</m:t>
+                                  </m:r>
+                                </m:e>
+                                <m:sub>
+                                  <m:r>
+                                    <a:rPr lang="fr-FR" b="0" i="1" smtClean="0">
+                                      <a:latin typeface="Cambria Math" panose="02040503050406030204" pitchFamily="18" charset="0"/>
+                                    </a:rPr>
+                                    <m:t>𝐻</m:t>
+                                  </m:r>
+                                </m:sub>
+                              </m:sSub>
+                            </m:num>
+                            <m:den>
+                              <m:r>
+                                <a:rPr lang="fr-FR" b="0" i="1" smtClean="0">
+                                  <a:latin typeface="Cambria Math" panose="02040503050406030204" pitchFamily="18" charset="0"/>
+                                </a:rPr>
+                                <m:t>𝑎</m:t>
+                              </m:r>
+                            </m:den>
+                          </m:f>
+                        </m:e>
+                      </m:d>
+                    </m:oMath>
+                  </m:oMathPara>
+                </a14:m>
+                <a:endParaRPr lang="fr-FR" dirty="0"/>
+              </a:p>
+            </p:txBody>
+          </p:sp>
+        </mc:Choice>
+        <mc:Fallback>
+          <p:sp>
+            <p:nvSpPr>
+              <p:cNvPr id="6" name="ZoneTexte 5">
+                <a:extLst>
+                  <a:ext uri="{FF2B5EF4-FFF2-40B4-BE49-F238E27FC236}">
+                    <a16:creationId xmlns:a16="http://schemas.microsoft.com/office/drawing/2014/main" id="{95C93AA5-2CC1-F794-F3D1-256E6B6AEC83}"/>
+                  </a:ext>
+                </a:extLst>
+              </p:cNvPr>
+              <p:cNvSpPr txBox="1">
+                <a:spLocks noRot="1" noChangeAspect="1" noMove="1" noResize="1" noEditPoints="1" noAdjustHandles="1" noChangeArrowheads="1" noChangeShapeType="1" noTextEdit="1"/>
+              </p:cNvSpPr>
+              <p:nvPr/>
+            </p:nvSpPr>
+            <p:spPr>
+              <a:xfrm>
+                <a:off x="7083058" y="1764500"/>
+                <a:ext cx="2425600" cy="566694"/>
+              </a:xfrm>
+              <a:prstGeom prst="rect">
+                <a:avLst/>
+              </a:prstGeom>
+              <a:blipFill>
+                <a:blip r:embed="rId5"/>
+                <a:stretch>
+                  <a:fillRect/>
+                </a:stretch>
+              </a:blipFill>
+            </p:spPr>
+            <p:txBody>
+              <a:bodyPr/>
+              <a:lstStyle/>
+              <a:p>
+                <a:r>
+                  <a:rPr lang="fr-FR">
+                    <a:noFill/>
+                  </a:rPr>
+                  <a:t> </a:t>
+                </a:r>
+              </a:p>
+            </p:txBody>
+          </p:sp>
+        </mc:Fallback>
+      </mc:AlternateContent>
+    </p:spTree>
+    <p:extLst>
+      <p:ext uri="{BB962C8B-B14F-4D97-AF65-F5344CB8AC3E}">
+        <p14:creationId xmlns:p14="http://schemas.microsoft.com/office/powerpoint/2010/main" val="3891265910"/>
+      </p:ext>
+    </p:extLst>
+  </p:cSld>
+  <p:clrMapOvr>
+    <a:masterClrMapping/>
+  </p:clrMapOvr>
+</p:sld>
+</file>
+
 <file path=ppt/theme/theme1.xml><?xml version="1.0" encoding="utf-8"?>
 <a:theme xmlns:a="http://schemas.openxmlformats.org/drawingml/2006/main" name="Thème Office">
   <a:themeElements>

</xml_diff>